<commit_message>
W2 Datalab 1 Work I
</commit_message>
<xml_diff>
--- a/Deliverables/Learning Log - Y1B-2024-25_ADSAI.pptx
+++ b/Deliverables/Learning Log - Y1B-2024-25_ADSAI.pptx
@@ -15323,10 +15323,9 @@
               <a:buChar char="●"/>
             </a:pPr>
             <a:r>
-              <a:rPr lang="en"/>
+              <a:rPr lang="en" b="1" dirty="0"/>
               <a:t>What goal(s) did you set for this week?</a:t>
             </a:r>
-            <a:endParaRPr/>
           </a:p>
           <a:p>
             <a:pPr marL="182880" lvl="0" indent="-154940" algn="l" rtl="0">
@@ -15340,10 +15339,10 @@
               <a:buChar char="●"/>
             </a:pPr>
             <a:r>
-              <a:rPr lang="en"/>
-              <a:t>What have you actually been able to do? </a:t>
-            </a:r>
-            <a:endParaRPr/>
+              <a:rPr lang="en" dirty="0"/>
+              <a:t>My goal for this week is to make sure I fill in the WorkLog correctly.</a:t>
+            </a:r>
+            <a:endParaRPr dirty="0"/>
           </a:p>
           <a:p>
             <a:pPr marL="182880" lvl="0" indent="-154940" algn="l" rtl="0">
@@ -15357,10 +15356,27 @@
               <a:buChar char="●"/>
             </a:pPr>
             <a:r>
-              <a:rPr lang="en"/>
+              <a:rPr lang="en" b="1" dirty="0"/>
+              <a:t>What have you actually been able to do? </a:t>
+            </a:r>
+            <a:endParaRPr b="1" dirty="0"/>
+          </a:p>
+          <a:p>
+            <a:pPr marL="182880" lvl="0" indent="-154940" algn="l" rtl="0">
+              <a:spcBef>
+                <a:spcPts val="0"/>
+              </a:spcBef>
+              <a:spcAft>
+                <a:spcPts val="0"/>
+              </a:spcAft>
+              <a:buSzPts val="1000"/>
+              <a:buChar char="●"/>
+            </a:pPr>
+            <a:r>
+              <a:rPr lang="en" b="1" dirty="0"/>
               <a:t>Showcase the evidence of your progress (production artifacts, short descriptions-links-pictures animated gifs, etc.)</a:t>
             </a:r>
-            <a:endParaRPr/>
+            <a:endParaRPr b="1" dirty="0"/>
           </a:p>
         </p:txBody>
       </p:sp>
@@ -15400,10 +15416,10 @@
               <a:buChar char="●"/>
             </a:pPr>
             <a:r>
-              <a:rPr lang="en"/>
+              <a:rPr lang="en" b="1" dirty="0"/>
               <a:t>How did the week go? </a:t>
             </a:r>
-            <a:endParaRPr/>
+            <a:endParaRPr b="1" dirty="0"/>
           </a:p>
           <a:p>
             <a:pPr marL="182880" lvl="0" indent="-154940" algn="l" rtl="0">
@@ -15417,10 +15433,10 @@
               <a:buChar char="●"/>
             </a:pPr>
             <a:r>
-              <a:rPr lang="en"/>
+              <a:rPr lang="en" b="1" dirty="0"/>
               <a:t>What went well? </a:t>
             </a:r>
-            <a:endParaRPr/>
+            <a:endParaRPr b="1" dirty="0"/>
           </a:p>
           <a:p>
             <a:pPr marL="182880" lvl="0" indent="-154940" algn="l" rtl="0">
@@ -15434,10 +15450,10 @@
               <a:buChar char="●"/>
             </a:pPr>
             <a:r>
-              <a:rPr lang="en"/>
+              <a:rPr lang="en" b="1" dirty="0"/>
               <a:t>What didn’t go so well? </a:t>
             </a:r>
-            <a:endParaRPr/>
+            <a:endParaRPr b="1" dirty="0"/>
           </a:p>
           <a:p>
             <a:pPr marL="182880" lvl="0" indent="-154940" algn="l" rtl="0">
@@ -15451,10 +15467,10 @@
               <a:buChar char="●"/>
             </a:pPr>
             <a:r>
-              <a:rPr lang="en"/>
+              <a:rPr lang="en" b="1" dirty="0"/>
               <a:t>What did you learn? </a:t>
             </a:r>
-            <a:endParaRPr/>
+            <a:endParaRPr b="1" dirty="0"/>
           </a:p>
           <a:p>
             <a:pPr marL="182880" lvl="0" indent="-154940" algn="l" rtl="0">
@@ -15468,10 +15484,10 @@
               <a:buChar char="●"/>
             </a:pPr>
             <a:r>
-              <a:rPr lang="en"/>
+              <a:rPr lang="en" b="1" dirty="0"/>
               <a:t>What could be added as an Action point looking forward to next week?</a:t>
             </a:r>
-            <a:endParaRPr/>
+            <a:endParaRPr b="1" dirty="0"/>
           </a:p>
         </p:txBody>
       </p:sp>
@@ -40062,7 +40078,23 @@
               <a:rPr lang="en" b="1" dirty="0"/>
               <a:t>What have you actually been able to do? </a:t>
             </a:r>
-            <a:endParaRPr b="1" dirty="0"/>
+          </a:p>
+          <a:p>
+            <a:pPr marL="182880" lvl="0" indent="-154940" algn="l" rtl="0">
+              <a:spcBef>
+                <a:spcPts val="0"/>
+              </a:spcBef>
+              <a:spcAft>
+                <a:spcPts val="0"/>
+              </a:spcAft>
+              <a:buSzPts val="1000"/>
+              <a:buChar char="●"/>
+            </a:pPr>
+            <a:r>
+              <a:rPr lang="en" dirty="0"/>
+              <a:t>I have found my footing for the first week so far.</a:t>
+            </a:r>
+            <a:endParaRPr dirty="0"/>
           </a:p>
           <a:p>
             <a:pPr marL="182880" lvl="0" indent="-154940" algn="l" rtl="0">
@@ -40120,9 +40152,8 @@
             </a:pPr>
             <a:r>
               <a:rPr lang="en" b="1" dirty="0"/>
-              <a:t>How did the week go? </a:t>
-            </a:r>
-            <a:endParaRPr b="1" dirty="0"/>
+              <a:t>How did the week go?</a:t>
+            </a:r>
           </a:p>
           <a:p>
             <a:pPr marL="182880" lvl="0" indent="-154940" algn="l" rtl="0">
@@ -40136,8 +40167,12 @@
               <a:buChar char="●"/>
             </a:pPr>
             <a:r>
+              <a:rPr lang="en" dirty="0"/>
+              <a:t>I had some problems with certain tasks, but in general did do quite a bit of work.</a:t>
+            </a:r>
+            <a:r>
               <a:rPr lang="en" b="1" dirty="0"/>
-              <a:t>What went well? </a:t>
+              <a:t> </a:t>
             </a:r>
             <a:endParaRPr b="1" dirty="0"/>
           </a:p>
@@ -40154,9 +40189,8 @@
             </a:pPr>
             <a:r>
               <a:rPr lang="en" b="1" dirty="0"/>
-              <a:t>What didn’t go so well? </a:t>
-            </a:r>
-            <a:endParaRPr b="1" dirty="0"/>
+              <a:t>What went well? </a:t>
+            </a:r>
           </a:p>
           <a:p>
             <a:pPr marL="182880" lvl="0" indent="-154940" algn="l" rtl="0">
@@ -40170,10 +40204,10 @@
               <a:buChar char="●"/>
             </a:pPr>
             <a:r>
-              <a:rPr lang="en" b="1" dirty="0"/>
-              <a:t>What did you learn? </a:t>
-            </a:r>
-            <a:endParaRPr b="1" dirty="0"/>
+              <a:rPr lang="en-GB" dirty="0"/>
+              <a:t>Finding solutions to unexpected problems.</a:t>
+            </a:r>
+            <a:endParaRPr dirty="0"/>
           </a:p>
           <a:p>
             <a:pPr marL="182880" lvl="0" indent="-154940" algn="l" rtl="0">
@@ -40188,9 +40222,75 @@
             </a:pPr>
             <a:r>
               <a:rPr lang="en" b="1" dirty="0"/>
+              <a:t>What didn’t go so well? </a:t>
+            </a:r>
+          </a:p>
+          <a:p>
+            <a:pPr marL="182880" lvl="0" indent="-154940" algn="l" rtl="0">
+              <a:spcBef>
+                <a:spcPts val="0"/>
+              </a:spcBef>
+              <a:spcAft>
+                <a:spcPts val="0"/>
+              </a:spcAft>
+              <a:buSzPts val="1000"/>
+              <a:buChar char="●"/>
+            </a:pPr>
+            <a:r>
+              <a:rPr lang="en" dirty="0"/>
+              <a:t>Filling in the WorkLog (especially towards the end of the week)</a:t>
+            </a:r>
+            <a:endParaRPr dirty="0"/>
+          </a:p>
+          <a:p>
+            <a:pPr marL="182880" lvl="0" indent="-154940" algn="l" rtl="0">
+              <a:spcBef>
+                <a:spcPts val="0"/>
+              </a:spcBef>
+              <a:spcAft>
+                <a:spcPts val="0"/>
+              </a:spcAft>
+              <a:buSzPts val="1000"/>
+              <a:buChar char="●"/>
+            </a:pPr>
+            <a:r>
+              <a:rPr lang="en" b="1" dirty="0"/>
+              <a:t>What did you learn? </a:t>
+            </a:r>
+            <a:endParaRPr b="1" dirty="0"/>
+          </a:p>
+          <a:p>
+            <a:pPr marL="182880" lvl="0" indent="-154940" algn="l" rtl="0">
+              <a:spcBef>
+                <a:spcPts val="0"/>
+              </a:spcBef>
+              <a:spcAft>
+                <a:spcPts val="0"/>
+              </a:spcAft>
+              <a:buSzPts val="1000"/>
+              <a:buChar char="●"/>
+            </a:pPr>
+            <a:r>
+              <a:rPr lang="en" b="1" dirty="0"/>
               <a:t>What could be added as an Action point looking forward to next week?</a:t>
             </a:r>
-            <a:endParaRPr b="1" dirty="0"/>
+          </a:p>
+          <a:p>
+            <a:pPr marL="182880" lvl="0" indent="-154940" algn="l" rtl="0">
+              <a:spcBef>
+                <a:spcPts val="0"/>
+              </a:spcBef>
+              <a:spcAft>
+                <a:spcPts val="0"/>
+              </a:spcAft>
+              <a:buSzPts val="1000"/>
+              <a:buChar char="●"/>
+            </a:pPr>
+            <a:r>
+              <a:rPr lang="en" dirty="0"/>
+              <a:t>The WorkLog needs to be filled in correctly.</a:t>
+            </a:r>
+            <a:endParaRPr dirty="0"/>
           </a:p>
         </p:txBody>
       </p:sp>
@@ -40893,15 +40993,6 @@
 </file>
 
 <file path=customXml/item1.xml><?xml version="1.0" encoding="utf-8"?>
-<?mso-contentType ?>
-<FormTemplates xmlns="http://schemas.microsoft.com/sharepoint/v3/contenttype/forms">
-  <Display>DocumentLibraryForm</Display>
-  <Edit>DocumentLibraryForm</Edit>
-  <New>DocumentLibraryForm</New>
-</FormTemplates>
-</file>
-
-<file path=customXml/item2.xml><?xml version="1.0" encoding="utf-8"?>
 <ct:contentTypeSchema xmlns:ct="http://schemas.microsoft.com/office/2006/metadata/contentType" xmlns:ma="http://schemas.microsoft.com/office/2006/metadata/properties/metaAttributes" ct:_="" ma:_="" ma:contentTypeName="Document" ma:contentTypeID="0x0101000BADAD4AA324BF48804EF76FD903323C" ma:contentTypeVersion="15" ma:contentTypeDescription="Create a new document." ma:contentTypeScope="" ma:versionID="4ea0feda506421460444ca95554a0aab">
   <xsd:schema xmlns:xsd="http://www.w3.org/2001/XMLSchema" xmlns:xs="http://www.w3.org/2001/XMLSchema" xmlns:p="http://schemas.microsoft.com/office/2006/metadata/properties" xmlns:ns2="5ff92c65-ed86-4457-baee-ccd535c9ea21" xmlns:ns3="6c8d291c-a5bf-4049-930d-38db8e991d8e" targetNamespace="http://schemas.microsoft.com/office/2006/metadata/properties" ma:root="true" ma:fieldsID="0fc8cf7d0f5ee312899395875a30595e" ns2:_="" ns3:_="">
     <xsd:import namespace="5ff92c65-ed86-4457-baee-ccd535c9ea21"/>
@@ -41136,7 +41227,7 @@
 </ct:contentTypeSchema>
 </file>
 
-<file path=customXml/item3.xml><?xml version="1.0" encoding="utf-8"?>
+<file path=customXml/item2.xml><?xml version="1.0" encoding="utf-8"?>
 <p:properties xmlns:p="http://schemas.microsoft.com/office/2006/metadata/properties" xmlns:xsi="http://www.w3.org/2001/XMLSchema-instance" xmlns:pc="http://schemas.microsoft.com/office/infopath/2007/PartnerControls">
   <documentManagement>
     <SharedWithUsers xmlns="6c8d291c-a5bf-4049-930d-38db8e991d8e">
@@ -41154,15 +41245,16 @@
 </p:properties>
 </file>
 
-<file path=customXml/itemProps1.xml><?xml version="1.0" encoding="utf-8"?>
-<ds:datastoreItem xmlns:ds="http://schemas.openxmlformats.org/officeDocument/2006/customXml" ds:itemID="{98D9791E-52D0-4ABB-925A-4EAECF798D9B}">
-  <ds:schemaRefs>
-    <ds:schemaRef ds:uri="http://schemas.microsoft.com/sharepoint/v3/contenttype/forms"/>
-  </ds:schemaRefs>
-</ds:datastoreItem>
+<file path=customXml/item3.xml><?xml version="1.0" encoding="utf-8"?>
+<?mso-contentType ?>
+<FormTemplates xmlns="http://schemas.microsoft.com/sharepoint/v3/contenttype/forms">
+  <Display>DocumentLibraryForm</Display>
+  <Edit>DocumentLibraryForm</Edit>
+  <New>DocumentLibraryForm</New>
+</FormTemplates>
 </file>
 
-<file path=customXml/itemProps2.xml><?xml version="1.0" encoding="utf-8"?>
+<file path=customXml/itemProps1.xml><?xml version="1.0" encoding="utf-8"?>
 <ds:datastoreItem xmlns:ds="http://schemas.openxmlformats.org/officeDocument/2006/customXml" ds:itemID="{AA562638-1947-4789-9FBF-F833DB2C18A8}">
   <ds:schemaRefs>
     <ds:schemaRef ds:uri="5ff92c65-ed86-4457-baee-ccd535c9ea21"/>
@@ -41181,7 +41273,7 @@
 </ds:datastoreItem>
 </file>
 
-<file path=customXml/itemProps3.xml><?xml version="1.0" encoding="utf-8"?>
+<file path=customXml/itemProps2.xml><?xml version="1.0" encoding="utf-8"?>
 <ds:datastoreItem xmlns:ds="http://schemas.openxmlformats.org/officeDocument/2006/customXml" ds:itemID="{3067B86F-F5BB-4BE6-9A37-0E19E53CB68B}">
   <ds:schemaRefs>
     <ds:schemaRef ds:uri="5ff92c65-ed86-4457-baee-ccd535c9ea21"/>
@@ -41196,4 +41288,12 @@
     <ds:schemaRef ds:uri="http://www.w3.org/XML/1998/namespace"/>
   </ds:schemaRefs>
 </ds:datastoreItem>
+</file>
+
+<file path=customXml/itemProps3.xml><?xml version="1.0" encoding="utf-8"?>
+<ds:datastoreItem xmlns:ds="http://schemas.openxmlformats.org/officeDocument/2006/customXml" ds:itemID="{98D9791E-52D0-4ABB-925A-4EAECF798D9B}">
+  <ds:schemaRefs>
+    <ds:schemaRef ds:uri="http://schemas.microsoft.com/sharepoint/v3/contenttype/forms"/>
+  </ds:schemaRefs>
+</ds:datastoreItem>
 </file>
</xml_diff>

<commit_message>
W2 Datalab 2 Work I (Startup and pre-datalab work)
</commit_message>
<xml_diff>
--- a/Deliverables/Learning Log - Y1B-2024-25_ADSAI.pptx
+++ b/Deliverables/Learning Log - Y1B-2024-25_ADSAI.pptx
@@ -40993,6 +40993,15 @@
 </file>
 
 <file path=customXml/item1.xml><?xml version="1.0" encoding="utf-8"?>
+<?mso-contentType ?>
+<FormTemplates xmlns="http://schemas.microsoft.com/sharepoint/v3/contenttype/forms">
+  <Display>DocumentLibraryForm</Display>
+  <Edit>DocumentLibraryForm</Edit>
+  <New>DocumentLibraryForm</New>
+</FormTemplates>
+</file>
+
+<file path=customXml/item2.xml><?xml version="1.0" encoding="utf-8"?>
 <ct:contentTypeSchema xmlns:ct="http://schemas.microsoft.com/office/2006/metadata/contentType" xmlns:ma="http://schemas.microsoft.com/office/2006/metadata/properties/metaAttributes" ct:_="" ma:_="" ma:contentTypeName="Document" ma:contentTypeID="0x0101000BADAD4AA324BF48804EF76FD903323C" ma:contentTypeVersion="15" ma:contentTypeDescription="Create a new document." ma:contentTypeScope="" ma:versionID="4ea0feda506421460444ca95554a0aab">
   <xsd:schema xmlns:xsd="http://www.w3.org/2001/XMLSchema" xmlns:xs="http://www.w3.org/2001/XMLSchema" xmlns:p="http://schemas.microsoft.com/office/2006/metadata/properties" xmlns:ns2="5ff92c65-ed86-4457-baee-ccd535c9ea21" xmlns:ns3="6c8d291c-a5bf-4049-930d-38db8e991d8e" targetNamespace="http://schemas.microsoft.com/office/2006/metadata/properties" ma:root="true" ma:fieldsID="0fc8cf7d0f5ee312899395875a30595e" ns2:_="" ns3:_="">
     <xsd:import namespace="5ff92c65-ed86-4457-baee-ccd535c9ea21"/>
@@ -41227,7 +41236,7 @@
 </ct:contentTypeSchema>
 </file>
 
-<file path=customXml/item2.xml><?xml version="1.0" encoding="utf-8"?>
+<file path=customXml/item3.xml><?xml version="1.0" encoding="utf-8"?>
 <p:properties xmlns:p="http://schemas.microsoft.com/office/2006/metadata/properties" xmlns:xsi="http://www.w3.org/2001/XMLSchema-instance" xmlns:pc="http://schemas.microsoft.com/office/infopath/2007/PartnerControls">
   <documentManagement>
     <SharedWithUsers xmlns="6c8d291c-a5bf-4049-930d-38db8e991d8e">
@@ -41245,16 +41254,15 @@
 </p:properties>
 </file>
 
-<file path=customXml/item3.xml><?xml version="1.0" encoding="utf-8"?>
-<?mso-contentType ?>
-<FormTemplates xmlns="http://schemas.microsoft.com/sharepoint/v3/contenttype/forms">
-  <Display>DocumentLibraryForm</Display>
-  <Edit>DocumentLibraryForm</Edit>
-  <New>DocumentLibraryForm</New>
-</FormTemplates>
+<file path=customXml/itemProps1.xml><?xml version="1.0" encoding="utf-8"?>
+<ds:datastoreItem xmlns:ds="http://schemas.openxmlformats.org/officeDocument/2006/customXml" ds:itemID="{98D9791E-52D0-4ABB-925A-4EAECF798D9B}">
+  <ds:schemaRefs>
+    <ds:schemaRef ds:uri="http://schemas.microsoft.com/sharepoint/v3/contenttype/forms"/>
+  </ds:schemaRefs>
+</ds:datastoreItem>
 </file>
 
-<file path=customXml/itemProps1.xml><?xml version="1.0" encoding="utf-8"?>
+<file path=customXml/itemProps2.xml><?xml version="1.0" encoding="utf-8"?>
 <ds:datastoreItem xmlns:ds="http://schemas.openxmlformats.org/officeDocument/2006/customXml" ds:itemID="{AA562638-1947-4789-9FBF-F833DB2C18A8}">
   <ds:schemaRefs>
     <ds:schemaRef ds:uri="5ff92c65-ed86-4457-baee-ccd535c9ea21"/>
@@ -41273,7 +41281,7 @@
 </ds:datastoreItem>
 </file>
 
-<file path=customXml/itemProps2.xml><?xml version="1.0" encoding="utf-8"?>
+<file path=customXml/itemProps3.xml><?xml version="1.0" encoding="utf-8"?>
 <ds:datastoreItem xmlns:ds="http://schemas.openxmlformats.org/officeDocument/2006/customXml" ds:itemID="{3067B86F-F5BB-4BE6-9A37-0E19E53CB68B}">
   <ds:schemaRefs>
     <ds:schemaRef ds:uri="5ff92c65-ed86-4457-baee-ccd535c9ea21"/>
@@ -41288,12 +41296,4 @@
     <ds:schemaRef ds:uri="http://www.w3.org/XML/1998/namespace"/>
   </ds:schemaRefs>
 </ds:datastoreItem>
-</file>
-
-<file path=customXml/itemProps3.xml><?xml version="1.0" encoding="utf-8"?>
-<ds:datastoreItem xmlns:ds="http://schemas.openxmlformats.org/officeDocument/2006/customXml" ds:itemID="{98D9791E-52D0-4ABB-925A-4EAECF798D9B}">
-  <ds:schemaRefs>
-    <ds:schemaRef ds:uri="http://schemas.microsoft.com/sharepoint/v3/contenttype/forms"/>
-  </ds:schemaRefs>
-</ds:datastoreItem>
 </file>
</xml_diff>

<commit_message>
W2 Datalab 2 Work II (Post-datalab)
</commit_message>
<xml_diff>
--- a/Deliverables/Learning Log - Y1B-2024-25_ADSAI.pptx
+++ b/Deliverables/Learning Log - Y1B-2024-25_ADSAI.pptx
@@ -37818,10 +37818,10 @@
               <a:buNone/>
             </a:pPr>
             <a:r>
-              <a:rPr lang="en"/>
+              <a:rPr lang="en" dirty="0"/>
               <a:t>What I learned last block -													     Previous block’s grade</a:t>
             </a:r>
-            <a:endParaRPr/>
+            <a:endParaRPr dirty="0"/>
           </a:p>
         </p:txBody>
       </p:sp>
@@ -37860,8 +37860,8 @@
               <a:buNone/>
             </a:pPr>
             <a:r>
-              <a:rPr lang="en" dirty="0"/>
-              <a:t>...</a:t>
+              <a:rPr lang="pl-PL" dirty="0"/>
+              <a:t>Last block I learned the foundations of Data Science. I also learned the foundations of math and Python skills required for the study. I was also taught how to use and create reports and dashboard in PowerBI.</a:t>
             </a:r>
             <a:endParaRPr dirty="0"/>
           </a:p>
@@ -40092,7 +40092,11 @@
             </a:pPr>
             <a:r>
               <a:rPr lang="en" dirty="0"/>
-              <a:t>I have found my footing for the first week so far.</a:t>
+              <a:t>I have found my footing for the first week so far</a:t>
+            </a:r>
+            <a:r>
+              <a:rPr lang="pl-PL" dirty="0"/>
+              <a:t> and have followed the lessons.</a:t>
             </a:r>
             <a:endParaRPr dirty="0"/>
           </a:p>
@@ -40205,7 +40209,11 @@
             </a:pPr>
             <a:r>
               <a:rPr lang="en-GB" dirty="0"/>
-              <a:t>Finding solutions to unexpected problems.</a:t>
+              <a:t>Finding solutions to unexpected problems</a:t>
+            </a:r>
+            <a:r>
+              <a:rPr lang="pl-PL" dirty="0"/>
+              <a:t>, such as figuring out the password to Postgresql or downloading the „credit.csv” file</a:t>
             </a:r>
             <a:endParaRPr dirty="0"/>
           </a:p>
@@ -40238,7 +40246,27 @@
             </a:pPr>
             <a:r>
               <a:rPr lang="en" dirty="0"/>
-              <a:t>Filling in the WorkLog (especially towards the end of the week)</a:t>
+              <a:t>Filling in</a:t>
+            </a:r>
+            <a:r>
+              <a:rPr lang="pl-PL" dirty="0"/>
+              <a:t> and evidencing in</a:t>
+            </a:r>
+            <a:r>
+              <a:rPr lang="en" dirty="0"/>
+              <a:t> the WorkLog</a:t>
+            </a:r>
+            <a:r>
+              <a:rPr lang="pl-PL" dirty="0"/>
+              <a:t>, </a:t>
+            </a:r>
+            <a:r>
+              <a:rPr lang="en" dirty="0"/>
+              <a:t>especially towards the end of the week</a:t>
+            </a:r>
+            <a:r>
+              <a:rPr lang="pl-PL" dirty="0"/>
+              <a:t>.</a:t>
             </a:r>
             <a:endParaRPr dirty="0"/>
           </a:p>
@@ -40257,7 +40285,7 @@
               <a:rPr lang="en" b="1" dirty="0"/>
               <a:t>What did you learn? </a:t>
             </a:r>
-            <a:endParaRPr b="1" dirty="0"/>
+            <a:endParaRPr lang="pl-PL" b="1" dirty="0"/>
           </a:p>
           <a:p>
             <a:pPr marL="182880" lvl="0" indent="-154940" algn="l" rtl="0">
@@ -40271,9 +40299,10 @@
               <a:buChar char="●"/>
             </a:pPr>
             <a:r>
-              <a:rPr lang="en" b="1" dirty="0"/>
-              <a:t>What could be added as an Action point looking forward to next week?</a:t>
-            </a:r>
+              <a:rPr lang="pl-PL" dirty="0"/>
+              <a:t>I learned the basics of SQL and machine learning.</a:t>
+            </a:r>
+            <a:endParaRPr dirty="0"/>
           </a:p>
           <a:p>
             <a:pPr marL="182880" lvl="0" indent="-154940" algn="l" rtl="0">
@@ -40287,8 +40316,28 @@
               <a:buChar char="●"/>
             </a:pPr>
             <a:r>
+              <a:rPr lang="en" b="1" dirty="0"/>
+              <a:t>What could be added as an Action point looking forward to next week?</a:t>
+            </a:r>
+          </a:p>
+          <a:p>
+            <a:pPr marL="182880" lvl="0" indent="-154940" algn="l" rtl="0">
+              <a:spcBef>
+                <a:spcPts val="0"/>
+              </a:spcBef>
+              <a:spcAft>
+                <a:spcPts val="0"/>
+              </a:spcAft>
+              <a:buSzPts val="1000"/>
+              <a:buChar char="●"/>
+            </a:pPr>
+            <a:r>
               <a:rPr lang="en" dirty="0"/>
-              <a:t>The WorkLog needs to be filled in correctly.</a:t>
+              <a:t>The WorkLog needs to be filled in correctly</a:t>
+            </a:r>
+            <a:r>
+              <a:rPr lang="pl-PL" dirty="0"/>
+              <a:t> with regards to the tasks, evidence and reflection.</a:t>
             </a:r>
             <a:endParaRPr dirty="0"/>
           </a:p>
@@ -40993,15 +41042,6 @@
 </file>
 
 <file path=customXml/item1.xml><?xml version="1.0" encoding="utf-8"?>
-<?mso-contentType ?>
-<FormTemplates xmlns="http://schemas.microsoft.com/sharepoint/v3/contenttype/forms">
-  <Display>DocumentLibraryForm</Display>
-  <Edit>DocumentLibraryForm</Edit>
-  <New>DocumentLibraryForm</New>
-</FormTemplates>
-</file>
-
-<file path=customXml/item2.xml><?xml version="1.0" encoding="utf-8"?>
 <ct:contentTypeSchema xmlns:ct="http://schemas.microsoft.com/office/2006/metadata/contentType" xmlns:ma="http://schemas.microsoft.com/office/2006/metadata/properties/metaAttributes" ct:_="" ma:_="" ma:contentTypeName="Document" ma:contentTypeID="0x0101000BADAD4AA324BF48804EF76FD903323C" ma:contentTypeVersion="15" ma:contentTypeDescription="Create a new document." ma:contentTypeScope="" ma:versionID="4ea0feda506421460444ca95554a0aab">
   <xsd:schema xmlns:xsd="http://www.w3.org/2001/XMLSchema" xmlns:xs="http://www.w3.org/2001/XMLSchema" xmlns:p="http://schemas.microsoft.com/office/2006/metadata/properties" xmlns:ns2="5ff92c65-ed86-4457-baee-ccd535c9ea21" xmlns:ns3="6c8d291c-a5bf-4049-930d-38db8e991d8e" targetNamespace="http://schemas.microsoft.com/office/2006/metadata/properties" ma:root="true" ma:fieldsID="0fc8cf7d0f5ee312899395875a30595e" ns2:_="" ns3:_="">
     <xsd:import namespace="5ff92c65-ed86-4457-baee-ccd535c9ea21"/>
@@ -41236,7 +41276,7 @@
 </ct:contentTypeSchema>
 </file>
 
-<file path=customXml/item3.xml><?xml version="1.0" encoding="utf-8"?>
+<file path=customXml/item2.xml><?xml version="1.0" encoding="utf-8"?>
 <p:properties xmlns:p="http://schemas.microsoft.com/office/2006/metadata/properties" xmlns:xsi="http://www.w3.org/2001/XMLSchema-instance" xmlns:pc="http://schemas.microsoft.com/office/infopath/2007/PartnerControls">
   <documentManagement>
     <SharedWithUsers xmlns="6c8d291c-a5bf-4049-930d-38db8e991d8e">
@@ -41254,15 +41294,16 @@
 </p:properties>
 </file>
 
-<file path=customXml/itemProps1.xml><?xml version="1.0" encoding="utf-8"?>
-<ds:datastoreItem xmlns:ds="http://schemas.openxmlformats.org/officeDocument/2006/customXml" ds:itemID="{98D9791E-52D0-4ABB-925A-4EAECF798D9B}">
-  <ds:schemaRefs>
-    <ds:schemaRef ds:uri="http://schemas.microsoft.com/sharepoint/v3/contenttype/forms"/>
-  </ds:schemaRefs>
-</ds:datastoreItem>
+<file path=customXml/item3.xml><?xml version="1.0" encoding="utf-8"?>
+<?mso-contentType ?>
+<FormTemplates xmlns="http://schemas.microsoft.com/sharepoint/v3/contenttype/forms">
+  <Display>DocumentLibraryForm</Display>
+  <Edit>DocumentLibraryForm</Edit>
+  <New>DocumentLibraryForm</New>
+</FormTemplates>
 </file>
 
-<file path=customXml/itemProps2.xml><?xml version="1.0" encoding="utf-8"?>
+<file path=customXml/itemProps1.xml><?xml version="1.0" encoding="utf-8"?>
 <ds:datastoreItem xmlns:ds="http://schemas.openxmlformats.org/officeDocument/2006/customXml" ds:itemID="{AA562638-1947-4789-9FBF-F833DB2C18A8}">
   <ds:schemaRefs>
     <ds:schemaRef ds:uri="5ff92c65-ed86-4457-baee-ccd535c9ea21"/>
@@ -41281,7 +41322,7 @@
 </ds:datastoreItem>
 </file>
 
-<file path=customXml/itemProps3.xml><?xml version="1.0" encoding="utf-8"?>
+<file path=customXml/itemProps2.xml><?xml version="1.0" encoding="utf-8"?>
 <ds:datastoreItem xmlns:ds="http://schemas.openxmlformats.org/officeDocument/2006/customXml" ds:itemID="{3067B86F-F5BB-4BE6-9A37-0E19E53CB68B}">
   <ds:schemaRefs>
     <ds:schemaRef ds:uri="5ff92c65-ed86-4457-baee-ccd535c9ea21"/>
@@ -41296,4 +41337,12 @@
     <ds:schemaRef ds:uri="http://www.w3.org/XML/1998/namespace"/>
   </ds:schemaRefs>
 </ds:datastoreItem>
+</file>
+
+<file path=customXml/itemProps3.xml><?xml version="1.0" encoding="utf-8"?>
+<ds:datastoreItem xmlns:ds="http://schemas.openxmlformats.org/officeDocument/2006/customXml" ds:itemID="{98D9791E-52D0-4ABB-925A-4EAECF798D9B}">
+  <ds:schemaRefs>
+    <ds:schemaRef ds:uri="http://schemas.microsoft.com/sharepoint/v3/contenttype/forms"/>
+  </ds:schemaRefs>
+</ds:datastoreItem>
 </file>
</xml_diff>

<commit_message>
Week 2 finish and week 3 start.
</commit_message>
<xml_diff>
--- a/Deliverables/Learning Log - Y1B-2024-25_ADSAI.pptx
+++ b/Deliverables/Learning Log - Y1B-2024-25_ADSAI.pptx
@@ -15359,7 +15359,24 @@
               <a:rPr lang="en" b="1" dirty="0"/>
               <a:t>What have you actually been able to do? </a:t>
             </a:r>
-            <a:endParaRPr b="1" dirty="0"/>
+            <a:endParaRPr lang="pl-PL" b="1" dirty="0"/>
+          </a:p>
+          <a:p>
+            <a:pPr marL="182880" lvl="0" indent="-154940" algn="l" rtl="0">
+              <a:spcBef>
+                <a:spcPts val="0"/>
+              </a:spcBef>
+              <a:spcAft>
+                <a:spcPts val="0"/>
+              </a:spcAft>
+              <a:buSzPts val="1000"/>
+              <a:buChar char="●"/>
+            </a:pPr>
+            <a:r>
+              <a:rPr lang="pl-PL" dirty="0"/>
+              <a:t>I have filled in my Worklog better this week except for Friday where I forgot to fill it in after I returned home.</a:t>
+            </a:r>
+            <a:endParaRPr dirty="0"/>
           </a:p>
           <a:p>
             <a:pPr marL="182880" lvl="0" indent="-154940" algn="l" rtl="0">
@@ -15419,7 +15436,7 @@
               <a:rPr lang="en" b="1" dirty="0"/>
               <a:t>How did the week go? </a:t>
             </a:r>
-            <a:endParaRPr b="1" dirty="0"/>
+            <a:endParaRPr lang="pl-PL" b="1" dirty="0"/>
           </a:p>
           <a:p>
             <a:pPr marL="182880" lvl="0" indent="-154940" algn="l" rtl="0">
@@ -15433,10 +15450,27 @@
               <a:buChar char="●"/>
             </a:pPr>
             <a:r>
+              <a:rPr lang="pl-PL" dirty="0"/>
+              <a:t>There were ups and downs during this week but on average I would say it went quite well.</a:t>
+            </a:r>
+            <a:endParaRPr dirty="0"/>
+          </a:p>
+          <a:p>
+            <a:pPr marL="182880" lvl="0" indent="-154940" algn="l" rtl="0">
+              <a:spcBef>
+                <a:spcPts val="0"/>
+              </a:spcBef>
+              <a:spcAft>
+                <a:spcPts val="0"/>
+              </a:spcAft>
+              <a:buSzPts val="1000"/>
+              <a:buChar char="●"/>
+            </a:pPr>
+            <a:r>
               <a:rPr lang="en" b="1" dirty="0"/>
               <a:t>What went well? </a:t>
             </a:r>
-            <a:endParaRPr b="1" dirty="0"/>
+            <a:endParaRPr lang="pl-PL" b="1" dirty="0"/>
           </a:p>
           <a:p>
             <a:pPr marL="182880" lvl="0" indent="-154940" algn="l" rtl="0">
@@ -15450,10 +15484,27 @@
               <a:buChar char="●"/>
             </a:pPr>
             <a:r>
+              <a:rPr lang="pl-PL" dirty="0"/>
+              <a:t>Following the content.</a:t>
+            </a:r>
+            <a:endParaRPr dirty="0"/>
+          </a:p>
+          <a:p>
+            <a:pPr marL="182880" lvl="0" indent="-154940" algn="l" rtl="0">
+              <a:spcBef>
+                <a:spcPts val="0"/>
+              </a:spcBef>
+              <a:spcAft>
+                <a:spcPts val="0"/>
+              </a:spcAft>
+              <a:buSzPts val="1000"/>
+              <a:buChar char="●"/>
+            </a:pPr>
+            <a:r>
               <a:rPr lang="en" b="1" dirty="0"/>
               <a:t>What didn’t go so well? </a:t>
             </a:r>
-            <a:endParaRPr b="1" dirty="0"/>
+            <a:endParaRPr lang="pl-PL" b="1" dirty="0"/>
           </a:p>
           <a:p>
             <a:pPr marL="182880" lvl="0" indent="-154940" algn="l" rtl="0">
@@ -15467,10 +15518,27 @@
               <a:buChar char="●"/>
             </a:pPr>
             <a:r>
+              <a:rPr lang="pl-PL" dirty="0"/>
+              <a:t>Finishing up my work.</a:t>
+            </a:r>
+            <a:endParaRPr dirty="0"/>
+          </a:p>
+          <a:p>
+            <a:pPr marL="182880" lvl="0" indent="-154940" algn="l" rtl="0">
+              <a:spcBef>
+                <a:spcPts val="0"/>
+              </a:spcBef>
+              <a:spcAft>
+                <a:spcPts val="0"/>
+              </a:spcAft>
+              <a:buSzPts val="1000"/>
+              <a:buChar char="●"/>
+            </a:pPr>
+            <a:r>
               <a:rPr lang="en" b="1" dirty="0"/>
               <a:t>What did you learn? </a:t>
             </a:r>
-            <a:endParaRPr b="1" dirty="0"/>
+            <a:endParaRPr lang="pl-PL" b="1" dirty="0"/>
           </a:p>
           <a:p>
             <a:pPr marL="182880" lvl="0" indent="-154940" algn="l" rtl="0">
@@ -15484,10 +15552,44 @@
               <a:buChar char="●"/>
             </a:pPr>
             <a:r>
+              <a:rPr lang="pl-PL" dirty="0"/>
+              <a:t>I learned some new concepts in the field of machine learning and EDA concepts.</a:t>
+            </a:r>
+            <a:endParaRPr dirty="0"/>
+          </a:p>
+          <a:p>
+            <a:pPr marL="182880" lvl="0" indent="-154940" algn="l" rtl="0">
+              <a:spcBef>
+                <a:spcPts val="0"/>
+              </a:spcBef>
+              <a:spcAft>
+                <a:spcPts val="0"/>
+              </a:spcAft>
+              <a:buSzPts val="1000"/>
+              <a:buChar char="●"/>
+            </a:pPr>
+            <a:r>
               <a:rPr lang="en" b="1" dirty="0"/>
               <a:t>What could be added as an Action point looking forward to next week?</a:t>
             </a:r>
-            <a:endParaRPr b="1" dirty="0"/>
+            <a:endParaRPr lang="pl-PL" b="1" dirty="0"/>
+          </a:p>
+          <a:p>
+            <a:pPr marL="182880" lvl="0" indent="-154940" algn="l" rtl="0">
+              <a:spcBef>
+                <a:spcPts val="0"/>
+              </a:spcBef>
+              <a:spcAft>
+                <a:spcPts val="0"/>
+              </a:spcAft>
+              <a:buSzPts val="1000"/>
+              <a:buChar char="●"/>
+            </a:pPr>
+            <a:r>
+              <a:rPr lang="pl-PL" dirty="0"/>
+              <a:t>Finishing some of my planned tasks that I did not finish during this week and week 1.</a:t>
+            </a:r>
+            <a:endParaRPr dirty="0"/>
           </a:p>
         </p:txBody>
       </p:sp>
@@ -15772,14 +15874,14 @@
               <a:buChar char="●"/>
             </a:pPr>
             <a:r>
-              <a:rPr lang="en" b="1"/>
-              <a:t>[Reviewer]</a:t>
-            </a:r>
-            <a:r>
-              <a:rPr lang="en"/>
-              <a:t> Feedback</a:t>
-            </a:r>
-            <a:endParaRPr/>
+              <a:rPr lang="pl-PL" b="1" dirty="0"/>
+              <a:t>Mentor </a:t>
+            </a:r>
+            <a:r>
+              <a:rPr lang="pl-PL" dirty="0"/>
+              <a:t>I did a nice job of actually following the WorkLog but the evidencing needs to be done and what I wrote in the Learning Log needs to be a bit longer. I also went over what the SMARTER goals were due to me being a bit confused over them.</a:t>
+            </a:r>
+            <a:endParaRPr dirty="0"/>
           </a:p>
           <a:p>
             <a:pPr marL="0" lvl="0" indent="0" algn="l" rtl="0">
@@ -15792,10 +15894,14 @@
               <a:buNone/>
             </a:pPr>
             <a:r>
-              <a:rPr lang="en"/>
-              <a:t>Response</a:t>
-            </a:r>
-            <a:endParaRPr/>
+              <a:rPr lang="pl-PL" dirty="0"/>
+              <a:t>The WorkLog evidencing was obvious to me aswell. I also recieved the fedback about my texts in the Learning Log being too short last block, meaning it is something I need to be carefull about. </a:t>
+            </a:r>
+            <a:r>
+              <a:rPr lang="pl-PL"/>
+              <a:t>I am thankfull for the SMARTER goals explanation.</a:t>
+            </a:r>
+            <a:endParaRPr dirty="0"/>
           </a:p>
         </p:txBody>
       </p:sp>
@@ -16120,10 +16226,10 @@
               <a:buChar char="●"/>
             </a:pPr>
             <a:r>
-              <a:rPr lang="en"/>
+              <a:rPr lang="en" b="1" dirty="0"/>
               <a:t>What goal(s) did you set for this week?</a:t>
             </a:r>
-            <a:endParaRPr/>
+            <a:endParaRPr lang="pl-PL" b="1" dirty="0"/>
           </a:p>
           <a:p>
             <a:pPr marL="182880" lvl="0" indent="-154940" algn="l" rtl="0">
@@ -16137,10 +16243,10 @@
               <a:buChar char="●"/>
             </a:pPr>
             <a:r>
-              <a:rPr lang="en"/>
-              <a:t>What have you actually been able to do? </a:t>
-            </a:r>
-            <a:endParaRPr/>
+              <a:rPr lang="pl-PL"/>
+              <a:t>This week I need to catch up on work that I had planned in my WorkLog for the past 2 weeks that I did not finish.</a:t>
+            </a:r>
+            <a:endParaRPr dirty="0"/>
           </a:p>
           <a:p>
             <a:pPr marL="182880" lvl="0" indent="-154940" algn="l" rtl="0">
@@ -16154,10 +16260,53 @@
               <a:buChar char="●"/>
             </a:pPr>
             <a:r>
-              <a:rPr lang="en"/>
+              <a:rPr lang="en" b="1" dirty="0"/>
+              <a:t>What have you actually been able to do? </a:t>
+            </a:r>
+            <a:endParaRPr lang="pl-PL" b="1" dirty="0"/>
+          </a:p>
+          <a:p>
+            <a:pPr marL="182880" lvl="0" indent="-154940" algn="l" rtl="0">
+              <a:spcBef>
+                <a:spcPts val="0"/>
+              </a:spcBef>
+              <a:spcAft>
+                <a:spcPts val="0"/>
+              </a:spcAft>
+              <a:buSzPts val="1000"/>
+              <a:buChar char="●"/>
+            </a:pPr>
+            <a:endParaRPr dirty="0"/>
+          </a:p>
+          <a:p>
+            <a:pPr marL="182880" lvl="0" indent="-154940" algn="l" rtl="0">
+              <a:spcBef>
+                <a:spcPts val="0"/>
+              </a:spcBef>
+              <a:spcAft>
+                <a:spcPts val="0"/>
+              </a:spcAft>
+              <a:buSzPts val="1000"/>
+              <a:buChar char="●"/>
+            </a:pPr>
+            <a:r>
+              <a:rPr lang="en" b="1" dirty="0"/>
               <a:t>Showcase the evidence of your progress (production artifacts, short descriptions-links-pictures animated gifs, etc.)</a:t>
             </a:r>
-            <a:endParaRPr/>
+            <a:endParaRPr lang="pl-PL" b="1" dirty="0"/>
+          </a:p>
+          <a:p>
+            <a:pPr marL="182880" lvl="0" indent="-154940" algn="l" rtl="0">
+              <a:spcBef>
+                <a:spcPts val="0"/>
+              </a:spcBef>
+              <a:spcAft>
+                <a:spcPts val="0"/>
+              </a:spcAft>
+              <a:buSzPts val="1000"/>
+              <a:buChar char="●"/>
+            </a:pPr>
+            <a:endParaRPr dirty="0"/>
           </a:p>
         </p:txBody>
       </p:sp>
@@ -16197,10 +16346,14 @@
               <a:buChar char="●"/>
             </a:pPr>
             <a:r>
-              <a:rPr lang="en"/>
-              <a:t>How did the week go? </a:t>
-            </a:r>
-            <a:endParaRPr/>
+              <a:rPr lang="en" b="1" dirty="0"/>
+              <a:t>How did the week go</a:t>
+            </a:r>
+            <a:r>
+              <a:rPr lang="en" dirty="0"/>
+              <a:t>?</a:t>
+            </a:r>
+            <a:endParaRPr lang="pl-PL" dirty="0"/>
           </a:p>
           <a:p>
             <a:pPr marL="182880" lvl="0" indent="-154940" algn="l" rtl="0">
@@ -16214,10 +16367,10 @@
               <a:buChar char="●"/>
             </a:pPr>
             <a:r>
-              <a:rPr lang="en"/>
-              <a:t>What went well? </a:t>
-            </a:r>
-            <a:endParaRPr/>
+              <a:rPr lang="en" dirty="0"/>
+              <a:t> </a:t>
+            </a:r>
+            <a:endParaRPr dirty="0"/>
           </a:p>
           <a:p>
             <a:pPr marL="182880" lvl="0" indent="-154940" algn="l" rtl="0">
@@ -16231,10 +16384,10 @@
               <a:buChar char="●"/>
             </a:pPr>
             <a:r>
-              <a:rPr lang="en"/>
-              <a:t>What didn’t go so well? </a:t>
-            </a:r>
-            <a:endParaRPr/>
+              <a:rPr lang="en" b="1" dirty="0"/>
+              <a:t>What went well? </a:t>
+            </a:r>
+            <a:endParaRPr lang="pl-PL" b="1" dirty="0"/>
           </a:p>
           <a:p>
             <a:pPr marL="182880" lvl="0" indent="-154940" algn="l" rtl="0">
@@ -16247,11 +16400,7 @@
               <a:buSzPts val="1000"/>
               <a:buChar char="●"/>
             </a:pPr>
-            <a:r>
-              <a:rPr lang="en"/>
-              <a:t>What did you learn? </a:t>
-            </a:r>
-            <a:endParaRPr/>
+            <a:endParaRPr dirty="0"/>
           </a:p>
           <a:p>
             <a:pPr marL="182880" lvl="0" indent="-154940" algn="l" rtl="0">
@@ -16265,10 +16414,83 @@
               <a:buChar char="●"/>
             </a:pPr>
             <a:r>
-              <a:rPr lang="en"/>
+              <a:rPr lang="en" b="1" dirty="0"/>
+              <a:t>What didn’t go so well? </a:t>
+            </a:r>
+            <a:endParaRPr lang="pl-PL" b="1" dirty="0"/>
+          </a:p>
+          <a:p>
+            <a:pPr marL="182880" lvl="0" indent="-154940" algn="l" rtl="0">
+              <a:spcBef>
+                <a:spcPts val="0"/>
+              </a:spcBef>
+              <a:spcAft>
+                <a:spcPts val="0"/>
+              </a:spcAft>
+              <a:buSzPts val="1000"/>
+              <a:buChar char="●"/>
+            </a:pPr>
+            <a:endParaRPr dirty="0"/>
+          </a:p>
+          <a:p>
+            <a:pPr marL="182880" lvl="0" indent="-154940" algn="l" rtl="0">
+              <a:spcBef>
+                <a:spcPts val="0"/>
+              </a:spcBef>
+              <a:spcAft>
+                <a:spcPts val="0"/>
+              </a:spcAft>
+              <a:buSzPts val="1000"/>
+              <a:buChar char="●"/>
+            </a:pPr>
+            <a:r>
+              <a:rPr lang="en" b="1" dirty="0"/>
+              <a:t>What did you learn? </a:t>
+            </a:r>
+            <a:endParaRPr lang="pl-PL" b="1" dirty="0"/>
+          </a:p>
+          <a:p>
+            <a:pPr marL="182880" lvl="0" indent="-154940" algn="l" rtl="0">
+              <a:spcBef>
+                <a:spcPts val="0"/>
+              </a:spcBef>
+              <a:spcAft>
+                <a:spcPts val="0"/>
+              </a:spcAft>
+              <a:buSzPts val="1000"/>
+              <a:buChar char="●"/>
+            </a:pPr>
+            <a:endParaRPr dirty="0"/>
+          </a:p>
+          <a:p>
+            <a:pPr marL="182880" lvl="0" indent="-154940" algn="l" rtl="0">
+              <a:spcBef>
+                <a:spcPts val="0"/>
+              </a:spcBef>
+              <a:spcAft>
+                <a:spcPts val="0"/>
+              </a:spcAft>
+              <a:buSzPts val="1000"/>
+              <a:buChar char="●"/>
+            </a:pPr>
+            <a:r>
+              <a:rPr lang="en" b="1" dirty="0"/>
               <a:t>What could be added as an Action point looking forward to next week?</a:t>
             </a:r>
-            <a:endParaRPr/>
+            <a:endParaRPr lang="pl-PL" b="1" dirty="0"/>
+          </a:p>
+          <a:p>
+            <a:pPr marL="182880" lvl="0" indent="-154940" algn="l" rtl="0">
+              <a:spcBef>
+                <a:spcPts val="0"/>
+              </a:spcBef>
+              <a:spcAft>
+                <a:spcPts val="0"/>
+              </a:spcAft>
+              <a:buSzPts val="1000"/>
+              <a:buChar char="●"/>
+            </a:pPr>
+            <a:endParaRPr dirty="0"/>
           </a:p>
         </p:txBody>
       </p:sp>
@@ -37905,7 +38127,7 @@
             </a:pPr>
             <a:r>
               <a:rPr lang="pl-PL" dirty="0"/>
-              <a:t>I gave myself a 6.1 last block in the reflection and got a 6.91 at the end. Both of these are still without the Python exam which can give up to 2.0 points higher, although I suspect I will get somewhere between 0.5-1.5 based on the next month.</a:t>
+              <a:t>I gave myself a 6.1 last block in the reflection and got a 6.91 at the end. Both of these are still without the Python exam which can give up to 2.0 points higher. I of course don’t expect to get a perfect grade on the test but I believe I can get 1.0-1.5 based on how much time I spend on preparation for the test,</a:t>
             </a:r>
             <a:endParaRPr dirty="0"/>
           </a:p>
@@ -40091,12 +40313,8 @@
               <a:buChar char="●"/>
             </a:pPr>
             <a:r>
-              <a:rPr lang="en" dirty="0"/>
-              <a:t>I have found my footing for the first week so far</a:t>
-            </a:r>
-            <a:r>
               <a:rPr lang="pl-PL" dirty="0"/>
-              <a:t> and have followed the lessons.</a:t>
+              <a:t>I have done what I believe to be expected of me. I have followed all required lessons and am planning to follow some optional material as well.</a:t>
             </a:r>
             <a:endParaRPr dirty="0"/>
           </a:p>
@@ -40172,11 +40390,11 @@
             </a:pPr>
             <a:r>
               <a:rPr lang="en" dirty="0"/>
-              <a:t>I had some problems with certain tasks, but in general did do quite a bit of work.</a:t>
-            </a:r>
-            <a:r>
-              <a:rPr lang="en" b="1" dirty="0"/>
-              <a:t> </a:t>
+              <a:t>I had some problems with certain tasks, but in general did do </a:t>
+            </a:r>
+            <a:r>
+              <a:rPr lang="pl-PL" dirty="0"/>
+              <a:t>a lot of work.</a:t>
             </a:r>
             <a:endParaRPr b="1" dirty="0"/>
           </a:p>
@@ -40300,7 +40518,7 @@
             </a:pPr>
             <a:r>
               <a:rPr lang="pl-PL" dirty="0"/>
-              <a:t>I learned the basics of SQL and machine learning.</a:t>
+              <a:t>This week learned the basics of SQL and machine learning.</a:t>
             </a:r>
             <a:endParaRPr dirty="0"/>
           </a:p>
@@ -41042,6 +41260,15 @@
 </file>
 
 <file path=customXml/item1.xml><?xml version="1.0" encoding="utf-8"?>
+<?mso-contentType ?>
+<FormTemplates xmlns="http://schemas.microsoft.com/sharepoint/v3/contenttype/forms">
+  <Display>DocumentLibraryForm</Display>
+  <Edit>DocumentLibraryForm</Edit>
+  <New>DocumentLibraryForm</New>
+</FormTemplates>
+</file>
+
+<file path=customXml/item2.xml><?xml version="1.0" encoding="utf-8"?>
 <ct:contentTypeSchema xmlns:ct="http://schemas.microsoft.com/office/2006/metadata/contentType" xmlns:ma="http://schemas.microsoft.com/office/2006/metadata/properties/metaAttributes" ct:_="" ma:_="" ma:contentTypeName="Document" ma:contentTypeID="0x0101000BADAD4AA324BF48804EF76FD903323C" ma:contentTypeVersion="15" ma:contentTypeDescription="Create a new document." ma:contentTypeScope="" ma:versionID="4ea0feda506421460444ca95554a0aab">
   <xsd:schema xmlns:xsd="http://www.w3.org/2001/XMLSchema" xmlns:xs="http://www.w3.org/2001/XMLSchema" xmlns:p="http://schemas.microsoft.com/office/2006/metadata/properties" xmlns:ns2="5ff92c65-ed86-4457-baee-ccd535c9ea21" xmlns:ns3="6c8d291c-a5bf-4049-930d-38db8e991d8e" targetNamespace="http://schemas.microsoft.com/office/2006/metadata/properties" ma:root="true" ma:fieldsID="0fc8cf7d0f5ee312899395875a30595e" ns2:_="" ns3:_="">
     <xsd:import namespace="5ff92c65-ed86-4457-baee-ccd535c9ea21"/>
@@ -41276,7 +41503,7 @@
 </ct:contentTypeSchema>
 </file>
 
-<file path=customXml/item2.xml><?xml version="1.0" encoding="utf-8"?>
+<file path=customXml/item3.xml><?xml version="1.0" encoding="utf-8"?>
 <p:properties xmlns:p="http://schemas.microsoft.com/office/2006/metadata/properties" xmlns:xsi="http://www.w3.org/2001/XMLSchema-instance" xmlns:pc="http://schemas.microsoft.com/office/infopath/2007/PartnerControls">
   <documentManagement>
     <SharedWithUsers xmlns="6c8d291c-a5bf-4049-930d-38db8e991d8e">
@@ -41294,16 +41521,15 @@
 </p:properties>
 </file>
 
-<file path=customXml/item3.xml><?xml version="1.0" encoding="utf-8"?>
-<?mso-contentType ?>
-<FormTemplates xmlns="http://schemas.microsoft.com/sharepoint/v3/contenttype/forms">
-  <Display>DocumentLibraryForm</Display>
-  <Edit>DocumentLibraryForm</Edit>
-  <New>DocumentLibraryForm</New>
-</FormTemplates>
+<file path=customXml/itemProps1.xml><?xml version="1.0" encoding="utf-8"?>
+<ds:datastoreItem xmlns:ds="http://schemas.openxmlformats.org/officeDocument/2006/customXml" ds:itemID="{98D9791E-52D0-4ABB-925A-4EAECF798D9B}">
+  <ds:schemaRefs>
+    <ds:schemaRef ds:uri="http://schemas.microsoft.com/sharepoint/v3/contenttype/forms"/>
+  </ds:schemaRefs>
+</ds:datastoreItem>
 </file>
 
-<file path=customXml/itemProps1.xml><?xml version="1.0" encoding="utf-8"?>
+<file path=customXml/itemProps2.xml><?xml version="1.0" encoding="utf-8"?>
 <ds:datastoreItem xmlns:ds="http://schemas.openxmlformats.org/officeDocument/2006/customXml" ds:itemID="{AA562638-1947-4789-9FBF-F833DB2C18A8}">
   <ds:schemaRefs>
     <ds:schemaRef ds:uri="5ff92c65-ed86-4457-baee-ccd535c9ea21"/>
@@ -41322,7 +41548,7 @@
 </ds:datastoreItem>
 </file>
 
-<file path=customXml/itemProps2.xml><?xml version="1.0" encoding="utf-8"?>
+<file path=customXml/itemProps3.xml><?xml version="1.0" encoding="utf-8"?>
 <ds:datastoreItem xmlns:ds="http://schemas.openxmlformats.org/officeDocument/2006/customXml" ds:itemID="{3067B86F-F5BB-4BE6-9A37-0E19E53CB68B}">
   <ds:schemaRefs>
     <ds:schemaRef ds:uri="5ff92c65-ed86-4457-baee-ccd535c9ea21"/>
@@ -41337,12 +41563,4 @@
     <ds:schemaRef ds:uri="http://www.w3.org/XML/1998/namespace"/>
   </ds:schemaRefs>
 </ds:datastoreItem>
-</file>
-
-<file path=customXml/itemProps3.xml><?xml version="1.0" encoding="utf-8"?>
-<ds:datastoreItem xmlns:ds="http://schemas.openxmlformats.org/officeDocument/2006/customXml" ds:itemID="{98D9791E-52D0-4ABB-925A-4EAECF798D9B}">
-  <ds:schemaRefs>
-    <ds:schemaRef ds:uri="http://schemas.microsoft.com/sharepoint/v3/contenttype/forms"/>
-  </ds:schemaRefs>
-</ds:datastoreItem>
 </file>
</xml_diff>

<commit_message>
W4 DataLab 2 Work I (Beginning)
</commit_message>
<xml_diff>
--- a/Deliverables/Learning Log - Y1B-2024-25_ADSAI.pptx
+++ b/Deliverables/Learning Log - Y1B-2024-25_ADSAI.pptx
@@ -16243,8 +16243,8 @@
               <a:buChar char="●"/>
             </a:pPr>
             <a:r>
-              <a:rPr lang="pl-PL"/>
-              <a:t>This week I need to catch up on work that I had planned in my WorkLog for the past 2 weeks that I did not finish.</a:t>
+              <a:rPr lang="en-GB" dirty="0"/>
+              <a:t>My goal for this week is to continue working with the tasks that have been given to me.</a:t>
             </a:r>
             <a:endParaRPr dirty="0"/>
           </a:p>
@@ -16276,6 +16276,10 @@
               <a:buSzPts val="1000"/>
               <a:buChar char="●"/>
             </a:pPr>
+            <a:r>
+              <a:rPr lang="en-GB" dirty="0"/>
+              <a:t>I have continued working, just like I had planned.</a:t>
+            </a:r>
             <a:endParaRPr dirty="0"/>
           </a:p>
           <a:p>
@@ -16368,7 +16372,7 @@
             </a:pPr>
             <a:r>
               <a:rPr lang="en" dirty="0"/>
-              <a:t> </a:t>
+              <a:t> The week went well this time.</a:t>
             </a:r>
             <a:endParaRPr dirty="0"/>
           </a:p>
@@ -16400,6 +16404,10 @@
               <a:buSzPts val="1000"/>
               <a:buChar char="●"/>
             </a:pPr>
+            <a:r>
+              <a:rPr lang="en-GB" dirty="0"/>
+              <a:t>I got a lot of work done.</a:t>
+            </a:r>
             <a:endParaRPr dirty="0"/>
           </a:p>
           <a:p>
@@ -16430,6 +16438,10 @@
               <a:buSzPts val="1000"/>
               <a:buChar char="●"/>
             </a:pPr>
+            <a:r>
+              <a:rPr lang="en-GB" dirty="0"/>
+              <a:t>I did not get everything done and have fallen behind more. I also did not catch up with the unfinished work from the previous weeks.</a:t>
+            </a:r>
             <a:endParaRPr dirty="0"/>
           </a:p>
           <a:p>
@@ -16460,6 +16472,10 @@
               <a:buSzPts val="1000"/>
               <a:buChar char="●"/>
             </a:pPr>
+            <a:r>
+              <a:rPr lang="en-GB" dirty="0"/>
+              <a:t>I learned more concepts related to machine learning and re-learned the concept and rules of matrices.</a:t>
+            </a:r>
             <a:endParaRPr dirty="0"/>
           </a:p>
           <a:p>
@@ -16477,7 +16493,6 @@
               <a:rPr lang="en" b="1" dirty="0"/>
               <a:t>What could be added as an Action point looking forward to next week?</a:t>
             </a:r>
-            <a:endParaRPr lang="pl-PL" b="1" dirty="0"/>
           </a:p>
           <a:p>
             <a:pPr marL="182880" lvl="0" indent="-154940" algn="l" rtl="0">
@@ -16490,7 +16505,11 @@
               <a:buSzPts val="1000"/>
               <a:buChar char="●"/>
             </a:pPr>
-            <a:endParaRPr dirty="0"/>
+            <a:r>
+              <a:rPr lang="en" dirty="0"/>
+              <a:t>I need to concentrate a bit better buring datalabs as my focus drifts off sometimes.</a:t>
+            </a:r>
+            <a:endParaRPr lang="pl-PL" dirty="0"/>
           </a:p>
         </p:txBody>
       </p:sp>
@@ -17127,10 +17146,9 @@
               <a:buChar char="●"/>
             </a:pPr>
             <a:r>
-              <a:rPr lang="en"/>
+              <a:rPr lang="en" b="1" dirty="0"/>
               <a:t>What goal(s) did you set for this week?</a:t>
             </a:r>
-            <a:endParaRPr/>
           </a:p>
           <a:p>
             <a:pPr marL="182880" lvl="0" indent="-154940" algn="l" rtl="0">
@@ -17144,10 +17162,18 @@
               <a:buChar char="●"/>
             </a:pPr>
             <a:r>
-              <a:rPr lang="en"/>
-              <a:t>What have you actually been able to do? </a:t>
-            </a:r>
-            <a:endParaRPr/>
+              <a:rPr lang="en-GB" dirty="0"/>
+              <a:t>My goal this week is to mainly prepare for the Python retake on the 16</a:t>
+            </a:r>
+            <a:r>
+              <a:rPr lang="en-GB" baseline="30000" dirty="0"/>
+              <a:t>th</a:t>
+            </a:r>
+            <a:r>
+              <a:rPr lang="en-GB" dirty="0"/>
+              <a:t>.</a:t>
+            </a:r>
+            <a:endParaRPr dirty="0"/>
           </a:p>
           <a:p>
             <a:pPr marL="182880" lvl="0" indent="-154940" algn="l" rtl="0">
@@ -17161,10 +17187,51 @@
               <a:buChar char="●"/>
             </a:pPr>
             <a:r>
-              <a:rPr lang="en"/>
+              <a:rPr lang="en" b="1" dirty="0"/>
+              <a:t>What have you actually been able to do? </a:t>
+            </a:r>
+          </a:p>
+          <a:p>
+            <a:pPr marL="182880" lvl="0" indent="-154940" algn="l" rtl="0">
+              <a:spcBef>
+                <a:spcPts val="0"/>
+              </a:spcBef>
+              <a:spcAft>
+                <a:spcPts val="0"/>
+              </a:spcAft>
+              <a:buSzPts val="1000"/>
+              <a:buChar char="●"/>
+            </a:pPr>
+            <a:endParaRPr dirty="0"/>
+          </a:p>
+          <a:p>
+            <a:pPr marL="182880" lvl="0" indent="-154940" algn="l" rtl="0">
+              <a:spcBef>
+                <a:spcPts val="0"/>
+              </a:spcBef>
+              <a:spcAft>
+                <a:spcPts val="0"/>
+              </a:spcAft>
+              <a:buSzPts val="1000"/>
+              <a:buChar char="●"/>
+            </a:pPr>
+            <a:r>
+              <a:rPr lang="en" b="1" dirty="0"/>
               <a:t>Showcase the evidence of your progress (production artifacts, short descriptions-links-pictures animated gifs, etc.)</a:t>
             </a:r>
-            <a:endParaRPr/>
+          </a:p>
+          <a:p>
+            <a:pPr marL="182880" lvl="0" indent="-154940" algn="l" rtl="0">
+              <a:spcBef>
+                <a:spcPts val="0"/>
+              </a:spcBef>
+              <a:spcAft>
+                <a:spcPts val="0"/>
+              </a:spcAft>
+              <a:buSzPts val="1000"/>
+              <a:buChar char="●"/>
+            </a:pPr>
+            <a:endParaRPr dirty="0"/>
           </a:p>
         </p:txBody>
       </p:sp>
@@ -17204,10 +17271,9 @@
               <a:buChar char="●"/>
             </a:pPr>
             <a:r>
-              <a:rPr lang="en"/>
+              <a:rPr lang="en" b="1" dirty="0"/>
               <a:t>How did the week go? </a:t>
             </a:r>
-            <a:endParaRPr/>
           </a:p>
           <a:p>
             <a:pPr marL="182880" lvl="0" indent="-154940" algn="l" rtl="0">
@@ -17220,11 +17286,7 @@
               <a:buSzPts val="1000"/>
               <a:buChar char="●"/>
             </a:pPr>
-            <a:r>
-              <a:rPr lang="en"/>
-              <a:t>What went well? </a:t>
-            </a:r>
-            <a:endParaRPr/>
+            <a:endParaRPr dirty="0"/>
           </a:p>
           <a:p>
             <a:pPr marL="182880" lvl="0" indent="-154940" algn="l" rtl="0">
@@ -17238,10 +17300,9 @@
               <a:buChar char="●"/>
             </a:pPr>
             <a:r>
-              <a:rPr lang="en"/>
-              <a:t>What didn’t go so well? </a:t>
-            </a:r>
-            <a:endParaRPr/>
+              <a:rPr lang="en" b="1" dirty="0"/>
+              <a:t>What went well? </a:t>
+            </a:r>
           </a:p>
           <a:p>
             <a:pPr marL="182880" lvl="0" indent="-154940" algn="l" rtl="0">
@@ -17254,11 +17315,7 @@
               <a:buSzPts val="1000"/>
               <a:buChar char="●"/>
             </a:pPr>
-            <a:r>
-              <a:rPr lang="en"/>
-              <a:t>What did you learn? </a:t>
-            </a:r>
-            <a:endParaRPr/>
+            <a:endParaRPr dirty="0"/>
           </a:p>
           <a:p>
             <a:pPr marL="182880" lvl="0" indent="-154940" algn="l" rtl="0">
@@ -17272,10 +17329,80 @@
               <a:buChar char="●"/>
             </a:pPr>
             <a:r>
-              <a:rPr lang="en"/>
+              <a:rPr lang="en" b="1" dirty="0"/>
+              <a:t>What didn’t go so well? </a:t>
+            </a:r>
+          </a:p>
+          <a:p>
+            <a:pPr marL="182880" lvl="0" indent="-154940" algn="l" rtl="0">
+              <a:spcBef>
+                <a:spcPts val="0"/>
+              </a:spcBef>
+              <a:spcAft>
+                <a:spcPts val="0"/>
+              </a:spcAft>
+              <a:buSzPts val="1000"/>
+              <a:buChar char="●"/>
+            </a:pPr>
+            <a:endParaRPr dirty="0"/>
+          </a:p>
+          <a:p>
+            <a:pPr marL="182880" lvl="0" indent="-154940" algn="l" rtl="0">
+              <a:spcBef>
+                <a:spcPts val="0"/>
+              </a:spcBef>
+              <a:spcAft>
+                <a:spcPts val="0"/>
+              </a:spcAft>
+              <a:buSzPts val="1000"/>
+              <a:buChar char="●"/>
+            </a:pPr>
+            <a:r>
+              <a:rPr lang="en" b="1" dirty="0"/>
+              <a:t>What did you learn? </a:t>
+            </a:r>
+          </a:p>
+          <a:p>
+            <a:pPr marL="182880" lvl="0" indent="-154940" algn="l" rtl="0">
+              <a:spcBef>
+                <a:spcPts val="0"/>
+              </a:spcBef>
+              <a:spcAft>
+                <a:spcPts val="0"/>
+              </a:spcAft>
+              <a:buSzPts val="1000"/>
+              <a:buChar char="●"/>
+            </a:pPr>
+            <a:endParaRPr dirty="0"/>
+          </a:p>
+          <a:p>
+            <a:pPr marL="182880" lvl="0" indent="-154940" algn="l" rtl="0">
+              <a:spcBef>
+                <a:spcPts val="0"/>
+              </a:spcBef>
+              <a:spcAft>
+                <a:spcPts val="0"/>
+              </a:spcAft>
+              <a:buSzPts val="1000"/>
+              <a:buChar char="●"/>
+            </a:pPr>
+            <a:r>
+              <a:rPr lang="en" b="1" dirty="0"/>
               <a:t>What could be added as an Action point looking forward to next week?</a:t>
             </a:r>
-            <a:endParaRPr/>
+          </a:p>
+          <a:p>
+            <a:pPr marL="182880" lvl="0" indent="-154940" algn="l" rtl="0">
+              <a:spcBef>
+                <a:spcPts val="0"/>
+              </a:spcBef>
+              <a:spcAft>
+                <a:spcPts val="0"/>
+              </a:spcAft>
+              <a:buSzPts val="1000"/>
+              <a:buChar char="●"/>
+            </a:pPr>
+            <a:endParaRPr dirty="0"/>
           </a:p>
         </p:txBody>
       </p:sp>
@@ -41260,15 +41387,6 @@
 </file>
 
 <file path=customXml/item1.xml><?xml version="1.0" encoding="utf-8"?>
-<?mso-contentType ?>
-<FormTemplates xmlns="http://schemas.microsoft.com/sharepoint/v3/contenttype/forms">
-  <Display>DocumentLibraryForm</Display>
-  <Edit>DocumentLibraryForm</Edit>
-  <New>DocumentLibraryForm</New>
-</FormTemplates>
-</file>
-
-<file path=customXml/item2.xml><?xml version="1.0" encoding="utf-8"?>
 <ct:contentTypeSchema xmlns:ct="http://schemas.microsoft.com/office/2006/metadata/contentType" xmlns:ma="http://schemas.microsoft.com/office/2006/metadata/properties/metaAttributes" ct:_="" ma:_="" ma:contentTypeName="Document" ma:contentTypeID="0x0101000BADAD4AA324BF48804EF76FD903323C" ma:contentTypeVersion="15" ma:contentTypeDescription="Create a new document." ma:contentTypeScope="" ma:versionID="4ea0feda506421460444ca95554a0aab">
   <xsd:schema xmlns:xsd="http://www.w3.org/2001/XMLSchema" xmlns:xs="http://www.w3.org/2001/XMLSchema" xmlns:p="http://schemas.microsoft.com/office/2006/metadata/properties" xmlns:ns2="5ff92c65-ed86-4457-baee-ccd535c9ea21" xmlns:ns3="6c8d291c-a5bf-4049-930d-38db8e991d8e" targetNamespace="http://schemas.microsoft.com/office/2006/metadata/properties" ma:root="true" ma:fieldsID="0fc8cf7d0f5ee312899395875a30595e" ns2:_="" ns3:_="">
     <xsd:import namespace="5ff92c65-ed86-4457-baee-ccd535c9ea21"/>
@@ -41503,7 +41621,7 @@
 </ct:contentTypeSchema>
 </file>
 
-<file path=customXml/item3.xml><?xml version="1.0" encoding="utf-8"?>
+<file path=customXml/item2.xml><?xml version="1.0" encoding="utf-8"?>
 <p:properties xmlns:p="http://schemas.microsoft.com/office/2006/metadata/properties" xmlns:xsi="http://www.w3.org/2001/XMLSchema-instance" xmlns:pc="http://schemas.microsoft.com/office/infopath/2007/PartnerControls">
   <documentManagement>
     <SharedWithUsers xmlns="6c8d291c-a5bf-4049-930d-38db8e991d8e">
@@ -41521,15 +41639,16 @@
 </p:properties>
 </file>
 
-<file path=customXml/itemProps1.xml><?xml version="1.0" encoding="utf-8"?>
-<ds:datastoreItem xmlns:ds="http://schemas.openxmlformats.org/officeDocument/2006/customXml" ds:itemID="{98D9791E-52D0-4ABB-925A-4EAECF798D9B}">
-  <ds:schemaRefs>
-    <ds:schemaRef ds:uri="http://schemas.microsoft.com/sharepoint/v3/contenttype/forms"/>
-  </ds:schemaRefs>
-</ds:datastoreItem>
+<file path=customXml/item3.xml><?xml version="1.0" encoding="utf-8"?>
+<?mso-contentType ?>
+<FormTemplates xmlns="http://schemas.microsoft.com/sharepoint/v3/contenttype/forms">
+  <Display>DocumentLibraryForm</Display>
+  <Edit>DocumentLibraryForm</Edit>
+  <New>DocumentLibraryForm</New>
+</FormTemplates>
 </file>
 
-<file path=customXml/itemProps2.xml><?xml version="1.0" encoding="utf-8"?>
+<file path=customXml/itemProps1.xml><?xml version="1.0" encoding="utf-8"?>
 <ds:datastoreItem xmlns:ds="http://schemas.openxmlformats.org/officeDocument/2006/customXml" ds:itemID="{AA562638-1947-4789-9FBF-F833DB2C18A8}">
   <ds:schemaRefs>
     <ds:schemaRef ds:uri="5ff92c65-ed86-4457-baee-ccd535c9ea21"/>
@@ -41548,7 +41667,7 @@
 </ds:datastoreItem>
 </file>
 
-<file path=customXml/itemProps3.xml><?xml version="1.0" encoding="utf-8"?>
+<file path=customXml/itemProps2.xml><?xml version="1.0" encoding="utf-8"?>
 <ds:datastoreItem xmlns:ds="http://schemas.openxmlformats.org/officeDocument/2006/customXml" ds:itemID="{3067B86F-F5BB-4BE6-9A37-0E19E53CB68B}">
   <ds:schemaRefs>
     <ds:schemaRef ds:uri="5ff92c65-ed86-4457-baee-ccd535c9ea21"/>
@@ -41563,4 +41682,12 @@
     <ds:schemaRef ds:uri="http://www.w3.org/XML/1998/namespace"/>
   </ds:schemaRefs>
 </ds:datastoreItem>
+</file>
+
+<file path=customXml/itemProps3.xml><?xml version="1.0" encoding="utf-8"?>
+<ds:datastoreItem xmlns:ds="http://schemas.openxmlformats.org/officeDocument/2006/customXml" ds:itemID="{98D9791E-52D0-4ABB-925A-4EAECF798D9B}">
+  <ds:schemaRefs>
+    <ds:schemaRef ds:uri="http://schemas.microsoft.com/sharepoint/v3/contenttype/forms"/>
+  </ds:schemaRefs>
+</ds:datastoreItem>
 </file>
</xml_diff>

<commit_message>
W4 DataLab 2 Work II (End)
</commit_message>
<xml_diff>
--- a/Deliverables/Learning Log - Y1B-2024-25_ADSAI.pptx
+++ b/Deliverables/Learning Log - Y1B-2024-25_ADSAI.pptx
@@ -38557,6 +38557,18 @@
               </a:spcAft>
               <a:buNone/>
             </a:pPr>
+            <a:r>
+              <a:rPr lang="en-GB" dirty="0"/>
+              <a:t>Sleep good well :</a:t>
+            </a:r>
+            <a:r>
+              <a:rPr lang="en-GB" dirty="0" err="1"/>
+              <a:t>thumbsup</a:t>
+            </a:r>
+            <a:r>
+              <a:rPr lang="en-GB" dirty="0"/>
+              <a:t>:</a:t>
+            </a:r>
             <a:endParaRPr dirty="0"/>
           </a:p>
           <a:p>
@@ -41387,6 +41399,33 @@
 </file>
 
 <file path=customXml/item1.xml><?xml version="1.0" encoding="utf-8"?>
+<p:properties xmlns:p="http://schemas.microsoft.com/office/2006/metadata/properties" xmlns:xsi="http://www.w3.org/2001/XMLSchema-instance" xmlns:pc="http://schemas.microsoft.com/office/infopath/2007/PartnerControls">
+  <documentManagement>
+    <SharedWithUsers xmlns="6c8d291c-a5bf-4049-930d-38db8e991d8e">
+      <UserInfo>
+        <DisplayName/>
+        <AccountId xsi:nil="true"/>
+        <AccountType/>
+      </UserInfo>
+    </SharedWithUsers>
+    <TaxCatchAll xmlns="6c8d291c-a5bf-4049-930d-38db8e991d8e" xsi:nil="true"/>
+    <lcf76f155ced4ddcb4097134ff3c332f xmlns="5ff92c65-ed86-4457-baee-ccd535c9ea21">
+      <Terms xmlns="http://schemas.microsoft.com/office/infopath/2007/PartnerControls"/>
+    </lcf76f155ced4ddcb4097134ff3c332f>
+  </documentManagement>
+</p:properties>
+</file>
+
+<file path=customXml/item2.xml><?xml version="1.0" encoding="utf-8"?>
+<?mso-contentType ?>
+<FormTemplates xmlns="http://schemas.microsoft.com/sharepoint/v3/contenttype/forms">
+  <Display>DocumentLibraryForm</Display>
+  <Edit>DocumentLibraryForm</Edit>
+  <New>DocumentLibraryForm</New>
+</FormTemplates>
+</file>
+
+<file path=customXml/item3.xml><?xml version="1.0" encoding="utf-8"?>
 <ct:contentTypeSchema xmlns:ct="http://schemas.microsoft.com/office/2006/metadata/contentType" xmlns:ma="http://schemas.microsoft.com/office/2006/metadata/properties/metaAttributes" ct:_="" ma:_="" ma:contentTypeName="Document" ma:contentTypeID="0x0101000BADAD4AA324BF48804EF76FD903323C" ma:contentTypeVersion="15" ma:contentTypeDescription="Create a new document." ma:contentTypeScope="" ma:versionID="4ea0feda506421460444ca95554a0aab">
   <xsd:schema xmlns:xsd="http://www.w3.org/2001/XMLSchema" xmlns:xs="http://www.w3.org/2001/XMLSchema" xmlns:p="http://schemas.microsoft.com/office/2006/metadata/properties" xmlns:ns2="5ff92c65-ed86-4457-baee-ccd535c9ea21" xmlns:ns3="6c8d291c-a5bf-4049-930d-38db8e991d8e" targetNamespace="http://schemas.microsoft.com/office/2006/metadata/properties" ma:root="true" ma:fieldsID="0fc8cf7d0f5ee312899395875a30595e" ns2:_="" ns3:_="">
     <xsd:import namespace="5ff92c65-ed86-4457-baee-ccd535c9ea21"/>
@@ -41621,34 +41660,32 @@
 </ct:contentTypeSchema>
 </file>
 
-<file path=customXml/item2.xml><?xml version="1.0" encoding="utf-8"?>
-<p:properties xmlns:p="http://schemas.microsoft.com/office/2006/metadata/properties" xmlns:xsi="http://www.w3.org/2001/XMLSchema-instance" xmlns:pc="http://schemas.microsoft.com/office/infopath/2007/PartnerControls">
-  <documentManagement>
-    <SharedWithUsers xmlns="6c8d291c-a5bf-4049-930d-38db8e991d8e">
-      <UserInfo>
-        <DisplayName/>
-        <AccountId xsi:nil="true"/>
-        <AccountType/>
-      </UserInfo>
-    </SharedWithUsers>
-    <TaxCatchAll xmlns="6c8d291c-a5bf-4049-930d-38db8e991d8e" xsi:nil="true"/>
-    <lcf76f155ced4ddcb4097134ff3c332f xmlns="5ff92c65-ed86-4457-baee-ccd535c9ea21">
-      <Terms xmlns="http://schemas.microsoft.com/office/infopath/2007/PartnerControls"/>
-    </lcf76f155ced4ddcb4097134ff3c332f>
-  </documentManagement>
-</p:properties>
+<file path=customXml/itemProps1.xml><?xml version="1.0" encoding="utf-8"?>
+<ds:datastoreItem xmlns:ds="http://schemas.openxmlformats.org/officeDocument/2006/customXml" ds:itemID="{3067B86F-F5BB-4BE6-9A37-0E19E53CB68B}">
+  <ds:schemaRefs>
+    <ds:schemaRef ds:uri="5ff92c65-ed86-4457-baee-ccd535c9ea21"/>
+    <ds:schemaRef ds:uri="6c8d291c-a5bf-4049-930d-38db8e991d8e"/>
+    <ds:schemaRef ds:uri="http://purl.org/dc/dcmitype/"/>
+    <ds:schemaRef ds:uri="http://purl.org/dc/elements/1.1/"/>
+    <ds:schemaRef ds:uri="http://purl.org/dc/terms/"/>
+    <ds:schemaRef ds:uri="http://schemas.microsoft.com/office/2006/documentManagement/types"/>
+    <ds:schemaRef ds:uri="http://schemas.microsoft.com/office/2006/metadata/properties"/>
+    <ds:schemaRef ds:uri="http://schemas.microsoft.com/office/infopath/2007/PartnerControls"/>
+    <ds:schemaRef ds:uri="http://schemas.openxmlformats.org/package/2006/metadata/core-properties"/>
+    <ds:schemaRef ds:uri="http://www.w3.org/XML/1998/namespace"/>
+  </ds:schemaRefs>
+</ds:datastoreItem>
 </file>
 
-<file path=customXml/item3.xml><?xml version="1.0" encoding="utf-8"?>
-<?mso-contentType ?>
-<FormTemplates xmlns="http://schemas.microsoft.com/sharepoint/v3/contenttype/forms">
-  <Display>DocumentLibraryForm</Display>
-  <Edit>DocumentLibraryForm</Edit>
-  <New>DocumentLibraryForm</New>
-</FormTemplates>
+<file path=customXml/itemProps2.xml><?xml version="1.0" encoding="utf-8"?>
+<ds:datastoreItem xmlns:ds="http://schemas.openxmlformats.org/officeDocument/2006/customXml" ds:itemID="{98D9791E-52D0-4ABB-925A-4EAECF798D9B}">
+  <ds:schemaRefs>
+    <ds:schemaRef ds:uri="http://schemas.microsoft.com/sharepoint/v3/contenttype/forms"/>
+  </ds:schemaRefs>
+</ds:datastoreItem>
 </file>
 
-<file path=customXml/itemProps1.xml><?xml version="1.0" encoding="utf-8"?>
+<file path=customXml/itemProps3.xml><?xml version="1.0" encoding="utf-8"?>
 <ds:datastoreItem xmlns:ds="http://schemas.openxmlformats.org/officeDocument/2006/customXml" ds:itemID="{AA562638-1947-4789-9FBF-F833DB2C18A8}">
   <ds:schemaRefs>
     <ds:schemaRef ds:uri="5ff92c65-ed86-4457-baee-ccd535c9ea21"/>
@@ -41665,29 +41702,4 @@
     <ds:schemaRef ds:uri="http://www.w3.org/2001/XMLSchema"/>
   </ds:schemaRefs>
 </ds:datastoreItem>
-</file>
-
-<file path=customXml/itemProps2.xml><?xml version="1.0" encoding="utf-8"?>
-<ds:datastoreItem xmlns:ds="http://schemas.openxmlformats.org/officeDocument/2006/customXml" ds:itemID="{3067B86F-F5BB-4BE6-9A37-0E19E53CB68B}">
-  <ds:schemaRefs>
-    <ds:schemaRef ds:uri="5ff92c65-ed86-4457-baee-ccd535c9ea21"/>
-    <ds:schemaRef ds:uri="6c8d291c-a5bf-4049-930d-38db8e991d8e"/>
-    <ds:schemaRef ds:uri="http://purl.org/dc/dcmitype/"/>
-    <ds:schemaRef ds:uri="http://purl.org/dc/elements/1.1/"/>
-    <ds:schemaRef ds:uri="http://purl.org/dc/terms/"/>
-    <ds:schemaRef ds:uri="http://schemas.microsoft.com/office/2006/documentManagement/types"/>
-    <ds:schemaRef ds:uri="http://schemas.microsoft.com/office/2006/metadata/properties"/>
-    <ds:schemaRef ds:uri="http://schemas.microsoft.com/office/infopath/2007/PartnerControls"/>
-    <ds:schemaRef ds:uri="http://schemas.openxmlformats.org/package/2006/metadata/core-properties"/>
-    <ds:schemaRef ds:uri="http://www.w3.org/XML/1998/namespace"/>
-  </ds:schemaRefs>
-</ds:datastoreItem>
-</file>
-
-<file path=customXml/itemProps3.xml><?xml version="1.0" encoding="utf-8"?>
-<ds:datastoreItem xmlns:ds="http://schemas.openxmlformats.org/officeDocument/2006/customXml" ds:itemID="{98D9791E-52D0-4ABB-925A-4EAECF798D9B}">
-  <ds:schemaRefs>
-    <ds:schemaRef ds:uri="http://schemas.microsoft.com/sharepoint/v3/contenttype/forms"/>
-  </ds:schemaRefs>
-</ds:datastoreItem>
 </file>
</xml_diff>

<commit_message>
W5 DataLab 1 Work II (Pre-Break)
</commit_message>
<xml_diff>
--- a/Deliverables/Learning Log - Y1B-2024-25_ADSAI.pptx
+++ b/Deliverables/Learning Log - Y1B-2024-25_ADSAI.pptx
@@ -64,7 +64,7 @@
       <p:boldItalic r:id="rId53"/>
     </p:embeddedFont>
     <p:embeddedFont>
-      <p:font typeface="Open Sans" panose="020F0502020204030204" pitchFamily="34" charset="0"/>
+      <p:font typeface="Open Sans" panose="020B0606030504020204" pitchFamily="34" charset="0"/>
       <p:regular r:id="rId54"/>
       <p:bold r:id="rId55"/>
       <p:italic r:id="rId56"/>
@@ -78,19 +78,19 @@
       <p:boldItalic r:id="rId61"/>
     </p:embeddedFont>
     <p:embeddedFont>
-      <p:font typeface="Roboto" panose="020F0502020204030204" pitchFamily="2" charset="0"/>
+      <p:font typeface="Roboto" panose="02000000000000000000" pitchFamily="2" charset="0"/>
       <p:regular r:id="rId62"/>
       <p:bold r:id="rId63"/>
       <p:italic r:id="rId64"/>
       <p:boldItalic r:id="rId65"/>
     </p:embeddedFont>
     <p:embeddedFont>
-      <p:font typeface="Roboto Light" panose="020F0502020204030204" pitchFamily="2" charset="0"/>
+      <p:font typeface="Roboto Light" panose="02000000000000000000" pitchFamily="2" charset="0"/>
       <p:regular r:id="rId66"/>
       <p:italic r:id="rId67"/>
     </p:embeddedFont>
     <p:embeddedFont>
-      <p:font typeface="Roboto Thin" panose="020F0502020204030204" pitchFamily="2" charset="0"/>
+      <p:font typeface="Roboto Thin" panose="02000000000000000000" pitchFamily="2" charset="0"/>
       <p:regular r:id="rId68"/>
       <p:italic r:id="rId69"/>
     </p:embeddedFont>
@@ -17202,6 +17202,130 @@
               <a:buSzPts val="1000"/>
               <a:buChar char="●"/>
             </a:pPr>
+            <a:r>
+              <a:rPr lang="de-DE" dirty="0"/>
+              <a:t>I </a:t>
+            </a:r>
+            <a:r>
+              <a:rPr lang="de-DE" dirty="0" err="1"/>
+              <a:t>have</a:t>
+            </a:r>
+            <a:r>
+              <a:rPr lang="de-DE" dirty="0"/>
+              <a:t> </a:t>
+            </a:r>
+            <a:r>
+              <a:rPr lang="de-DE" dirty="0" err="1"/>
+              <a:t>prepared</a:t>
+            </a:r>
+            <a:r>
+              <a:rPr lang="de-DE" dirty="0"/>
+              <a:t> </a:t>
+            </a:r>
+            <a:r>
+              <a:rPr lang="de-DE" dirty="0" err="1"/>
+              <a:t>for</a:t>
+            </a:r>
+            <a:r>
+              <a:rPr lang="de-DE" dirty="0"/>
+              <a:t> </a:t>
+            </a:r>
+            <a:r>
+              <a:rPr lang="de-DE" dirty="0" err="1"/>
+              <a:t>the</a:t>
+            </a:r>
+            <a:r>
+              <a:rPr lang="de-DE" dirty="0"/>
+              <a:t> </a:t>
+            </a:r>
+            <a:r>
+              <a:rPr lang="de-DE" dirty="0" err="1"/>
+              <a:t>retake</a:t>
+            </a:r>
+            <a:r>
+              <a:rPr lang="de-DE" dirty="0"/>
+              <a:t> and </a:t>
+            </a:r>
+            <a:r>
+              <a:rPr lang="de-DE" dirty="0" err="1"/>
+              <a:t>continued</a:t>
+            </a:r>
+            <a:r>
+              <a:rPr lang="de-DE" dirty="0"/>
+              <a:t> </a:t>
+            </a:r>
+            <a:r>
+              <a:rPr lang="de-DE" dirty="0" err="1"/>
+              <a:t>working</a:t>
+            </a:r>
+            <a:r>
+              <a:rPr lang="de-DE" dirty="0"/>
+              <a:t> on </a:t>
+            </a:r>
+            <a:r>
+              <a:rPr lang="de-DE" dirty="0" err="1"/>
+              <a:t>the</a:t>
+            </a:r>
+            <a:r>
+              <a:rPr lang="de-DE" dirty="0"/>
+              <a:t> </a:t>
+            </a:r>
+            <a:r>
+              <a:rPr lang="de-DE" dirty="0" err="1"/>
+              <a:t>task</a:t>
+            </a:r>
+            <a:r>
+              <a:rPr lang="de-DE" dirty="0"/>
+              <a:t> </a:t>
+            </a:r>
+            <a:r>
+              <a:rPr lang="de-DE" dirty="0" err="1"/>
+              <a:t>from</a:t>
+            </a:r>
+            <a:r>
+              <a:rPr lang="de-DE" dirty="0"/>
+              <a:t> </a:t>
+            </a:r>
+            <a:r>
+              <a:rPr lang="de-DE" dirty="0" err="1"/>
+              <a:t>the</a:t>
+            </a:r>
+            <a:r>
+              <a:rPr lang="de-DE" dirty="0"/>
+              <a:t> </a:t>
+            </a:r>
+            <a:r>
+              <a:rPr lang="de-DE" dirty="0" err="1"/>
+              <a:t>other</a:t>
+            </a:r>
+            <a:r>
+              <a:rPr lang="de-DE" dirty="0"/>
+              <a:t> </a:t>
+            </a:r>
+            <a:r>
+              <a:rPr lang="de-DE" dirty="0" err="1"/>
+              <a:t>days</a:t>
+            </a:r>
+            <a:r>
+              <a:rPr lang="de-DE" dirty="0"/>
+              <a:t> </a:t>
+            </a:r>
+            <a:r>
+              <a:rPr lang="de-DE" dirty="0" err="1"/>
+              <a:t>that</a:t>
+            </a:r>
+            <a:r>
+              <a:rPr lang="de-DE" dirty="0"/>
+              <a:t> I </a:t>
+            </a:r>
+            <a:r>
+              <a:rPr lang="de-DE" dirty="0" err="1"/>
+              <a:t>wasn</a:t>
+            </a:r>
+            <a:r>
+              <a:rPr lang="de-DE" dirty="0"/>
+              <a:t> not sick.</a:t>
+            </a:r>
             <a:endParaRPr dirty="0"/>
           </a:p>
           <a:p>
@@ -17286,6 +17410,122 @@
               <a:buSzPts val="1000"/>
               <a:buChar char="●"/>
             </a:pPr>
+            <a:r>
+              <a:rPr lang="de-DE" dirty="0"/>
+              <a:t>The </a:t>
+            </a:r>
+            <a:r>
+              <a:rPr lang="de-DE" dirty="0" err="1"/>
+              <a:t>week</a:t>
+            </a:r>
+            <a:r>
+              <a:rPr lang="de-DE" dirty="0"/>
+              <a:t> </a:t>
+            </a:r>
+            <a:r>
+              <a:rPr lang="de-DE" dirty="0" err="1"/>
+              <a:t>began</a:t>
+            </a:r>
+            <a:r>
+              <a:rPr lang="de-DE" dirty="0"/>
+              <a:t> </a:t>
+            </a:r>
+            <a:r>
+              <a:rPr lang="de-DE" dirty="0" err="1"/>
+              <a:t>bad</a:t>
+            </a:r>
+            <a:r>
+              <a:rPr lang="de-DE" dirty="0"/>
+              <a:t> </a:t>
+            </a:r>
+            <a:r>
+              <a:rPr lang="de-DE" dirty="0" err="1"/>
+              <a:t>with</a:t>
+            </a:r>
+            <a:r>
+              <a:rPr lang="de-DE" dirty="0"/>
+              <a:t> </a:t>
+            </a:r>
+            <a:r>
+              <a:rPr lang="de-DE" dirty="0" err="1"/>
+              <a:t>me</a:t>
+            </a:r>
+            <a:r>
+              <a:rPr lang="de-DE" dirty="0"/>
+              <a:t> </a:t>
+            </a:r>
+            <a:r>
+              <a:rPr lang="de-DE" dirty="0" err="1"/>
+              <a:t>being</a:t>
+            </a:r>
+            <a:r>
+              <a:rPr lang="de-DE" dirty="0"/>
+              <a:t> sick but </a:t>
+            </a:r>
+            <a:r>
+              <a:rPr lang="de-DE" dirty="0" err="1"/>
+              <a:t>it</a:t>
+            </a:r>
+            <a:r>
+              <a:rPr lang="de-DE" dirty="0"/>
+              <a:t> </a:t>
+            </a:r>
+            <a:r>
+              <a:rPr lang="de-DE" dirty="0" err="1"/>
+              <a:t>did</a:t>
+            </a:r>
+            <a:r>
+              <a:rPr lang="de-DE" dirty="0"/>
+              <a:t> turn </a:t>
+            </a:r>
+            <a:r>
+              <a:rPr lang="de-DE" dirty="0" err="1"/>
+              <a:t>good</a:t>
+            </a:r>
+            <a:r>
+              <a:rPr lang="de-DE" dirty="0"/>
+              <a:t> </a:t>
+            </a:r>
+            <a:r>
+              <a:rPr lang="de-DE" dirty="0" err="1"/>
+              <a:t>as</a:t>
+            </a:r>
+            <a:r>
+              <a:rPr lang="de-DE" dirty="0"/>
+              <a:t> I </a:t>
+            </a:r>
+            <a:r>
+              <a:rPr lang="de-DE" dirty="0" err="1"/>
+              <a:t>prepared</a:t>
+            </a:r>
+            <a:r>
+              <a:rPr lang="de-DE" dirty="0"/>
+              <a:t> </a:t>
+            </a:r>
+            <a:r>
+              <a:rPr lang="de-DE" dirty="0" err="1"/>
+              <a:t>for</a:t>
+            </a:r>
+            <a:r>
+              <a:rPr lang="de-DE" dirty="0"/>
+              <a:t> </a:t>
+            </a:r>
+            <a:r>
+              <a:rPr lang="de-DE" dirty="0" err="1"/>
+              <a:t>the</a:t>
+            </a:r>
+            <a:r>
+              <a:rPr lang="de-DE" dirty="0"/>
+              <a:t> </a:t>
+            </a:r>
+            <a:r>
+              <a:rPr lang="de-DE" dirty="0" err="1"/>
+              <a:t>retakes</a:t>
+            </a:r>
+            <a:r>
+              <a:rPr lang="de-DE" dirty="0"/>
+              <a:t>.</a:t>
+            </a:r>
             <a:endParaRPr dirty="0"/>
           </a:p>
           <a:p>
@@ -17315,6 +17555,38 @@
               <a:buSzPts val="1000"/>
               <a:buChar char="●"/>
             </a:pPr>
+            <a:r>
+              <a:rPr lang="de-DE" dirty="0" err="1"/>
+              <a:t>Preparation</a:t>
+            </a:r>
+            <a:r>
+              <a:rPr lang="de-DE" dirty="0"/>
+              <a:t> </a:t>
+            </a:r>
+            <a:r>
+              <a:rPr lang="de-DE" dirty="0" err="1"/>
+              <a:t>for</a:t>
+            </a:r>
+            <a:r>
+              <a:rPr lang="de-DE" dirty="0"/>
+              <a:t> </a:t>
+            </a:r>
+            <a:r>
+              <a:rPr lang="de-DE" dirty="0" err="1"/>
+              <a:t>the</a:t>
+            </a:r>
+            <a:r>
+              <a:rPr lang="de-DE" dirty="0"/>
+              <a:t> </a:t>
+            </a:r>
+            <a:r>
+              <a:rPr lang="de-DE" dirty="0" err="1"/>
+              <a:t>retakes</a:t>
+            </a:r>
+            <a:r>
+              <a:rPr lang="de-DE" dirty="0"/>
+              <a:t>.</a:t>
+            </a:r>
             <a:endParaRPr dirty="0"/>
           </a:p>
           <a:p>
@@ -17344,6 +17616,82 @@
               <a:buSzPts val="1000"/>
               <a:buChar char="●"/>
             </a:pPr>
+            <a:r>
+              <a:rPr lang="de-DE" dirty="0"/>
+              <a:t>On Tuesday and a </a:t>
+            </a:r>
+            <a:r>
+              <a:rPr lang="de-DE" dirty="0" err="1"/>
+              <a:t>bit</a:t>
+            </a:r>
+            <a:r>
+              <a:rPr lang="de-DE" dirty="0"/>
+              <a:t> on Wednesday I was sick, so I </a:t>
+            </a:r>
+            <a:r>
+              <a:rPr lang="de-DE" dirty="0" err="1"/>
+              <a:t>fell</a:t>
+            </a:r>
+            <a:r>
+              <a:rPr lang="de-DE" dirty="0"/>
+              <a:t> </a:t>
+            </a:r>
+            <a:r>
+              <a:rPr lang="de-DE" dirty="0" err="1"/>
+              <a:t>behind</a:t>
+            </a:r>
+            <a:r>
+              <a:rPr lang="de-DE" dirty="0"/>
+              <a:t> </a:t>
+            </a:r>
+            <a:r>
+              <a:rPr lang="de-DE" dirty="0" err="1"/>
+              <a:t>with</a:t>
+            </a:r>
+            <a:r>
+              <a:rPr lang="de-DE" dirty="0"/>
+              <a:t> </a:t>
+            </a:r>
+            <a:r>
+              <a:rPr lang="de-DE" dirty="0" err="1"/>
+              <a:t>the</a:t>
+            </a:r>
+            <a:r>
+              <a:rPr lang="de-DE" dirty="0"/>
+              <a:t> </a:t>
+            </a:r>
+            <a:r>
+              <a:rPr lang="de-DE" dirty="0" err="1"/>
+              <a:t>tasks</a:t>
+            </a:r>
+            <a:r>
+              <a:rPr lang="de-DE" dirty="0"/>
+              <a:t> </a:t>
+            </a:r>
+            <a:r>
+              <a:rPr lang="de-DE" dirty="0" err="1"/>
+              <a:t>for</a:t>
+            </a:r>
+            <a:r>
+              <a:rPr lang="de-DE" dirty="0"/>
+              <a:t> </a:t>
+            </a:r>
+            <a:r>
+              <a:rPr lang="de-DE" dirty="0" err="1"/>
+              <a:t>the</a:t>
+            </a:r>
+            <a:r>
+              <a:rPr lang="de-DE" dirty="0"/>
+              <a:t> </a:t>
+            </a:r>
+            <a:r>
+              <a:rPr lang="de-DE" dirty="0" err="1"/>
+              <a:t>week</a:t>
+            </a:r>
+            <a:r>
+              <a:rPr lang="de-DE" dirty="0"/>
+              <a:t>.</a:t>
+            </a:r>
             <a:endParaRPr dirty="0"/>
           </a:p>
           <a:p>
@@ -17373,6 +17721,98 @@
               <a:buSzPts val="1000"/>
               <a:buChar char="●"/>
             </a:pPr>
+            <a:r>
+              <a:rPr lang="de-DE" dirty="0"/>
+              <a:t>I </a:t>
+            </a:r>
+            <a:r>
+              <a:rPr lang="de-DE" dirty="0" err="1"/>
+              <a:t>learned</a:t>
+            </a:r>
+            <a:r>
+              <a:rPr lang="de-DE" dirty="0"/>
+              <a:t> </a:t>
+            </a:r>
+            <a:r>
+              <a:rPr lang="de-DE" dirty="0" err="1"/>
+              <a:t>the</a:t>
+            </a:r>
+            <a:r>
+              <a:rPr lang="de-DE" dirty="0"/>
+              <a:t> </a:t>
+            </a:r>
+            <a:r>
+              <a:rPr lang="de-DE" dirty="0" err="1"/>
+              <a:t>theory</a:t>
+            </a:r>
+            <a:r>
+              <a:rPr lang="de-DE" dirty="0"/>
+              <a:t> </a:t>
+            </a:r>
+            <a:r>
+              <a:rPr lang="de-DE" dirty="0" err="1"/>
+              <a:t>behind</a:t>
+            </a:r>
+            <a:r>
+              <a:rPr lang="de-DE" dirty="0"/>
+              <a:t> </a:t>
+            </a:r>
+            <a:r>
+              <a:rPr lang="de-DE" dirty="0" err="1"/>
+              <a:t>concepts</a:t>
+            </a:r>
+            <a:r>
+              <a:rPr lang="de-DE" dirty="0"/>
+              <a:t> such </a:t>
+            </a:r>
+            <a:r>
+              <a:rPr lang="de-DE" dirty="0" err="1"/>
+              <a:t>as</a:t>
+            </a:r>
+            <a:r>
+              <a:rPr lang="de-DE" dirty="0"/>
+              <a:t> </a:t>
+            </a:r>
+            <a:r>
+              <a:rPr lang="de-DE" dirty="0" err="1"/>
+              <a:t>boosting</a:t>
+            </a:r>
+            <a:r>
+              <a:rPr lang="de-DE" dirty="0"/>
+              <a:t>, stacking, </a:t>
+            </a:r>
+            <a:r>
+              <a:rPr lang="de-DE" dirty="0" err="1"/>
+              <a:t>voting</a:t>
+            </a:r>
+            <a:r>
+              <a:rPr lang="de-DE" dirty="0"/>
+              <a:t> </a:t>
+            </a:r>
+            <a:r>
+              <a:rPr lang="de-DE" dirty="0" err="1"/>
+              <a:t>classifiers</a:t>
+            </a:r>
+            <a:r>
+              <a:rPr lang="de-DE" dirty="0"/>
+              <a:t>, and </a:t>
+            </a:r>
+            <a:r>
+              <a:rPr lang="de-DE" dirty="0" err="1"/>
+              <a:t>decision</a:t>
+            </a:r>
+            <a:r>
+              <a:rPr lang="de-DE" dirty="0"/>
+              <a:t> </a:t>
+            </a:r>
+            <a:r>
+              <a:rPr lang="de-DE" dirty="0" err="1"/>
+              <a:t>trees</a:t>
+            </a:r>
+            <a:r>
+              <a:rPr lang="de-DE" dirty="0"/>
+              <a:t>.</a:t>
+            </a:r>
             <a:endParaRPr dirty="0"/>
           </a:p>
           <a:p>
@@ -17402,6 +17842,66 @@
               <a:buSzPts val="1000"/>
               <a:buChar char="●"/>
             </a:pPr>
+            <a:r>
+              <a:rPr lang="de-DE" dirty="0"/>
+              <a:t>Catch </a:t>
+            </a:r>
+            <a:r>
+              <a:rPr lang="de-DE" dirty="0" err="1"/>
+              <a:t>up</a:t>
+            </a:r>
+            <a:r>
+              <a:rPr lang="de-DE" dirty="0"/>
+              <a:t> </a:t>
+            </a:r>
+            <a:r>
+              <a:rPr lang="de-DE" dirty="0" err="1"/>
+              <a:t>with</a:t>
+            </a:r>
+            <a:r>
+              <a:rPr lang="de-DE" dirty="0"/>
+              <a:t> </a:t>
+            </a:r>
+            <a:r>
+              <a:rPr lang="de-DE" dirty="0" err="1"/>
+              <a:t>the</a:t>
+            </a:r>
+            <a:r>
+              <a:rPr lang="de-DE" dirty="0"/>
+              <a:t> </a:t>
+            </a:r>
+            <a:r>
+              <a:rPr lang="de-DE" dirty="0" err="1"/>
+              <a:t>work</a:t>
+            </a:r>
+            <a:r>
+              <a:rPr lang="de-DE" dirty="0"/>
+              <a:t> I </a:t>
+            </a:r>
+            <a:r>
+              <a:rPr lang="de-DE" dirty="0" err="1"/>
+              <a:t>missed</a:t>
+            </a:r>
+            <a:r>
+              <a:rPr lang="de-DE" dirty="0"/>
+              <a:t> </a:t>
+            </a:r>
+            <a:r>
+              <a:rPr lang="de-DE" dirty="0" err="1"/>
+              <a:t>this</a:t>
+            </a:r>
+            <a:r>
+              <a:rPr lang="de-DE" dirty="0"/>
+              <a:t> </a:t>
+            </a:r>
+            <a:r>
+              <a:rPr lang="de-DE" dirty="0" err="1"/>
+              <a:t>week</a:t>
+            </a:r>
+            <a:r>
+              <a:rPr lang="de-DE"/>
+              <a:t>.</a:t>
+            </a:r>
             <a:endParaRPr dirty="0"/>
           </a:p>
         </p:txBody>
@@ -17692,14 +18192,14 @@
               <a:buChar char="●"/>
             </a:pPr>
             <a:r>
-              <a:rPr lang="en" b="1"/>
-              <a:t>[Reviewer]</a:t>
-            </a:r>
-            <a:r>
-              <a:rPr lang="en"/>
-              <a:t> Feedback</a:t>
-            </a:r>
-            <a:endParaRPr/>
+              <a:rPr lang="en" b="1" dirty="0"/>
+              <a:t>Mentor </a:t>
+            </a:r>
+            <a:r>
+              <a:rPr lang="en" dirty="0"/>
+              <a:t>The WorkLog had some problems, such as not having any evidence, having too little feedback/reflection, and not having filled in the “Task” column. The Learning Log had too few sentences in the “What did you do?” and “Reflection” parts and I should re-write some of them. In terms of programming, I am a bit behind the planning.</a:t>
+            </a:r>
+            <a:endParaRPr dirty="0"/>
           </a:p>
           <a:p>
             <a:pPr marL="0" lvl="0" indent="0" algn="l" rtl="0">
@@ -17712,10 +18212,26 @@
               <a:buNone/>
             </a:pPr>
             <a:r>
-              <a:rPr lang="en"/>
-              <a:t>Response</a:t>
-            </a:r>
-            <a:endParaRPr/>
+              <a:rPr lang="en" dirty="0"/>
+              <a:t>Most of the feedback is fair. The WorkLog evidence I have not done but I really should do, and at the moment I am planning to do that during the vacation, and the reflections have to be re-written too in the vacation. The “Task” part I only learned t</a:t>
+            </a:r>
+            <a:r>
+              <a:rPr lang="nl-NL" dirty="0"/>
+              <a:t>ha</a:t>
+            </a:r>
+            <a:r>
+              <a:rPr lang="en" dirty="0"/>
+              <a:t>t day so I did not ha</a:t>
+            </a:r>
+            <a:r>
+              <a:rPr lang="nl-NL" dirty="0" err="1"/>
+              <a:t>ve</a:t>
+            </a:r>
+            <a:r>
+              <a:rPr lang="en" dirty="0"/>
+              <a:t> the time to do it. The Learning Log feedback is the same as the previous time and I tried to address it, but apparently I did not too a good enough job. I knew that I was a bit behind as I was a bit sick this week.</a:t>
+            </a:r>
+            <a:endParaRPr dirty="0"/>
           </a:p>
         </p:txBody>
       </p:sp>
@@ -41624,15 +42140,6 @@
 </file>
 
 <file path=customXml/item1.xml><?xml version="1.0" encoding="utf-8"?>
-<?mso-contentType ?>
-<FormTemplates xmlns="http://schemas.microsoft.com/sharepoint/v3/contenttype/forms">
-  <Display>DocumentLibraryForm</Display>
-  <Edit>DocumentLibraryForm</Edit>
-  <New>DocumentLibraryForm</New>
-</FormTemplates>
-</file>
-
-<file path=customXml/item2.xml><?xml version="1.0" encoding="utf-8"?>
 <ct:contentTypeSchema xmlns:ct="http://schemas.microsoft.com/office/2006/metadata/contentType" xmlns:ma="http://schemas.microsoft.com/office/2006/metadata/properties/metaAttributes" ct:_="" ma:_="" ma:contentTypeName="Document" ma:contentTypeID="0x0101000BADAD4AA324BF48804EF76FD903323C" ma:contentTypeVersion="15" ma:contentTypeDescription="Create a new document." ma:contentTypeScope="" ma:versionID="4ea0feda506421460444ca95554a0aab">
   <xsd:schema xmlns:xsd="http://www.w3.org/2001/XMLSchema" xmlns:xs="http://www.w3.org/2001/XMLSchema" xmlns:p="http://schemas.microsoft.com/office/2006/metadata/properties" xmlns:ns2="5ff92c65-ed86-4457-baee-ccd535c9ea21" xmlns:ns3="6c8d291c-a5bf-4049-930d-38db8e991d8e" targetNamespace="http://schemas.microsoft.com/office/2006/metadata/properties" ma:root="true" ma:fieldsID="0fc8cf7d0f5ee312899395875a30595e" ns2:_="" ns3:_="">
     <xsd:import namespace="5ff92c65-ed86-4457-baee-ccd535c9ea21"/>
@@ -41867,7 +42374,7 @@
 </ct:contentTypeSchema>
 </file>
 
-<file path=customXml/item3.xml><?xml version="1.0" encoding="utf-8"?>
+<file path=customXml/item2.xml><?xml version="1.0" encoding="utf-8"?>
 <p:properties xmlns:p="http://schemas.microsoft.com/office/2006/metadata/properties" xmlns:xsi="http://www.w3.org/2001/XMLSchema-instance" xmlns:pc="http://schemas.microsoft.com/office/infopath/2007/PartnerControls">
   <documentManagement>
     <SharedWithUsers xmlns="6c8d291c-a5bf-4049-930d-38db8e991d8e">
@@ -41885,15 +42392,16 @@
 </p:properties>
 </file>
 
-<file path=customXml/itemProps1.xml><?xml version="1.0" encoding="utf-8"?>
-<ds:datastoreItem xmlns:ds="http://schemas.openxmlformats.org/officeDocument/2006/customXml" ds:itemID="{98D9791E-52D0-4ABB-925A-4EAECF798D9B}">
-  <ds:schemaRefs>
-    <ds:schemaRef ds:uri="http://schemas.microsoft.com/sharepoint/v3/contenttype/forms"/>
-  </ds:schemaRefs>
-</ds:datastoreItem>
+<file path=customXml/item3.xml><?xml version="1.0" encoding="utf-8"?>
+<?mso-contentType ?>
+<FormTemplates xmlns="http://schemas.microsoft.com/sharepoint/v3/contenttype/forms">
+  <Display>DocumentLibraryForm</Display>
+  <Edit>DocumentLibraryForm</Edit>
+  <New>DocumentLibraryForm</New>
+</FormTemplates>
 </file>
 
-<file path=customXml/itemProps2.xml><?xml version="1.0" encoding="utf-8"?>
+<file path=customXml/itemProps1.xml><?xml version="1.0" encoding="utf-8"?>
 <ds:datastoreItem xmlns:ds="http://schemas.openxmlformats.org/officeDocument/2006/customXml" ds:itemID="{AA562638-1947-4789-9FBF-F833DB2C18A8}">
   <ds:schemaRefs>
     <ds:schemaRef ds:uri="5ff92c65-ed86-4457-baee-ccd535c9ea21"/>
@@ -41912,7 +42420,7 @@
 </ds:datastoreItem>
 </file>
 
-<file path=customXml/itemProps3.xml><?xml version="1.0" encoding="utf-8"?>
+<file path=customXml/itemProps2.xml><?xml version="1.0" encoding="utf-8"?>
 <ds:datastoreItem xmlns:ds="http://schemas.openxmlformats.org/officeDocument/2006/customXml" ds:itemID="{3067B86F-F5BB-4BE6-9A37-0E19E53CB68B}">
   <ds:schemaRefs>
     <ds:schemaRef ds:uri="5ff92c65-ed86-4457-baee-ccd535c9ea21"/>
@@ -41927,4 +42435,12 @@
     <ds:schemaRef ds:uri="http://www.w3.org/XML/1998/namespace"/>
   </ds:schemaRefs>
 </ds:datastoreItem>
+</file>
+
+<file path=customXml/itemProps3.xml><?xml version="1.0" encoding="utf-8"?>
+<ds:datastoreItem xmlns:ds="http://schemas.openxmlformats.org/officeDocument/2006/customXml" ds:itemID="{98D9791E-52D0-4ABB-925A-4EAECF798D9B}">
+  <ds:schemaRefs>
+    <ds:schemaRef ds:uri="http://schemas.microsoft.com/sharepoint/v3/contenttype/forms"/>
+  </ds:schemaRefs>
+</ds:datastoreItem>
 </file>
</xml_diff>

<commit_message>
W5 DataLab 2 Work I
</commit_message>
<xml_diff>
--- a/Deliverables/Learning Log - Y1B-2024-25_ADSAI.pptx
+++ b/Deliverables/Learning Log - Y1B-2024-25_ADSAI.pptx
@@ -42140,6 +42140,33 @@
 </file>
 
 <file path=customXml/item1.xml><?xml version="1.0" encoding="utf-8"?>
+<p:properties xmlns:p="http://schemas.microsoft.com/office/2006/metadata/properties" xmlns:xsi="http://www.w3.org/2001/XMLSchema-instance" xmlns:pc="http://schemas.microsoft.com/office/infopath/2007/PartnerControls">
+  <documentManagement>
+    <SharedWithUsers xmlns="6c8d291c-a5bf-4049-930d-38db8e991d8e">
+      <UserInfo>
+        <DisplayName/>
+        <AccountId xsi:nil="true"/>
+        <AccountType/>
+      </UserInfo>
+    </SharedWithUsers>
+    <TaxCatchAll xmlns="6c8d291c-a5bf-4049-930d-38db8e991d8e" xsi:nil="true"/>
+    <lcf76f155ced4ddcb4097134ff3c332f xmlns="5ff92c65-ed86-4457-baee-ccd535c9ea21">
+      <Terms xmlns="http://schemas.microsoft.com/office/infopath/2007/PartnerControls"/>
+    </lcf76f155ced4ddcb4097134ff3c332f>
+  </documentManagement>
+</p:properties>
+</file>
+
+<file path=customXml/item2.xml><?xml version="1.0" encoding="utf-8"?>
+<?mso-contentType ?>
+<FormTemplates xmlns="http://schemas.microsoft.com/sharepoint/v3/contenttype/forms">
+  <Display>DocumentLibraryForm</Display>
+  <Edit>DocumentLibraryForm</Edit>
+  <New>DocumentLibraryForm</New>
+</FormTemplates>
+</file>
+
+<file path=customXml/item3.xml><?xml version="1.0" encoding="utf-8"?>
 <ct:contentTypeSchema xmlns:ct="http://schemas.microsoft.com/office/2006/metadata/contentType" xmlns:ma="http://schemas.microsoft.com/office/2006/metadata/properties/metaAttributes" ct:_="" ma:_="" ma:contentTypeName="Document" ma:contentTypeID="0x0101000BADAD4AA324BF48804EF76FD903323C" ma:contentTypeVersion="15" ma:contentTypeDescription="Create a new document." ma:contentTypeScope="" ma:versionID="4ea0feda506421460444ca95554a0aab">
   <xsd:schema xmlns:xsd="http://www.w3.org/2001/XMLSchema" xmlns:xs="http://www.w3.org/2001/XMLSchema" xmlns:p="http://schemas.microsoft.com/office/2006/metadata/properties" xmlns:ns2="5ff92c65-ed86-4457-baee-ccd535c9ea21" xmlns:ns3="6c8d291c-a5bf-4049-930d-38db8e991d8e" targetNamespace="http://schemas.microsoft.com/office/2006/metadata/properties" ma:root="true" ma:fieldsID="0fc8cf7d0f5ee312899395875a30595e" ns2:_="" ns3:_="">
     <xsd:import namespace="5ff92c65-ed86-4457-baee-ccd535c9ea21"/>
@@ -42374,34 +42401,32 @@
 </ct:contentTypeSchema>
 </file>
 
-<file path=customXml/item2.xml><?xml version="1.0" encoding="utf-8"?>
-<p:properties xmlns:p="http://schemas.microsoft.com/office/2006/metadata/properties" xmlns:xsi="http://www.w3.org/2001/XMLSchema-instance" xmlns:pc="http://schemas.microsoft.com/office/infopath/2007/PartnerControls">
-  <documentManagement>
-    <SharedWithUsers xmlns="6c8d291c-a5bf-4049-930d-38db8e991d8e">
-      <UserInfo>
-        <DisplayName/>
-        <AccountId xsi:nil="true"/>
-        <AccountType/>
-      </UserInfo>
-    </SharedWithUsers>
-    <TaxCatchAll xmlns="6c8d291c-a5bf-4049-930d-38db8e991d8e" xsi:nil="true"/>
-    <lcf76f155ced4ddcb4097134ff3c332f xmlns="5ff92c65-ed86-4457-baee-ccd535c9ea21">
-      <Terms xmlns="http://schemas.microsoft.com/office/infopath/2007/PartnerControls"/>
-    </lcf76f155ced4ddcb4097134ff3c332f>
-  </documentManagement>
-</p:properties>
+<file path=customXml/itemProps1.xml><?xml version="1.0" encoding="utf-8"?>
+<ds:datastoreItem xmlns:ds="http://schemas.openxmlformats.org/officeDocument/2006/customXml" ds:itemID="{3067B86F-F5BB-4BE6-9A37-0E19E53CB68B}">
+  <ds:schemaRefs>
+    <ds:schemaRef ds:uri="5ff92c65-ed86-4457-baee-ccd535c9ea21"/>
+    <ds:schemaRef ds:uri="6c8d291c-a5bf-4049-930d-38db8e991d8e"/>
+    <ds:schemaRef ds:uri="http://purl.org/dc/dcmitype/"/>
+    <ds:schemaRef ds:uri="http://purl.org/dc/elements/1.1/"/>
+    <ds:schemaRef ds:uri="http://purl.org/dc/terms/"/>
+    <ds:schemaRef ds:uri="http://schemas.microsoft.com/office/2006/documentManagement/types"/>
+    <ds:schemaRef ds:uri="http://schemas.microsoft.com/office/2006/metadata/properties"/>
+    <ds:schemaRef ds:uri="http://schemas.microsoft.com/office/infopath/2007/PartnerControls"/>
+    <ds:schemaRef ds:uri="http://schemas.openxmlformats.org/package/2006/metadata/core-properties"/>
+    <ds:schemaRef ds:uri="http://www.w3.org/XML/1998/namespace"/>
+  </ds:schemaRefs>
+</ds:datastoreItem>
 </file>
 
-<file path=customXml/item3.xml><?xml version="1.0" encoding="utf-8"?>
-<?mso-contentType ?>
-<FormTemplates xmlns="http://schemas.microsoft.com/sharepoint/v3/contenttype/forms">
-  <Display>DocumentLibraryForm</Display>
-  <Edit>DocumentLibraryForm</Edit>
-  <New>DocumentLibraryForm</New>
-</FormTemplates>
+<file path=customXml/itemProps2.xml><?xml version="1.0" encoding="utf-8"?>
+<ds:datastoreItem xmlns:ds="http://schemas.openxmlformats.org/officeDocument/2006/customXml" ds:itemID="{98D9791E-52D0-4ABB-925A-4EAECF798D9B}">
+  <ds:schemaRefs>
+    <ds:schemaRef ds:uri="http://schemas.microsoft.com/sharepoint/v3/contenttype/forms"/>
+  </ds:schemaRefs>
+</ds:datastoreItem>
 </file>
 
-<file path=customXml/itemProps1.xml><?xml version="1.0" encoding="utf-8"?>
+<file path=customXml/itemProps3.xml><?xml version="1.0" encoding="utf-8"?>
 <ds:datastoreItem xmlns:ds="http://schemas.openxmlformats.org/officeDocument/2006/customXml" ds:itemID="{AA562638-1947-4789-9FBF-F833DB2C18A8}">
   <ds:schemaRefs>
     <ds:schemaRef ds:uri="5ff92c65-ed86-4457-baee-ccd535c9ea21"/>
@@ -42418,29 +42443,4 @@
     <ds:schemaRef ds:uri="http://www.w3.org/2001/XMLSchema"/>
   </ds:schemaRefs>
 </ds:datastoreItem>
-</file>
-
-<file path=customXml/itemProps2.xml><?xml version="1.0" encoding="utf-8"?>
-<ds:datastoreItem xmlns:ds="http://schemas.openxmlformats.org/officeDocument/2006/customXml" ds:itemID="{3067B86F-F5BB-4BE6-9A37-0E19E53CB68B}">
-  <ds:schemaRefs>
-    <ds:schemaRef ds:uri="5ff92c65-ed86-4457-baee-ccd535c9ea21"/>
-    <ds:schemaRef ds:uri="6c8d291c-a5bf-4049-930d-38db8e991d8e"/>
-    <ds:schemaRef ds:uri="http://purl.org/dc/dcmitype/"/>
-    <ds:schemaRef ds:uri="http://purl.org/dc/elements/1.1/"/>
-    <ds:schemaRef ds:uri="http://purl.org/dc/terms/"/>
-    <ds:schemaRef ds:uri="http://schemas.microsoft.com/office/2006/documentManagement/types"/>
-    <ds:schemaRef ds:uri="http://schemas.microsoft.com/office/2006/metadata/properties"/>
-    <ds:schemaRef ds:uri="http://schemas.microsoft.com/office/infopath/2007/PartnerControls"/>
-    <ds:schemaRef ds:uri="http://schemas.openxmlformats.org/package/2006/metadata/core-properties"/>
-    <ds:schemaRef ds:uri="http://www.w3.org/XML/1998/namespace"/>
-  </ds:schemaRefs>
-</ds:datastoreItem>
-</file>
-
-<file path=customXml/itemProps3.xml><?xml version="1.0" encoding="utf-8"?>
-<ds:datastoreItem xmlns:ds="http://schemas.openxmlformats.org/officeDocument/2006/customXml" ds:itemID="{98D9791E-52D0-4ABB-925A-4EAECF798D9B}">
-  <ds:schemaRefs>
-    <ds:schemaRef ds:uri="http://schemas.microsoft.com/sharepoint/v3/contenttype/forms"/>
-  </ds:schemaRefs>
-</ds:datastoreItem>
 </file>
</xml_diff>

<commit_message>
Week 7 start & organizing
</commit_message>
<xml_diff>
--- a/Deliverables/Learning Log - Y1B-2024-25_ADSAI.pptx
+++ b/Deliverables/Learning Log - Y1B-2024-25_ADSAI.pptx
@@ -19585,10 +19585,9 @@
               <a:buChar char="●"/>
             </a:pPr>
             <a:r>
-              <a:rPr lang="en"/>
+              <a:rPr lang="en" b="1" dirty="0"/>
               <a:t>What goal(s) did you set for this week?</a:t>
             </a:r>
-            <a:endParaRPr/>
           </a:p>
           <a:p>
             <a:pPr marL="182880" lvl="0" indent="-154940" algn="l" rtl="0">
@@ -19602,10 +19601,146 @@
               <a:buChar char="●"/>
             </a:pPr>
             <a:r>
-              <a:rPr lang="en"/>
-              <a:t>What have you actually been able to do? </a:t>
-            </a:r>
-            <a:endParaRPr/>
+              <a:rPr lang="de-DE" dirty="0"/>
+              <a:t>My </a:t>
+            </a:r>
+            <a:r>
+              <a:rPr lang="de-DE" dirty="0" err="1"/>
+              <a:t>goal</a:t>
+            </a:r>
+            <a:r>
+              <a:rPr lang="de-DE" dirty="0"/>
+              <a:t> </a:t>
+            </a:r>
+            <a:r>
+              <a:rPr lang="de-DE" dirty="0" err="1"/>
+              <a:t>this</a:t>
+            </a:r>
+            <a:r>
+              <a:rPr lang="de-DE" dirty="0"/>
+              <a:t> </a:t>
+            </a:r>
+            <a:r>
+              <a:rPr lang="de-DE" dirty="0" err="1"/>
+              <a:t>week</a:t>
+            </a:r>
+            <a:r>
+              <a:rPr lang="de-DE" dirty="0"/>
+              <a:t> </a:t>
+            </a:r>
+            <a:r>
+              <a:rPr lang="de-DE" dirty="0" err="1"/>
+              <a:t>is</a:t>
+            </a:r>
+            <a:r>
+              <a:rPr lang="de-DE" dirty="0"/>
+              <a:t> </a:t>
+            </a:r>
+            <a:r>
+              <a:rPr lang="de-DE" dirty="0" err="1"/>
+              <a:t>to</a:t>
+            </a:r>
+            <a:r>
+              <a:rPr lang="de-DE" dirty="0"/>
+              <a:t> finish </a:t>
+            </a:r>
+            <a:r>
+              <a:rPr lang="de-DE" dirty="0" err="1"/>
+              <a:t>working</a:t>
+            </a:r>
+            <a:r>
+              <a:rPr lang="de-DE" dirty="0"/>
+              <a:t> on </a:t>
+            </a:r>
+            <a:r>
+              <a:rPr lang="de-DE" dirty="0" err="1"/>
+              <a:t>the</a:t>
+            </a:r>
+            <a:r>
+              <a:rPr lang="de-DE" dirty="0"/>
+              <a:t> </a:t>
+            </a:r>
+            <a:r>
+              <a:rPr lang="de-DE" dirty="0" err="1"/>
+              <a:t>backlog</a:t>
+            </a:r>
+            <a:r>
+              <a:rPr lang="de-DE" dirty="0"/>
+              <a:t> </a:t>
+            </a:r>
+            <a:r>
+              <a:rPr lang="de-DE" dirty="0" err="1"/>
+              <a:t>of</a:t>
+            </a:r>
+            <a:r>
+              <a:rPr lang="de-DE" dirty="0"/>
+              <a:t> </a:t>
+            </a:r>
+            <a:r>
+              <a:rPr lang="de-DE" dirty="0" err="1"/>
+              <a:t>tasks</a:t>
+            </a:r>
+            <a:r>
+              <a:rPr lang="de-DE" dirty="0"/>
+              <a:t> </a:t>
+            </a:r>
+            <a:r>
+              <a:rPr lang="de-DE" dirty="0" err="1"/>
+              <a:t>from</a:t>
+            </a:r>
+            <a:r>
+              <a:rPr lang="de-DE" dirty="0"/>
+              <a:t> </a:t>
+            </a:r>
+            <a:r>
+              <a:rPr lang="de-DE" dirty="0" err="1"/>
+              <a:t>previous</a:t>
+            </a:r>
+            <a:r>
+              <a:rPr lang="de-DE" dirty="0"/>
+              <a:t> </a:t>
+            </a:r>
+            <a:r>
+              <a:rPr lang="de-DE" dirty="0" err="1"/>
+              <a:t>weeks</a:t>
+            </a:r>
+            <a:r>
+              <a:rPr lang="de-DE" dirty="0"/>
+              <a:t> </a:t>
+            </a:r>
+            <a:r>
+              <a:rPr lang="de-DE" dirty="0" err="1"/>
+              <a:t>that</a:t>
+            </a:r>
+            <a:r>
+              <a:rPr lang="de-DE" dirty="0"/>
+              <a:t> I </a:t>
+            </a:r>
+            <a:r>
+              <a:rPr lang="de-DE" dirty="0" err="1"/>
+              <a:t>began</a:t>
+            </a:r>
+            <a:r>
+              <a:rPr lang="de-DE" dirty="0"/>
+              <a:t> </a:t>
+            </a:r>
+            <a:r>
+              <a:rPr lang="de-DE" dirty="0" err="1"/>
+              <a:t>doing</a:t>
+            </a:r>
+            <a:r>
+              <a:rPr lang="de-DE" dirty="0"/>
+              <a:t> in </a:t>
+            </a:r>
+            <a:r>
+              <a:rPr lang="de-DE" dirty="0" err="1"/>
+              <a:t>week</a:t>
+            </a:r>
+            <a:r>
+              <a:rPr lang="de-DE"/>
+              <a:t> 5.</a:t>
+            </a:r>
+            <a:endParaRPr dirty="0"/>
           </a:p>
           <a:p>
             <a:pPr marL="182880" lvl="0" indent="-154940" algn="l" rtl="0">
@@ -19619,10 +19754,51 @@
               <a:buChar char="●"/>
             </a:pPr>
             <a:r>
-              <a:rPr lang="en"/>
+              <a:rPr lang="en" b="1" dirty="0"/>
+              <a:t>What have you actually been able to do? </a:t>
+            </a:r>
+          </a:p>
+          <a:p>
+            <a:pPr marL="182880" lvl="0" indent="-154940" algn="l" rtl="0">
+              <a:spcBef>
+                <a:spcPts val="0"/>
+              </a:spcBef>
+              <a:spcAft>
+                <a:spcPts val="0"/>
+              </a:spcAft>
+              <a:buSzPts val="1000"/>
+              <a:buChar char="●"/>
+            </a:pPr>
+            <a:endParaRPr dirty="0"/>
+          </a:p>
+          <a:p>
+            <a:pPr marL="182880" lvl="0" indent="-154940" algn="l" rtl="0">
+              <a:spcBef>
+                <a:spcPts val="0"/>
+              </a:spcBef>
+              <a:spcAft>
+                <a:spcPts val="0"/>
+              </a:spcAft>
+              <a:buSzPts val="1000"/>
+              <a:buChar char="●"/>
+            </a:pPr>
+            <a:r>
+              <a:rPr lang="en" b="1" dirty="0"/>
               <a:t>Showcase the evidence of your progress (production artifacts, short descriptions-links-pictures animated gifs, etc.)</a:t>
             </a:r>
-            <a:endParaRPr/>
+          </a:p>
+          <a:p>
+            <a:pPr marL="182880" lvl="0" indent="-154940" algn="l" rtl="0">
+              <a:spcBef>
+                <a:spcPts val="0"/>
+              </a:spcBef>
+              <a:spcAft>
+                <a:spcPts val="0"/>
+              </a:spcAft>
+              <a:buSzPts val="1000"/>
+              <a:buChar char="●"/>
+            </a:pPr>
+            <a:endParaRPr dirty="0"/>
           </a:p>
         </p:txBody>
       </p:sp>
@@ -19662,10 +19838,9 @@
               <a:buChar char="●"/>
             </a:pPr>
             <a:r>
-              <a:rPr lang="en"/>
+              <a:rPr lang="en" b="1" dirty="0"/>
               <a:t>How did the week go? </a:t>
             </a:r>
-            <a:endParaRPr/>
           </a:p>
           <a:p>
             <a:pPr marL="182880" lvl="0" indent="-154940" algn="l" rtl="0">
@@ -19678,11 +19853,7 @@
               <a:buSzPts val="1000"/>
               <a:buChar char="●"/>
             </a:pPr>
-            <a:r>
-              <a:rPr lang="en"/>
-              <a:t>What went well? </a:t>
-            </a:r>
-            <a:endParaRPr/>
+            <a:endParaRPr dirty="0"/>
           </a:p>
           <a:p>
             <a:pPr marL="182880" lvl="0" indent="-154940" algn="l" rtl="0">
@@ -19696,10 +19867,9 @@
               <a:buChar char="●"/>
             </a:pPr>
             <a:r>
-              <a:rPr lang="en"/>
-              <a:t>What didn’t go so well? </a:t>
-            </a:r>
-            <a:endParaRPr/>
+              <a:rPr lang="en" b="1" dirty="0"/>
+              <a:t>What went well? </a:t>
+            </a:r>
           </a:p>
           <a:p>
             <a:pPr marL="182880" lvl="0" indent="-154940" algn="l" rtl="0">
@@ -19712,11 +19882,7 @@
               <a:buSzPts val="1000"/>
               <a:buChar char="●"/>
             </a:pPr>
-            <a:r>
-              <a:rPr lang="en"/>
-              <a:t>What did you learn? </a:t>
-            </a:r>
-            <a:endParaRPr/>
+            <a:endParaRPr dirty="0"/>
           </a:p>
           <a:p>
             <a:pPr marL="182880" lvl="0" indent="-154940" algn="l" rtl="0">
@@ -19730,10 +19896,80 @@
               <a:buChar char="●"/>
             </a:pPr>
             <a:r>
-              <a:rPr lang="en"/>
+              <a:rPr lang="en" b="1" dirty="0"/>
+              <a:t>What didn’t go so well? </a:t>
+            </a:r>
+          </a:p>
+          <a:p>
+            <a:pPr marL="182880" lvl="0" indent="-154940" algn="l" rtl="0">
+              <a:spcBef>
+                <a:spcPts val="0"/>
+              </a:spcBef>
+              <a:spcAft>
+                <a:spcPts val="0"/>
+              </a:spcAft>
+              <a:buSzPts val="1000"/>
+              <a:buChar char="●"/>
+            </a:pPr>
+            <a:endParaRPr dirty="0"/>
+          </a:p>
+          <a:p>
+            <a:pPr marL="182880" lvl="0" indent="-154940" algn="l" rtl="0">
+              <a:spcBef>
+                <a:spcPts val="0"/>
+              </a:spcBef>
+              <a:spcAft>
+                <a:spcPts val="0"/>
+              </a:spcAft>
+              <a:buSzPts val="1000"/>
+              <a:buChar char="●"/>
+            </a:pPr>
+            <a:r>
+              <a:rPr lang="en" b="1" dirty="0"/>
+              <a:t>What did you learn? </a:t>
+            </a:r>
+          </a:p>
+          <a:p>
+            <a:pPr marL="182880" lvl="0" indent="-154940" algn="l" rtl="0">
+              <a:spcBef>
+                <a:spcPts val="0"/>
+              </a:spcBef>
+              <a:spcAft>
+                <a:spcPts val="0"/>
+              </a:spcAft>
+              <a:buSzPts val="1000"/>
+              <a:buChar char="●"/>
+            </a:pPr>
+            <a:endParaRPr dirty="0"/>
+          </a:p>
+          <a:p>
+            <a:pPr marL="182880" lvl="0" indent="-154940" algn="l" rtl="0">
+              <a:spcBef>
+                <a:spcPts val="0"/>
+              </a:spcBef>
+              <a:spcAft>
+                <a:spcPts val="0"/>
+              </a:spcAft>
+              <a:buSzPts val="1000"/>
+              <a:buChar char="●"/>
+            </a:pPr>
+            <a:r>
+              <a:rPr lang="en" b="1" dirty="0"/>
               <a:t>What could be added as an Action point looking forward to next week?</a:t>
             </a:r>
-            <a:endParaRPr/>
+          </a:p>
+          <a:p>
+            <a:pPr marL="182880" lvl="0" indent="-154940" algn="l" rtl="0">
+              <a:spcBef>
+                <a:spcPts val="0"/>
+              </a:spcBef>
+              <a:spcAft>
+                <a:spcPts val="0"/>
+              </a:spcAft>
+              <a:buSzPts val="1000"/>
+              <a:buChar char="●"/>
+            </a:pPr>
+            <a:endParaRPr dirty="0"/>
           </a:p>
         </p:txBody>
       </p:sp>
@@ -20644,10 +20880,9 @@
               <a:buChar char="●"/>
             </a:pPr>
             <a:r>
-              <a:rPr lang="en"/>
+              <a:rPr lang="en" b="1" dirty="0"/>
               <a:t>What goal(s) did you set for this week?</a:t>
             </a:r>
-            <a:endParaRPr/>
           </a:p>
           <a:p>
             <a:pPr marL="182880" lvl="0" indent="-154940" algn="l" rtl="0">
@@ -20661,10 +20896,82 @@
               <a:buChar char="●"/>
             </a:pPr>
             <a:r>
-              <a:rPr lang="en"/>
-              <a:t>What have you actually been able to do? </a:t>
-            </a:r>
-            <a:endParaRPr/>
+              <a:rPr lang="de-DE" dirty="0"/>
+              <a:t>I </a:t>
+            </a:r>
+            <a:r>
+              <a:rPr lang="de-DE" dirty="0" err="1"/>
+              <a:t>need</a:t>
+            </a:r>
+            <a:r>
+              <a:rPr lang="de-DE" dirty="0"/>
+              <a:t> </a:t>
+            </a:r>
+            <a:r>
+              <a:rPr lang="de-DE" dirty="0" err="1"/>
+              <a:t>to</a:t>
+            </a:r>
+            <a:r>
+              <a:rPr lang="de-DE" dirty="0"/>
+              <a:t> catch </a:t>
+            </a:r>
+            <a:r>
+              <a:rPr lang="de-DE" dirty="0" err="1"/>
+              <a:t>up</a:t>
+            </a:r>
+            <a:r>
+              <a:rPr lang="de-DE" dirty="0"/>
+              <a:t> on </a:t>
+            </a:r>
+            <a:r>
+              <a:rPr lang="de-DE" dirty="0" err="1"/>
+              <a:t>work</a:t>
+            </a:r>
+            <a:r>
+              <a:rPr lang="de-DE" dirty="0"/>
+              <a:t> </a:t>
+            </a:r>
+            <a:r>
+              <a:rPr lang="de-DE" dirty="0" err="1"/>
+              <a:t>that</a:t>
+            </a:r>
+            <a:r>
+              <a:rPr lang="de-DE" dirty="0"/>
+              <a:t> I </a:t>
+            </a:r>
+            <a:r>
+              <a:rPr lang="de-DE" dirty="0" err="1"/>
+              <a:t>did</a:t>
+            </a:r>
+            <a:r>
+              <a:rPr lang="de-DE" dirty="0"/>
+              <a:t> not do last </a:t>
+            </a:r>
+            <a:r>
+              <a:rPr lang="de-DE" dirty="0" err="1"/>
+              <a:t>week</a:t>
+            </a:r>
+            <a:r>
+              <a:rPr lang="de-DE" dirty="0"/>
+              <a:t> due </a:t>
+            </a:r>
+            <a:r>
+              <a:rPr lang="de-DE" dirty="0" err="1"/>
+              <a:t>to</a:t>
+            </a:r>
+            <a:r>
+              <a:rPr lang="de-DE" dirty="0"/>
+              <a:t> </a:t>
+            </a:r>
+            <a:r>
+              <a:rPr lang="de-DE" dirty="0" err="1"/>
+              <a:t>sickness</a:t>
+            </a:r>
+            <a:r>
+              <a:rPr lang="de-DE" dirty="0"/>
+              <a:t>.</a:t>
+            </a:r>
+            <a:endParaRPr dirty="0"/>
           </a:p>
           <a:p>
             <a:pPr marL="182880" lvl="0" indent="-154940" algn="l" rtl="0">
@@ -20678,10 +20985,51 @@
               <a:buChar char="●"/>
             </a:pPr>
             <a:r>
-              <a:rPr lang="en"/>
+              <a:rPr lang="en" b="1" dirty="0"/>
+              <a:t>What have you actually been able to do? </a:t>
+            </a:r>
+          </a:p>
+          <a:p>
+            <a:pPr marL="182880" lvl="0" indent="-154940" algn="l" rtl="0">
+              <a:spcBef>
+                <a:spcPts val="0"/>
+              </a:spcBef>
+              <a:spcAft>
+                <a:spcPts val="0"/>
+              </a:spcAft>
+              <a:buSzPts val="1000"/>
+              <a:buChar char="●"/>
+            </a:pPr>
+            <a:endParaRPr dirty="0"/>
+          </a:p>
+          <a:p>
+            <a:pPr marL="182880" lvl="0" indent="-154940" algn="l" rtl="0">
+              <a:spcBef>
+                <a:spcPts val="0"/>
+              </a:spcBef>
+              <a:spcAft>
+                <a:spcPts val="0"/>
+              </a:spcAft>
+              <a:buSzPts val="1000"/>
+              <a:buChar char="●"/>
+            </a:pPr>
+            <a:r>
+              <a:rPr lang="en" b="1" dirty="0"/>
               <a:t>Showcase the evidence of your progress (production artifacts, short descriptions-links-pictures animated gifs, etc.)</a:t>
             </a:r>
-            <a:endParaRPr/>
+          </a:p>
+          <a:p>
+            <a:pPr marL="182880" lvl="0" indent="-154940" algn="l" rtl="0">
+              <a:spcBef>
+                <a:spcPts val="0"/>
+              </a:spcBef>
+              <a:spcAft>
+                <a:spcPts val="0"/>
+              </a:spcAft>
+              <a:buSzPts val="1000"/>
+              <a:buChar char="●"/>
+            </a:pPr>
+            <a:endParaRPr dirty="0"/>
           </a:p>
         </p:txBody>
       </p:sp>
@@ -20721,10 +21069,9 @@
               <a:buChar char="●"/>
             </a:pPr>
             <a:r>
-              <a:rPr lang="en"/>
+              <a:rPr lang="en" b="1" dirty="0"/>
               <a:t>How did the week go? </a:t>
             </a:r>
-            <a:endParaRPr/>
           </a:p>
           <a:p>
             <a:pPr marL="182880" lvl="0" indent="-154940" algn="l" rtl="0">
@@ -20737,11 +21084,7 @@
               <a:buSzPts val="1000"/>
               <a:buChar char="●"/>
             </a:pPr>
-            <a:r>
-              <a:rPr lang="en"/>
-              <a:t>What went well? </a:t>
-            </a:r>
-            <a:endParaRPr/>
+            <a:endParaRPr dirty="0"/>
           </a:p>
           <a:p>
             <a:pPr marL="182880" lvl="0" indent="-154940" algn="l" rtl="0">
@@ -20755,10 +21098,9 @@
               <a:buChar char="●"/>
             </a:pPr>
             <a:r>
-              <a:rPr lang="en"/>
-              <a:t>What didn’t go so well? </a:t>
-            </a:r>
-            <a:endParaRPr/>
+              <a:rPr lang="en" b="1" dirty="0"/>
+              <a:t>What went well? </a:t>
+            </a:r>
           </a:p>
           <a:p>
             <a:pPr marL="182880" lvl="0" indent="-154940" algn="l" rtl="0">
@@ -20771,11 +21113,7 @@
               <a:buSzPts val="1000"/>
               <a:buChar char="●"/>
             </a:pPr>
-            <a:r>
-              <a:rPr lang="en"/>
-              <a:t>What did you learn? </a:t>
-            </a:r>
-            <a:endParaRPr/>
+            <a:endParaRPr dirty="0"/>
           </a:p>
           <a:p>
             <a:pPr marL="182880" lvl="0" indent="-154940" algn="l" rtl="0">
@@ -20789,10 +21127,80 @@
               <a:buChar char="●"/>
             </a:pPr>
             <a:r>
-              <a:rPr lang="en"/>
+              <a:rPr lang="en" b="1" dirty="0"/>
+              <a:t>What didn’t go so well? </a:t>
+            </a:r>
+          </a:p>
+          <a:p>
+            <a:pPr marL="182880" lvl="0" indent="-154940" algn="l" rtl="0">
+              <a:spcBef>
+                <a:spcPts val="0"/>
+              </a:spcBef>
+              <a:spcAft>
+                <a:spcPts val="0"/>
+              </a:spcAft>
+              <a:buSzPts val="1000"/>
+              <a:buChar char="●"/>
+            </a:pPr>
+            <a:endParaRPr dirty="0"/>
+          </a:p>
+          <a:p>
+            <a:pPr marL="182880" lvl="0" indent="-154940" algn="l" rtl="0">
+              <a:spcBef>
+                <a:spcPts val="0"/>
+              </a:spcBef>
+              <a:spcAft>
+                <a:spcPts val="0"/>
+              </a:spcAft>
+              <a:buSzPts val="1000"/>
+              <a:buChar char="●"/>
+            </a:pPr>
+            <a:r>
+              <a:rPr lang="en" b="1" dirty="0"/>
+              <a:t>What did you learn? </a:t>
+            </a:r>
+          </a:p>
+          <a:p>
+            <a:pPr marL="182880" lvl="0" indent="-154940" algn="l" rtl="0">
+              <a:spcBef>
+                <a:spcPts val="0"/>
+              </a:spcBef>
+              <a:spcAft>
+                <a:spcPts val="0"/>
+              </a:spcAft>
+              <a:buSzPts val="1000"/>
+              <a:buChar char="●"/>
+            </a:pPr>
+            <a:endParaRPr dirty="0"/>
+          </a:p>
+          <a:p>
+            <a:pPr marL="182880" lvl="0" indent="-154940" algn="l" rtl="0">
+              <a:spcBef>
+                <a:spcPts val="0"/>
+              </a:spcBef>
+              <a:spcAft>
+                <a:spcPts val="0"/>
+              </a:spcAft>
+              <a:buSzPts val="1000"/>
+              <a:buChar char="●"/>
+            </a:pPr>
+            <a:r>
+              <a:rPr lang="en" b="1" dirty="0"/>
               <a:t>What could be added as an Action point looking forward to next week?</a:t>
             </a:r>
-            <a:endParaRPr/>
+          </a:p>
+          <a:p>
+            <a:pPr marL="182880" lvl="0" indent="-154940" algn="l" rtl="0">
+              <a:spcBef>
+                <a:spcPts val="0"/>
+              </a:spcBef>
+              <a:spcAft>
+                <a:spcPts val="0"/>
+              </a:spcAft>
+              <a:buSzPts val="1000"/>
+              <a:buChar char="●"/>
+            </a:pPr>
+            <a:endParaRPr dirty="0"/>
           </a:p>
         </p:txBody>
       </p:sp>
@@ -42140,33 +42548,6 @@
 </file>
 
 <file path=customXml/item1.xml><?xml version="1.0" encoding="utf-8"?>
-<p:properties xmlns:p="http://schemas.microsoft.com/office/2006/metadata/properties" xmlns:xsi="http://www.w3.org/2001/XMLSchema-instance" xmlns:pc="http://schemas.microsoft.com/office/infopath/2007/PartnerControls">
-  <documentManagement>
-    <SharedWithUsers xmlns="6c8d291c-a5bf-4049-930d-38db8e991d8e">
-      <UserInfo>
-        <DisplayName/>
-        <AccountId xsi:nil="true"/>
-        <AccountType/>
-      </UserInfo>
-    </SharedWithUsers>
-    <TaxCatchAll xmlns="6c8d291c-a5bf-4049-930d-38db8e991d8e" xsi:nil="true"/>
-    <lcf76f155ced4ddcb4097134ff3c332f xmlns="5ff92c65-ed86-4457-baee-ccd535c9ea21">
-      <Terms xmlns="http://schemas.microsoft.com/office/infopath/2007/PartnerControls"/>
-    </lcf76f155ced4ddcb4097134ff3c332f>
-  </documentManagement>
-</p:properties>
-</file>
-
-<file path=customXml/item2.xml><?xml version="1.0" encoding="utf-8"?>
-<?mso-contentType ?>
-<FormTemplates xmlns="http://schemas.microsoft.com/sharepoint/v3/contenttype/forms">
-  <Display>DocumentLibraryForm</Display>
-  <Edit>DocumentLibraryForm</Edit>
-  <New>DocumentLibraryForm</New>
-</FormTemplates>
-</file>
-
-<file path=customXml/item3.xml><?xml version="1.0" encoding="utf-8"?>
 <ct:contentTypeSchema xmlns:ct="http://schemas.microsoft.com/office/2006/metadata/contentType" xmlns:ma="http://schemas.microsoft.com/office/2006/metadata/properties/metaAttributes" ct:_="" ma:_="" ma:contentTypeName="Document" ma:contentTypeID="0x0101000BADAD4AA324BF48804EF76FD903323C" ma:contentTypeVersion="15" ma:contentTypeDescription="Create a new document." ma:contentTypeScope="" ma:versionID="4ea0feda506421460444ca95554a0aab">
   <xsd:schema xmlns:xsd="http://www.w3.org/2001/XMLSchema" xmlns:xs="http://www.w3.org/2001/XMLSchema" xmlns:p="http://schemas.microsoft.com/office/2006/metadata/properties" xmlns:ns2="5ff92c65-ed86-4457-baee-ccd535c9ea21" xmlns:ns3="6c8d291c-a5bf-4049-930d-38db8e991d8e" targetNamespace="http://schemas.microsoft.com/office/2006/metadata/properties" ma:root="true" ma:fieldsID="0fc8cf7d0f5ee312899395875a30595e" ns2:_="" ns3:_="">
     <xsd:import namespace="5ff92c65-ed86-4457-baee-ccd535c9ea21"/>
@@ -42401,7 +42782,53 @@
 </ct:contentTypeSchema>
 </file>
 
+<file path=customXml/item2.xml><?xml version="1.0" encoding="utf-8"?>
+<p:properties xmlns:p="http://schemas.microsoft.com/office/2006/metadata/properties" xmlns:xsi="http://www.w3.org/2001/XMLSchema-instance" xmlns:pc="http://schemas.microsoft.com/office/infopath/2007/PartnerControls">
+  <documentManagement>
+    <SharedWithUsers xmlns="6c8d291c-a5bf-4049-930d-38db8e991d8e">
+      <UserInfo>
+        <DisplayName/>
+        <AccountId xsi:nil="true"/>
+        <AccountType/>
+      </UserInfo>
+    </SharedWithUsers>
+    <TaxCatchAll xmlns="6c8d291c-a5bf-4049-930d-38db8e991d8e" xsi:nil="true"/>
+    <lcf76f155ced4ddcb4097134ff3c332f xmlns="5ff92c65-ed86-4457-baee-ccd535c9ea21">
+      <Terms xmlns="http://schemas.microsoft.com/office/infopath/2007/PartnerControls"/>
+    </lcf76f155ced4ddcb4097134ff3c332f>
+  </documentManagement>
+</p:properties>
+</file>
+
+<file path=customXml/item3.xml><?xml version="1.0" encoding="utf-8"?>
+<?mso-contentType ?>
+<FormTemplates xmlns="http://schemas.microsoft.com/sharepoint/v3/contenttype/forms">
+  <Display>DocumentLibraryForm</Display>
+  <Edit>DocumentLibraryForm</Edit>
+  <New>DocumentLibraryForm</New>
+</FormTemplates>
+</file>
+
 <file path=customXml/itemProps1.xml><?xml version="1.0" encoding="utf-8"?>
+<ds:datastoreItem xmlns:ds="http://schemas.openxmlformats.org/officeDocument/2006/customXml" ds:itemID="{AA562638-1947-4789-9FBF-F833DB2C18A8}">
+  <ds:schemaRefs>
+    <ds:schemaRef ds:uri="5ff92c65-ed86-4457-baee-ccd535c9ea21"/>
+    <ds:schemaRef ds:uri="6c8d291c-a5bf-4049-930d-38db8e991d8e"/>
+    <ds:schemaRef ds:uri="http://purl.org/dc/elements/1.1/"/>
+    <ds:schemaRef ds:uri="http://purl.org/dc/terms/"/>
+    <ds:schemaRef ds:uri="http://schemas.microsoft.com/internal/obd"/>
+    <ds:schemaRef ds:uri="http://schemas.microsoft.com/office/2006/documentManagement/types"/>
+    <ds:schemaRef ds:uri="http://schemas.microsoft.com/office/2006/metadata/contentType"/>
+    <ds:schemaRef ds:uri="http://schemas.microsoft.com/office/2006/metadata/properties"/>
+    <ds:schemaRef ds:uri="http://schemas.microsoft.com/office/2006/metadata/properties/metaAttributes"/>
+    <ds:schemaRef ds:uri="http://schemas.microsoft.com/office/infopath/2007/PartnerControls"/>
+    <ds:schemaRef ds:uri="http://schemas.openxmlformats.org/package/2006/metadata/core-properties"/>
+    <ds:schemaRef ds:uri="http://www.w3.org/2001/XMLSchema"/>
+  </ds:schemaRefs>
+</ds:datastoreItem>
+</file>
+
+<file path=customXml/itemProps2.xml><?xml version="1.0" encoding="utf-8"?>
 <ds:datastoreItem xmlns:ds="http://schemas.openxmlformats.org/officeDocument/2006/customXml" ds:itemID="{3067B86F-F5BB-4BE6-9A37-0E19E53CB68B}">
   <ds:schemaRefs>
     <ds:schemaRef ds:uri="5ff92c65-ed86-4457-baee-ccd535c9ea21"/>
@@ -42418,29 +42845,10 @@
 </ds:datastoreItem>
 </file>
 
-<file path=customXml/itemProps2.xml><?xml version="1.0" encoding="utf-8"?>
+<file path=customXml/itemProps3.xml><?xml version="1.0" encoding="utf-8"?>
 <ds:datastoreItem xmlns:ds="http://schemas.openxmlformats.org/officeDocument/2006/customXml" ds:itemID="{98D9791E-52D0-4ABB-925A-4EAECF798D9B}">
   <ds:schemaRefs>
     <ds:schemaRef ds:uri="http://schemas.microsoft.com/sharepoint/v3/contenttype/forms"/>
   </ds:schemaRefs>
 </ds:datastoreItem>
-</file>
-
-<file path=customXml/itemProps3.xml><?xml version="1.0" encoding="utf-8"?>
-<ds:datastoreItem xmlns:ds="http://schemas.openxmlformats.org/officeDocument/2006/customXml" ds:itemID="{AA562638-1947-4789-9FBF-F833DB2C18A8}">
-  <ds:schemaRefs>
-    <ds:schemaRef ds:uri="5ff92c65-ed86-4457-baee-ccd535c9ea21"/>
-    <ds:schemaRef ds:uri="6c8d291c-a5bf-4049-930d-38db8e991d8e"/>
-    <ds:schemaRef ds:uri="http://purl.org/dc/elements/1.1/"/>
-    <ds:schemaRef ds:uri="http://purl.org/dc/terms/"/>
-    <ds:schemaRef ds:uri="http://schemas.microsoft.com/internal/obd"/>
-    <ds:schemaRef ds:uri="http://schemas.microsoft.com/office/2006/documentManagement/types"/>
-    <ds:schemaRef ds:uri="http://schemas.microsoft.com/office/2006/metadata/contentType"/>
-    <ds:schemaRef ds:uri="http://schemas.microsoft.com/office/2006/metadata/properties"/>
-    <ds:schemaRef ds:uri="http://schemas.microsoft.com/office/2006/metadata/properties/metaAttributes"/>
-    <ds:schemaRef ds:uri="http://schemas.microsoft.com/office/infopath/2007/PartnerControls"/>
-    <ds:schemaRef ds:uri="http://schemas.openxmlformats.org/package/2006/metadata/core-properties"/>
-    <ds:schemaRef ds:uri="http://www.w3.org/2001/XMLSchema"/>
-  </ds:schemaRefs>
-</ds:datastoreItem>
 </file>
</xml_diff>

<commit_message>
W8 DataLab 1 Work I (Start)
</commit_message>
<xml_diff>
--- a/Deliverables/Learning Log - Y1B-2024-25_ADSAI.pptx
+++ b/Deliverables/Learning Log - Y1B-2024-25_ADSAI.pptx
@@ -21204,7 +21204,7 @@
             </a:r>
             <a:r>
               <a:rPr lang="de-DE" dirty="0"/>
-              <a:t> xxx </a:t>
+              <a:t> 240 </a:t>
             </a:r>
             <a:r>
               <a:rPr lang="de-DE" dirty="0" err="1"/>
@@ -21212,7 +21212,7 @@
             </a:r>
             <a:r>
               <a:rPr lang="de-DE" dirty="0"/>
-              <a:t>, at 35 </a:t>
+              <a:t>, at 30 </a:t>
             </a:r>
             <a:r>
               <a:rPr lang="de-DE" dirty="0" err="1"/>
@@ -21228,11 +21228,11 @@
             </a:r>
             <a:r>
               <a:rPr lang="de-DE" dirty="0"/>
-              <a:t>, but </a:t>
-            </a:r>
-            <a:r>
-              <a:rPr lang="de-DE" dirty="0" err="1"/>
-              <a:t>with</a:t>
+              <a:t>, and I </a:t>
+            </a:r>
+            <a:r>
+              <a:rPr lang="de-DE" dirty="0" err="1"/>
+              <a:t>hope</a:t>
             </a:r>
             <a:r>
               <a:rPr lang="de-DE" dirty="0"/>
@@ -21240,7 +21240,15 @@
             </a:r>
             <a:r>
               <a:rPr lang="de-DE" dirty="0" err="1"/>
-              <a:t>me</a:t>
+              <a:t>to</a:t>
+            </a:r>
+            <a:r>
+              <a:rPr lang="de-DE" dirty="0"/>
+              <a:t> not </a:t>
+            </a:r>
+            <a:r>
+              <a:rPr lang="de-DE" dirty="0" err="1"/>
+              <a:t>need</a:t>
             </a:r>
             <a:r>
               <a:rPr lang="de-DE" dirty="0"/>
@@ -21248,11 +21256,51 @@
             </a:r>
             <a:r>
               <a:rPr lang="de-DE" dirty="0" err="1"/>
-              <a:t>becomming</a:t>
-            </a:r>
-            <a:r>
-              <a:rPr lang="de-DE" dirty="0"/>
-              <a:t> sick </a:t>
+              <a:t>to</a:t>
+            </a:r>
+            <a:r>
+              <a:rPr lang="de-DE" dirty="0"/>
+              <a:t> </a:t>
+            </a:r>
+            <a:r>
+              <a:rPr lang="de-DE" dirty="0" err="1"/>
+              <a:t>readjust</a:t>
+            </a:r>
+            <a:r>
+              <a:rPr lang="de-DE" dirty="0"/>
+              <a:t> </a:t>
+            </a:r>
+            <a:r>
+              <a:rPr lang="de-DE" dirty="0" err="1"/>
+              <a:t>it</a:t>
+            </a:r>
+            <a:r>
+              <a:rPr lang="de-DE" dirty="0"/>
+              <a:t> </a:t>
+            </a:r>
+            <a:r>
+              <a:rPr lang="de-DE" dirty="0" err="1"/>
+              <a:t>again</a:t>
+            </a:r>
+            <a:r>
+              <a:rPr lang="de-DE" dirty="0"/>
+              <a:t> after </a:t>
+            </a:r>
+            <a:r>
+              <a:rPr lang="de-DE" dirty="0" err="1"/>
+              <a:t>my</a:t>
+            </a:r>
+            <a:r>
+              <a:rPr lang="de-DE" dirty="0"/>
+              <a:t> </a:t>
+            </a:r>
+            <a:r>
+              <a:rPr lang="de-DE" dirty="0" err="1"/>
+              <a:t>sickness</a:t>
+            </a:r>
+            <a:r>
+              <a:rPr lang="de-DE" dirty="0"/>
+              <a:t> </a:t>
             </a:r>
             <a:r>
               <a:rPr lang="de-DE" dirty="0" err="1"/>
@@ -21265,62 +21313,6 @@
             <a:r>
               <a:rPr lang="de-DE" dirty="0" err="1"/>
               <a:t>week</a:t>
-            </a:r>
-            <a:r>
-              <a:rPr lang="de-DE" dirty="0"/>
-              <a:t> I </a:t>
-            </a:r>
-            <a:r>
-              <a:rPr lang="de-DE" dirty="0" err="1"/>
-              <a:t>may</a:t>
-            </a:r>
-            <a:r>
-              <a:rPr lang="de-DE" dirty="0"/>
-              <a:t> </a:t>
-            </a:r>
-            <a:r>
-              <a:rPr lang="de-DE" dirty="0" err="1"/>
-              <a:t>need</a:t>
-            </a:r>
-            <a:r>
-              <a:rPr lang="de-DE" dirty="0"/>
-              <a:t> </a:t>
-            </a:r>
-            <a:r>
-              <a:rPr lang="de-DE" dirty="0" err="1"/>
-              <a:t>to</a:t>
-            </a:r>
-            <a:r>
-              <a:rPr lang="de-DE" dirty="0"/>
-              <a:t> </a:t>
-            </a:r>
-            <a:r>
-              <a:rPr lang="de-DE" dirty="0" err="1"/>
-              <a:t>re-adjust</a:t>
-            </a:r>
-            <a:r>
-              <a:rPr lang="de-DE" dirty="0"/>
-              <a:t> </a:t>
-            </a:r>
-            <a:r>
-              <a:rPr lang="de-DE" dirty="0" err="1"/>
-              <a:t>it</a:t>
-            </a:r>
-            <a:r>
-              <a:rPr lang="de-DE" dirty="0"/>
-              <a:t> </a:t>
-            </a:r>
-            <a:r>
-              <a:rPr lang="de-DE" dirty="0" err="1"/>
-              <a:t>even</a:t>
-            </a:r>
-            <a:r>
-              <a:rPr lang="de-DE" dirty="0"/>
-              <a:t> </a:t>
-            </a:r>
-            <a:r>
-              <a:rPr lang="de-DE" dirty="0" err="1"/>
-              <a:t>lower</a:t>
             </a:r>
             <a:r>
               <a:rPr lang="de-DE" dirty="0"/>
@@ -22897,6 +22889,114 @@
               <a:buSzPts val="1000"/>
               <a:buChar char="●"/>
             </a:pPr>
+            <a:r>
+              <a:rPr lang="de-DE" dirty="0"/>
+              <a:t>I </a:t>
+            </a:r>
+            <a:r>
+              <a:rPr lang="de-DE" dirty="0" err="1"/>
+              <a:t>have</a:t>
+            </a:r>
+            <a:r>
+              <a:rPr lang="de-DE" dirty="0"/>
+              <a:t> </a:t>
+            </a:r>
+            <a:r>
+              <a:rPr lang="de-DE" dirty="0" err="1"/>
+              <a:t>caught</a:t>
+            </a:r>
+            <a:r>
+              <a:rPr lang="de-DE" dirty="0"/>
+              <a:t> </a:t>
+            </a:r>
+            <a:r>
+              <a:rPr lang="de-DE" dirty="0" err="1"/>
+              <a:t>up</a:t>
+            </a:r>
+            <a:r>
+              <a:rPr lang="de-DE" dirty="0"/>
+              <a:t> on all </a:t>
+            </a:r>
+            <a:r>
+              <a:rPr lang="de-DE" dirty="0" err="1"/>
+              <a:t>tasks</a:t>
+            </a:r>
+            <a:r>
+              <a:rPr lang="de-DE" dirty="0"/>
+              <a:t> bar 1 I </a:t>
+            </a:r>
+            <a:r>
+              <a:rPr lang="de-DE" dirty="0" err="1"/>
+              <a:t>missed</a:t>
+            </a:r>
+            <a:r>
+              <a:rPr lang="de-DE" dirty="0"/>
+              <a:t>, </a:t>
+            </a:r>
+            <a:r>
+              <a:rPr lang="de-DE" dirty="0" err="1"/>
+              <a:t>which</a:t>
+            </a:r>
+            <a:r>
+              <a:rPr lang="de-DE" dirty="0"/>
+              <a:t> I </a:t>
+            </a:r>
+            <a:r>
+              <a:rPr lang="de-DE" dirty="0" err="1"/>
+              <a:t>have</a:t>
+            </a:r>
+            <a:r>
+              <a:rPr lang="de-DE" dirty="0"/>
+              <a:t> </a:t>
+            </a:r>
+            <a:r>
+              <a:rPr lang="de-DE" dirty="0" err="1"/>
+              <a:t>begun</a:t>
+            </a:r>
+            <a:r>
+              <a:rPr lang="de-DE" dirty="0"/>
+              <a:t> </a:t>
+            </a:r>
+            <a:r>
+              <a:rPr lang="de-DE" dirty="0" err="1"/>
+              <a:t>working</a:t>
+            </a:r>
+            <a:r>
+              <a:rPr lang="de-DE" dirty="0"/>
+              <a:t> on at </a:t>
+            </a:r>
+            <a:r>
+              <a:rPr lang="de-DE" dirty="0" err="1"/>
+              <a:t>the</a:t>
+            </a:r>
+            <a:r>
+              <a:rPr lang="de-DE" dirty="0"/>
+              <a:t> </a:t>
+            </a:r>
+            <a:r>
+              <a:rPr lang="de-DE" dirty="0" err="1"/>
+              <a:t>start</a:t>
+            </a:r>
+            <a:r>
+              <a:rPr lang="de-DE" dirty="0"/>
+              <a:t> </a:t>
+            </a:r>
+            <a:r>
+              <a:rPr lang="de-DE" dirty="0" err="1"/>
+              <a:t>of</a:t>
+            </a:r>
+            <a:r>
+              <a:rPr lang="de-DE" dirty="0"/>
+              <a:t> </a:t>
+            </a:r>
+            <a:r>
+              <a:rPr lang="de-DE" dirty="0" err="1"/>
+              <a:t>week</a:t>
+            </a:r>
+            <a:r>
+              <a:rPr lang="de-DE" dirty="0"/>
+              <a:t> 8.</a:t>
+            </a:r>
             <a:endParaRPr dirty="0"/>
           </a:p>
           <a:p>
@@ -22981,6 +23081,58 @@
               <a:buSzPts val="1000"/>
               <a:buChar char="●"/>
             </a:pPr>
+            <a:r>
+              <a:rPr lang="de-DE" dirty="0"/>
+              <a:t>The </a:t>
+            </a:r>
+            <a:r>
+              <a:rPr lang="de-DE" dirty="0" err="1"/>
+              <a:t>week</a:t>
+            </a:r>
+            <a:r>
+              <a:rPr lang="de-DE" dirty="0"/>
+              <a:t> </a:t>
+            </a:r>
+            <a:r>
+              <a:rPr lang="de-DE" dirty="0" err="1"/>
+              <a:t>went</a:t>
+            </a:r>
+            <a:r>
+              <a:rPr lang="de-DE" dirty="0"/>
+              <a:t> </a:t>
+            </a:r>
+            <a:r>
+              <a:rPr lang="de-DE" dirty="0" err="1"/>
+              <a:t>very</a:t>
+            </a:r>
+            <a:r>
+              <a:rPr lang="de-DE" dirty="0"/>
+              <a:t> </a:t>
+            </a:r>
+            <a:r>
+              <a:rPr lang="de-DE" dirty="0" err="1"/>
+              <a:t>well</a:t>
+            </a:r>
+            <a:r>
+              <a:rPr lang="de-DE" dirty="0"/>
+              <a:t> and was </a:t>
+            </a:r>
+            <a:r>
+              <a:rPr lang="de-DE" dirty="0" err="1"/>
+              <a:t>very</a:t>
+            </a:r>
+            <a:r>
+              <a:rPr lang="de-DE" dirty="0"/>
+              <a:t> </a:t>
+            </a:r>
+            <a:r>
+              <a:rPr lang="de-DE" dirty="0" err="1"/>
+              <a:t>productive</a:t>
+            </a:r>
+            <a:r>
+              <a:rPr lang="de-DE" dirty="0"/>
+              <a:t>.</a:t>
+            </a:r>
             <a:endParaRPr dirty="0"/>
           </a:p>
           <a:p>
@@ -23010,6 +23162,54 @@
               <a:buSzPts val="1000"/>
               <a:buChar char="●"/>
             </a:pPr>
+            <a:r>
+              <a:rPr lang="de-DE" dirty="0" err="1"/>
+              <a:t>Cathing</a:t>
+            </a:r>
+            <a:r>
+              <a:rPr lang="de-DE" dirty="0"/>
+              <a:t> </a:t>
+            </a:r>
+            <a:r>
+              <a:rPr lang="de-DE" dirty="0" err="1"/>
+              <a:t>up</a:t>
+            </a:r>
+            <a:r>
+              <a:rPr lang="de-DE" dirty="0"/>
+              <a:t> on </a:t>
+            </a:r>
+            <a:r>
+              <a:rPr lang="de-DE" dirty="0" err="1"/>
+              <a:t>work</a:t>
+            </a:r>
+            <a:r>
+              <a:rPr lang="de-DE" dirty="0"/>
+              <a:t> </a:t>
+            </a:r>
+            <a:r>
+              <a:rPr lang="de-DE" dirty="0" err="1"/>
+              <a:t>from</a:t>
+            </a:r>
+            <a:r>
+              <a:rPr lang="de-DE" dirty="0"/>
+              <a:t> </a:t>
+            </a:r>
+            <a:r>
+              <a:rPr lang="de-DE" dirty="0" err="1"/>
+              <a:t>the</a:t>
+            </a:r>
+            <a:r>
+              <a:rPr lang="de-DE" dirty="0"/>
+              <a:t> last </a:t>
+            </a:r>
+            <a:r>
+              <a:rPr lang="de-DE" dirty="0" err="1"/>
+              <a:t>week</a:t>
+            </a:r>
+            <a:r>
+              <a:rPr lang="de-DE" dirty="0"/>
+              <a:t>.</a:t>
+            </a:r>
             <a:endParaRPr dirty="0"/>
           </a:p>
           <a:p>
@@ -23039,6 +23239,34 @@
               <a:buSzPts val="1000"/>
               <a:buChar char="●"/>
             </a:pPr>
+            <a:r>
+              <a:rPr lang="de-DE" dirty="0"/>
+              <a:t>Nothing </a:t>
+            </a:r>
+            <a:r>
+              <a:rPr lang="de-DE" dirty="0" err="1"/>
+              <a:t>much</a:t>
+            </a:r>
+            <a:r>
+              <a:rPr lang="de-DE" dirty="0"/>
+              <a:t> </a:t>
+            </a:r>
+            <a:r>
+              <a:rPr lang="de-DE" dirty="0" err="1"/>
+              <a:t>went</a:t>
+            </a:r>
+            <a:r>
+              <a:rPr lang="de-DE" dirty="0"/>
+              <a:t> </a:t>
+            </a:r>
+            <a:r>
+              <a:rPr lang="de-DE" dirty="0" err="1"/>
+              <a:t>wrong</a:t>
+            </a:r>
+            <a:r>
+              <a:rPr lang="de-DE" dirty="0"/>
+              <a:t>.</a:t>
+            </a:r>
             <a:endParaRPr dirty="0"/>
           </a:p>
           <a:p>
@@ -23068,6 +23296,70 @@
               <a:buSzPts val="1000"/>
               <a:buChar char="●"/>
             </a:pPr>
+            <a:r>
+              <a:rPr lang="de-DE" dirty="0" err="1"/>
+              <a:t>How</a:t>
+            </a:r>
+            <a:r>
+              <a:rPr lang="de-DE" dirty="0"/>
+              <a:t> </a:t>
+            </a:r>
+            <a:r>
+              <a:rPr lang="de-DE" dirty="0" err="1"/>
+              <a:t>to</a:t>
+            </a:r>
+            <a:r>
+              <a:rPr lang="de-DE" dirty="0"/>
+              <a:t> </a:t>
+            </a:r>
+            <a:r>
+              <a:rPr lang="de-DE" dirty="0" err="1"/>
+              <a:t>keep</a:t>
+            </a:r>
+            <a:r>
+              <a:rPr lang="de-DE" dirty="0"/>
+              <a:t> </a:t>
+            </a:r>
+            <a:r>
+              <a:rPr lang="de-DE" dirty="0" err="1"/>
+              <a:t>concentration</a:t>
+            </a:r>
+            <a:r>
+              <a:rPr lang="de-DE" dirty="0"/>
+              <a:t> and </a:t>
+            </a:r>
+            <a:r>
+              <a:rPr lang="de-DE" dirty="0" err="1"/>
+              <a:t>motivation</a:t>
+            </a:r>
+            <a:r>
+              <a:rPr lang="de-DE" dirty="0"/>
+              <a:t> </a:t>
+            </a:r>
+            <a:r>
+              <a:rPr lang="de-DE" dirty="0" err="1"/>
+              <a:t>for</a:t>
+            </a:r>
+            <a:r>
+              <a:rPr lang="de-DE" dirty="0"/>
+              <a:t> a </a:t>
+            </a:r>
+            <a:r>
+              <a:rPr lang="de-DE" dirty="0" err="1"/>
+              <a:t>pretty</a:t>
+            </a:r>
+            <a:r>
+              <a:rPr lang="de-DE" dirty="0"/>
+              <a:t> </a:t>
+            </a:r>
+            <a:r>
+              <a:rPr lang="de-DE" dirty="0" err="1"/>
+              <a:t>long</a:t>
+            </a:r>
+            <a:r>
+              <a:rPr lang="de-DE" dirty="0"/>
+              <a:t>.</a:t>
+            </a:r>
             <a:endParaRPr dirty="0"/>
           </a:p>
           <a:p>
@@ -23097,7 +23389,194 @@
               <a:buSzPts val="1000"/>
               <a:buChar char="●"/>
             </a:pPr>
-            <a:endParaRPr lang="de-DE" dirty="0"/>
+            <a:r>
+              <a:rPr lang="de-DE" dirty="0"/>
+              <a:t>I </a:t>
+            </a:r>
+            <a:r>
+              <a:rPr lang="de-DE" dirty="0" err="1"/>
+              <a:t>don‘t</a:t>
+            </a:r>
+            <a:r>
+              <a:rPr lang="de-DE" dirty="0"/>
+              <a:t> </a:t>
+            </a:r>
+            <a:r>
+              <a:rPr lang="de-DE" dirty="0" err="1"/>
+              <a:t>see</a:t>
+            </a:r>
+            <a:r>
+              <a:rPr lang="de-DE" dirty="0"/>
+              <a:t> </a:t>
+            </a:r>
+            <a:r>
+              <a:rPr lang="de-DE" dirty="0" err="1"/>
+              <a:t>anything</a:t>
+            </a:r>
+            <a:r>
+              <a:rPr lang="de-DE" dirty="0"/>
+              <a:t> </a:t>
+            </a:r>
+            <a:r>
+              <a:rPr lang="de-DE" dirty="0" err="1"/>
+              <a:t>from</a:t>
+            </a:r>
+            <a:r>
+              <a:rPr lang="de-DE" dirty="0"/>
+              <a:t> </a:t>
+            </a:r>
+            <a:r>
+              <a:rPr lang="de-DE" dirty="0" err="1"/>
+              <a:t>this</a:t>
+            </a:r>
+            <a:r>
+              <a:rPr lang="de-DE" dirty="0"/>
+              <a:t> </a:t>
+            </a:r>
+            <a:r>
+              <a:rPr lang="de-DE" dirty="0" err="1"/>
+              <a:t>week</a:t>
+            </a:r>
+            <a:r>
+              <a:rPr lang="de-DE" dirty="0"/>
+              <a:t> </a:t>
+            </a:r>
+            <a:r>
+              <a:rPr lang="de-DE" dirty="0" err="1"/>
+              <a:t>that</a:t>
+            </a:r>
+            <a:r>
+              <a:rPr lang="de-DE" dirty="0"/>
+              <a:t> </a:t>
+            </a:r>
+            <a:r>
+              <a:rPr lang="de-DE" dirty="0" err="1"/>
+              <a:t>could</a:t>
+            </a:r>
+            <a:r>
+              <a:rPr lang="de-DE" dirty="0"/>
+              <a:t> </a:t>
+            </a:r>
+            <a:r>
+              <a:rPr lang="de-DE" dirty="0" err="1"/>
+              <a:t>be</a:t>
+            </a:r>
+            <a:r>
+              <a:rPr lang="de-DE" dirty="0"/>
+              <a:t> </a:t>
+            </a:r>
+            <a:r>
+              <a:rPr lang="de-DE" dirty="0" err="1"/>
+              <a:t>added</a:t>
+            </a:r>
+            <a:r>
+              <a:rPr lang="de-DE" dirty="0"/>
+              <a:t>. I do </a:t>
+            </a:r>
+            <a:r>
+              <a:rPr lang="de-DE" dirty="0" err="1"/>
+              <a:t>need</a:t>
+            </a:r>
+            <a:r>
+              <a:rPr lang="de-DE" dirty="0"/>
+              <a:t> </a:t>
+            </a:r>
+            <a:r>
+              <a:rPr lang="de-DE" dirty="0" err="1"/>
+              <a:t>to</a:t>
+            </a:r>
+            <a:r>
+              <a:rPr lang="de-DE" dirty="0"/>
+              <a:t> </a:t>
+            </a:r>
+            <a:r>
+              <a:rPr lang="de-DE" dirty="0" err="1"/>
+              <a:t>work</a:t>
+            </a:r>
+            <a:r>
+              <a:rPr lang="de-DE" dirty="0"/>
+              <a:t> a </a:t>
+            </a:r>
+            <a:r>
+              <a:rPr lang="de-DE" dirty="0" err="1"/>
+              <a:t>lot</a:t>
+            </a:r>
+            <a:r>
+              <a:rPr lang="de-DE" dirty="0"/>
+              <a:t> </a:t>
+            </a:r>
+            <a:r>
+              <a:rPr lang="de-DE" dirty="0" err="1"/>
+              <a:t>next</a:t>
+            </a:r>
+            <a:r>
+              <a:rPr lang="de-DE" dirty="0"/>
+              <a:t> </a:t>
+            </a:r>
+            <a:r>
+              <a:rPr lang="de-DE" dirty="0" err="1"/>
+              <a:t>week</a:t>
+            </a:r>
+            <a:r>
+              <a:rPr lang="de-DE" dirty="0"/>
+              <a:t> </a:t>
+            </a:r>
+            <a:r>
+              <a:rPr lang="de-DE" dirty="0" err="1"/>
+              <a:t>as</a:t>
+            </a:r>
+            <a:r>
+              <a:rPr lang="de-DE" dirty="0"/>
+              <a:t> </a:t>
+            </a:r>
+            <a:r>
+              <a:rPr lang="de-DE" dirty="0" err="1"/>
+              <a:t>well</a:t>
+            </a:r>
+            <a:r>
+              <a:rPr lang="de-DE" dirty="0"/>
+              <a:t> </a:t>
+            </a:r>
+            <a:r>
+              <a:rPr lang="de-DE" dirty="0" err="1"/>
+              <a:t>as</a:t>
+            </a:r>
+            <a:r>
+              <a:rPr lang="de-DE" dirty="0"/>
+              <a:t> </a:t>
+            </a:r>
+            <a:r>
+              <a:rPr lang="de-DE" dirty="0" err="1"/>
+              <a:t>it</a:t>
+            </a:r>
+            <a:r>
+              <a:rPr lang="de-DE" dirty="0"/>
+              <a:t> </a:t>
+            </a:r>
+            <a:r>
+              <a:rPr lang="de-DE" dirty="0" err="1"/>
+              <a:t>is</a:t>
+            </a:r>
+            <a:r>
+              <a:rPr lang="de-DE" dirty="0"/>
+              <a:t> </a:t>
+            </a:r>
+            <a:r>
+              <a:rPr lang="de-DE" dirty="0" err="1"/>
+              <a:t>the</a:t>
+            </a:r>
+            <a:r>
+              <a:rPr lang="de-DE" dirty="0"/>
+              <a:t> final </a:t>
+            </a:r>
+            <a:r>
+              <a:rPr lang="de-DE" dirty="0" err="1"/>
+              <a:t>week</a:t>
+            </a:r>
+            <a:r>
+              <a:rPr lang="de-DE" dirty="0"/>
+              <a:t>.</a:t>
+            </a:r>
           </a:p>
           <a:p>
             <a:pPr marL="182880" indent="-154940"/>
@@ -23125,6 +23604,330 @@
               <a:buSzPts val="1000"/>
               <a:buChar char="●"/>
             </a:pPr>
+            <a:r>
+              <a:rPr lang="de-DE" dirty="0"/>
+              <a:t>Due </a:t>
+            </a:r>
+            <a:r>
+              <a:rPr lang="de-DE" dirty="0" err="1"/>
+              <a:t>to</a:t>
+            </a:r>
+            <a:r>
+              <a:rPr lang="de-DE" dirty="0"/>
+              <a:t> </a:t>
+            </a:r>
+            <a:r>
+              <a:rPr lang="de-DE" dirty="0" err="1"/>
+              <a:t>my</a:t>
+            </a:r>
+            <a:r>
+              <a:rPr lang="de-DE" dirty="0"/>
+              <a:t> </a:t>
+            </a:r>
+            <a:r>
+              <a:rPr lang="de-DE" dirty="0" err="1"/>
+              <a:t>sickness</a:t>
+            </a:r>
+            <a:r>
+              <a:rPr lang="de-DE" dirty="0"/>
+              <a:t> last </a:t>
+            </a:r>
+            <a:r>
+              <a:rPr lang="de-DE" dirty="0" err="1"/>
+              <a:t>week</a:t>
+            </a:r>
+            <a:r>
+              <a:rPr lang="de-DE" dirty="0"/>
+              <a:t> and </a:t>
+            </a:r>
+            <a:r>
+              <a:rPr lang="de-DE" dirty="0" err="1"/>
+              <a:t>need</a:t>
+            </a:r>
+            <a:r>
+              <a:rPr lang="de-DE" dirty="0"/>
+              <a:t> </a:t>
+            </a:r>
+            <a:r>
+              <a:rPr lang="de-DE" dirty="0" err="1"/>
+              <a:t>to</a:t>
+            </a:r>
+            <a:r>
+              <a:rPr lang="de-DE" dirty="0"/>
+              <a:t> catch </a:t>
+            </a:r>
+            <a:r>
+              <a:rPr lang="de-DE" dirty="0" err="1"/>
+              <a:t>up</a:t>
+            </a:r>
+            <a:r>
+              <a:rPr lang="de-DE" dirty="0"/>
+              <a:t> </a:t>
+            </a:r>
+            <a:r>
+              <a:rPr lang="de-DE" dirty="0" err="1"/>
+              <a:t>this</a:t>
+            </a:r>
+            <a:r>
+              <a:rPr lang="de-DE" dirty="0"/>
+              <a:t> </a:t>
+            </a:r>
+            <a:r>
+              <a:rPr lang="de-DE" dirty="0" err="1"/>
+              <a:t>week</a:t>
+            </a:r>
+            <a:r>
+              <a:rPr lang="de-DE" dirty="0"/>
+              <a:t>, </a:t>
+            </a:r>
+            <a:r>
+              <a:rPr lang="de-DE" dirty="0" err="1"/>
+              <a:t>the</a:t>
+            </a:r>
+            <a:r>
+              <a:rPr lang="de-DE" dirty="0"/>
+              <a:t> </a:t>
+            </a:r>
+            <a:r>
+              <a:rPr lang="de-DE" dirty="0" err="1"/>
+              <a:t>times</a:t>
+            </a:r>
+            <a:r>
+              <a:rPr lang="de-DE" dirty="0"/>
+              <a:t> </a:t>
+            </a:r>
+            <a:r>
+              <a:rPr lang="de-DE" dirty="0" err="1"/>
+              <a:t>for</a:t>
+            </a:r>
+            <a:r>
+              <a:rPr lang="de-DE" dirty="0"/>
+              <a:t> </a:t>
+            </a:r>
+            <a:r>
+              <a:rPr lang="de-DE" dirty="0" err="1"/>
+              <a:t>actual</a:t>
+            </a:r>
+            <a:r>
+              <a:rPr lang="de-DE" dirty="0"/>
+              <a:t> </a:t>
+            </a:r>
+            <a:r>
+              <a:rPr lang="de-DE" dirty="0" err="1"/>
+              <a:t>work</a:t>
+            </a:r>
+            <a:r>
+              <a:rPr lang="de-DE" dirty="0"/>
+              <a:t> </a:t>
+            </a:r>
+            <a:r>
+              <a:rPr lang="de-DE" dirty="0" err="1"/>
+              <a:t>this</a:t>
+            </a:r>
+            <a:r>
+              <a:rPr lang="de-DE" dirty="0"/>
+              <a:t> </a:t>
+            </a:r>
+            <a:r>
+              <a:rPr lang="de-DE" dirty="0" err="1"/>
+              <a:t>week</a:t>
+            </a:r>
+            <a:r>
+              <a:rPr lang="de-DE" dirty="0"/>
+              <a:t> </a:t>
+            </a:r>
+            <a:r>
+              <a:rPr lang="de-DE" dirty="0" err="1"/>
+              <a:t>have</a:t>
+            </a:r>
+            <a:r>
+              <a:rPr lang="de-DE" dirty="0"/>
+              <a:t> </a:t>
+            </a:r>
+            <a:r>
+              <a:rPr lang="de-DE" dirty="0" err="1"/>
+              <a:t>taken</a:t>
+            </a:r>
+            <a:r>
+              <a:rPr lang="de-DE" dirty="0"/>
+              <a:t> a </a:t>
+            </a:r>
+            <a:r>
+              <a:rPr lang="de-DE" dirty="0" err="1"/>
+              <a:t>hit</a:t>
+            </a:r>
+            <a:r>
+              <a:rPr lang="de-DE" dirty="0"/>
+              <a:t> </a:t>
+            </a:r>
+            <a:r>
+              <a:rPr lang="de-DE" dirty="0" err="1"/>
+              <a:t>while</a:t>
+            </a:r>
+            <a:r>
+              <a:rPr lang="de-DE" dirty="0"/>
+              <a:t> </a:t>
+            </a:r>
+            <a:r>
+              <a:rPr lang="de-DE" dirty="0" err="1"/>
+              <a:t>the</a:t>
+            </a:r>
+            <a:r>
+              <a:rPr lang="de-DE" dirty="0"/>
+              <a:t> </a:t>
+            </a:r>
+            <a:r>
+              <a:rPr lang="de-DE" dirty="0" err="1"/>
+              <a:t>actual</a:t>
+            </a:r>
+            <a:r>
+              <a:rPr lang="de-DE" dirty="0"/>
+              <a:t> time </a:t>
+            </a:r>
+            <a:r>
+              <a:rPr lang="de-DE" dirty="0" err="1"/>
+              <a:t>spent</a:t>
+            </a:r>
+            <a:r>
+              <a:rPr lang="de-DE" dirty="0"/>
+              <a:t> </a:t>
+            </a:r>
+            <a:r>
+              <a:rPr lang="de-DE" dirty="0" err="1"/>
+              <a:t>working</a:t>
+            </a:r>
+            <a:r>
+              <a:rPr lang="de-DE" dirty="0"/>
+              <a:t> </a:t>
+            </a:r>
+            <a:r>
+              <a:rPr lang="de-DE" dirty="0" err="1"/>
+              <a:t>has</a:t>
+            </a:r>
+            <a:r>
+              <a:rPr lang="de-DE" dirty="0"/>
+              <a:t> </a:t>
+            </a:r>
+            <a:r>
+              <a:rPr lang="de-DE" dirty="0" err="1"/>
+              <a:t>been</a:t>
+            </a:r>
+            <a:r>
+              <a:rPr lang="de-DE" dirty="0"/>
+              <a:t> </a:t>
+            </a:r>
+            <a:r>
+              <a:rPr lang="de-DE" dirty="0" err="1"/>
+              <a:t>the</a:t>
+            </a:r>
+            <a:r>
+              <a:rPr lang="de-DE" dirty="0"/>
+              <a:t> </a:t>
+            </a:r>
+            <a:r>
+              <a:rPr lang="de-DE" dirty="0" err="1"/>
+              <a:t>highest</a:t>
+            </a:r>
+            <a:r>
+              <a:rPr lang="de-DE" dirty="0"/>
+              <a:t> </a:t>
+            </a:r>
+            <a:r>
+              <a:rPr lang="de-DE" dirty="0" err="1"/>
+              <a:t>of</a:t>
+            </a:r>
+            <a:r>
+              <a:rPr lang="de-DE" dirty="0"/>
+              <a:t> all </a:t>
+            </a:r>
+            <a:r>
+              <a:rPr lang="de-DE" dirty="0" err="1"/>
+              <a:t>weeks</a:t>
+            </a:r>
+            <a:r>
+              <a:rPr lang="de-DE" dirty="0"/>
+              <a:t>. I </a:t>
+            </a:r>
+            <a:r>
+              <a:rPr lang="de-DE" dirty="0" err="1"/>
+              <a:t>have</a:t>
+            </a:r>
+            <a:r>
+              <a:rPr lang="de-DE" dirty="0"/>
+              <a:t> </a:t>
+            </a:r>
+            <a:r>
+              <a:rPr lang="de-DE" dirty="0" err="1"/>
+              <a:t>readjusted</a:t>
+            </a:r>
+            <a:r>
+              <a:rPr lang="de-DE" dirty="0"/>
+              <a:t> </a:t>
+            </a:r>
+            <a:r>
+              <a:rPr lang="de-DE" dirty="0" err="1"/>
+              <a:t>to</a:t>
+            </a:r>
+            <a:r>
+              <a:rPr lang="de-DE" dirty="0"/>
+              <a:t> </a:t>
+            </a:r>
+            <a:r>
+              <a:rPr lang="de-DE" dirty="0" err="1"/>
+              <a:t>the</a:t>
+            </a:r>
+            <a:r>
+              <a:rPr lang="de-DE" dirty="0"/>
+              <a:t> </a:t>
+            </a:r>
+            <a:r>
+              <a:rPr lang="de-DE" dirty="0" err="1"/>
+              <a:t>sleep</a:t>
+            </a:r>
+            <a:r>
+              <a:rPr lang="de-DE" dirty="0"/>
+              <a:t> </a:t>
+            </a:r>
+            <a:r>
+              <a:rPr lang="de-DE" dirty="0" err="1"/>
+              <a:t>schedule</a:t>
+            </a:r>
+            <a:r>
+              <a:rPr lang="de-DE" dirty="0"/>
+              <a:t> I </a:t>
+            </a:r>
+            <a:r>
+              <a:rPr lang="de-DE" dirty="0" err="1"/>
+              <a:t>had</a:t>
+            </a:r>
+            <a:r>
+              <a:rPr lang="de-DE" dirty="0"/>
+              <a:t> </a:t>
+            </a:r>
+            <a:r>
+              <a:rPr lang="de-DE" dirty="0" err="1"/>
+              <a:t>before</a:t>
+            </a:r>
+            <a:r>
+              <a:rPr lang="de-DE" dirty="0"/>
+              <a:t> </a:t>
+            </a:r>
+            <a:r>
+              <a:rPr lang="de-DE" dirty="0" err="1"/>
+              <a:t>the</a:t>
+            </a:r>
+            <a:r>
+              <a:rPr lang="de-DE" dirty="0"/>
+              <a:t> </a:t>
+            </a:r>
+            <a:r>
+              <a:rPr lang="de-DE" dirty="0" err="1"/>
+              <a:t>vacation</a:t>
+            </a:r>
+            <a:r>
+              <a:rPr lang="de-DE" dirty="0"/>
+              <a:t>.</a:t>
+            </a:r>
             <a:endParaRPr dirty="0"/>
           </a:p>
         </p:txBody>
@@ -23772,10 +24575,9 @@
               <a:buChar char="●"/>
             </a:pPr>
             <a:r>
-              <a:rPr lang="en"/>
+              <a:rPr lang="en" b="1" dirty="0"/>
               <a:t>What goal(s) did you set for this week?</a:t>
             </a:r>
-            <a:endParaRPr/>
           </a:p>
           <a:p>
             <a:pPr marL="182880" lvl="0" indent="-154940" algn="l" rtl="0">
@@ -23789,10 +24591,66 @@
               <a:buChar char="●"/>
             </a:pPr>
             <a:r>
-              <a:rPr lang="en"/>
-              <a:t>What have you actually been able to do? </a:t>
-            </a:r>
-            <a:endParaRPr/>
+              <a:rPr lang="de-DE" dirty="0"/>
+              <a:t>Do </a:t>
+            </a:r>
+            <a:r>
+              <a:rPr lang="de-DE" dirty="0" err="1"/>
+              <a:t>the</a:t>
+            </a:r>
+            <a:r>
+              <a:rPr lang="de-DE" dirty="0"/>
+              <a:t> final </a:t>
+            </a:r>
+            <a:r>
+              <a:rPr lang="de-DE" dirty="0" err="1"/>
+              <a:t>touches</a:t>
+            </a:r>
+            <a:r>
+              <a:rPr lang="de-DE" dirty="0"/>
+              <a:t> </a:t>
+            </a:r>
+            <a:r>
+              <a:rPr lang="de-DE" dirty="0" err="1"/>
+              <a:t>to</a:t>
+            </a:r>
+            <a:r>
+              <a:rPr lang="de-DE" dirty="0"/>
+              <a:t> </a:t>
+            </a:r>
+            <a:r>
+              <a:rPr lang="de-DE" dirty="0" err="1"/>
+              <a:t>my</a:t>
+            </a:r>
+            <a:r>
+              <a:rPr lang="de-DE" dirty="0"/>
+              <a:t> </a:t>
+            </a:r>
+            <a:r>
+              <a:rPr lang="de-DE" dirty="0" err="1"/>
+              <a:t>work</a:t>
+            </a:r>
+            <a:r>
+              <a:rPr lang="de-DE" dirty="0"/>
+              <a:t> </a:t>
+            </a:r>
+            <a:r>
+              <a:rPr lang="de-DE" dirty="0" err="1"/>
+              <a:t>this</a:t>
+            </a:r>
+            <a:r>
+              <a:rPr lang="de-DE" dirty="0"/>
+              <a:t> block and finish </a:t>
+            </a:r>
+            <a:r>
+              <a:rPr lang="de-DE" dirty="0" err="1"/>
+              <a:t>the</a:t>
+            </a:r>
+            <a:r>
+              <a:rPr lang="de-DE" dirty="0"/>
+              <a:t> block.</a:t>
+            </a:r>
+            <a:endParaRPr dirty="0"/>
           </a:p>
           <a:p>
             <a:pPr marL="182880" lvl="0" indent="-154940" algn="l" rtl="0">
@@ -23806,10 +24664,51 @@
               <a:buChar char="●"/>
             </a:pPr>
             <a:r>
-              <a:rPr lang="en"/>
+              <a:rPr lang="en" b="1" dirty="0"/>
+              <a:t>What have you actually been able to do? </a:t>
+            </a:r>
+          </a:p>
+          <a:p>
+            <a:pPr marL="182880" lvl="0" indent="-154940" algn="l" rtl="0">
+              <a:spcBef>
+                <a:spcPts val="0"/>
+              </a:spcBef>
+              <a:spcAft>
+                <a:spcPts val="0"/>
+              </a:spcAft>
+              <a:buSzPts val="1000"/>
+              <a:buChar char="●"/>
+            </a:pPr>
+            <a:endParaRPr dirty="0"/>
+          </a:p>
+          <a:p>
+            <a:pPr marL="182880" lvl="0" indent="-154940" algn="l" rtl="0">
+              <a:spcBef>
+                <a:spcPts val="0"/>
+              </a:spcBef>
+              <a:spcAft>
+                <a:spcPts val="0"/>
+              </a:spcAft>
+              <a:buSzPts val="1000"/>
+              <a:buChar char="●"/>
+            </a:pPr>
+            <a:r>
+              <a:rPr lang="en" b="1" dirty="0"/>
               <a:t>Showcase the evidence of your progress (production artifacts, short descriptions-links-pictures animated gifs, etc.)</a:t>
             </a:r>
-            <a:endParaRPr/>
+          </a:p>
+          <a:p>
+            <a:pPr marL="182880" lvl="0" indent="-154940" algn="l" rtl="0">
+              <a:spcBef>
+                <a:spcPts val="0"/>
+              </a:spcBef>
+              <a:spcAft>
+                <a:spcPts val="0"/>
+              </a:spcAft>
+              <a:buSzPts val="1000"/>
+              <a:buChar char="●"/>
+            </a:pPr>
+            <a:endParaRPr dirty="0"/>
           </a:p>
         </p:txBody>
       </p:sp>
@@ -23849,10 +24748,9 @@
               <a:buChar char="●"/>
             </a:pPr>
             <a:r>
-              <a:rPr lang="en"/>
+              <a:rPr lang="en" b="1" dirty="0"/>
               <a:t>How did the week go? </a:t>
             </a:r>
-            <a:endParaRPr/>
           </a:p>
           <a:p>
             <a:pPr marL="182880" lvl="0" indent="-154940" algn="l" rtl="0">
@@ -23865,11 +24763,7 @@
               <a:buSzPts val="1000"/>
               <a:buChar char="●"/>
             </a:pPr>
-            <a:r>
-              <a:rPr lang="en"/>
-              <a:t>What went well? </a:t>
-            </a:r>
-            <a:endParaRPr/>
+            <a:endParaRPr dirty="0"/>
           </a:p>
           <a:p>
             <a:pPr marL="182880" lvl="0" indent="-154940" algn="l" rtl="0">
@@ -23883,10 +24777,9 @@
               <a:buChar char="●"/>
             </a:pPr>
             <a:r>
-              <a:rPr lang="en"/>
-              <a:t>What didn’t go so well? </a:t>
-            </a:r>
-            <a:endParaRPr/>
+              <a:rPr lang="en" b="1" dirty="0"/>
+              <a:t>What went well? </a:t>
+            </a:r>
           </a:p>
           <a:p>
             <a:pPr marL="182880" lvl="0" indent="-154940" algn="l" rtl="0">
@@ -23899,11 +24792,7 @@
               <a:buSzPts val="1000"/>
               <a:buChar char="●"/>
             </a:pPr>
-            <a:r>
-              <a:rPr lang="en"/>
-              <a:t>What did you learn? </a:t>
-            </a:r>
-            <a:endParaRPr/>
+            <a:endParaRPr dirty="0"/>
           </a:p>
           <a:p>
             <a:pPr marL="182880" lvl="0" indent="-154940" algn="l" rtl="0">
@@ -23917,10 +24806,108 @@
               <a:buChar char="●"/>
             </a:pPr>
             <a:r>
-              <a:rPr lang="en"/>
+              <a:rPr lang="en" b="1" dirty="0"/>
+              <a:t>What didn’t go so well? </a:t>
+            </a:r>
+          </a:p>
+          <a:p>
+            <a:pPr marL="182880" lvl="0" indent="-154940" algn="l" rtl="0">
+              <a:spcBef>
+                <a:spcPts val="0"/>
+              </a:spcBef>
+              <a:spcAft>
+                <a:spcPts val="0"/>
+              </a:spcAft>
+              <a:buSzPts val="1000"/>
+              <a:buChar char="●"/>
+            </a:pPr>
+            <a:endParaRPr dirty="0"/>
+          </a:p>
+          <a:p>
+            <a:pPr marL="182880" lvl="0" indent="-154940" algn="l" rtl="0">
+              <a:spcBef>
+                <a:spcPts val="0"/>
+              </a:spcBef>
+              <a:spcAft>
+                <a:spcPts val="0"/>
+              </a:spcAft>
+              <a:buSzPts val="1000"/>
+              <a:buChar char="●"/>
+            </a:pPr>
+            <a:r>
+              <a:rPr lang="en" b="1" dirty="0"/>
+              <a:t>What did you learn? </a:t>
+            </a:r>
+          </a:p>
+          <a:p>
+            <a:pPr marL="182880" lvl="0" indent="-154940" algn="l" rtl="0">
+              <a:spcBef>
+                <a:spcPts val="0"/>
+              </a:spcBef>
+              <a:spcAft>
+                <a:spcPts val="0"/>
+              </a:spcAft>
+              <a:buSzPts val="1000"/>
+              <a:buChar char="●"/>
+            </a:pPr>
+            <a:endParaRPr dirty="0"/>
+          </a:p>
+          <a:p>
+            <a:pPr marL="182880" lvl="0" indent="-154940" algn="l" rtl="0">
+              <a:spcBef>
+                <a:spcPts val="0"/>
+              </a:spcBef>
+              <a:spcAft>
+                <a:spcPts val="0"/>
+              </a:spcAft>
+              <a:buSzPts val="1000"/>
+              <a:buChar char="●"/>
+            </a:pPr>
+            <a:r>
+              <a:rPr lang="en" b="1" dirty="0"/>
               <a:t>What could be added as an Action point looking forward to next week?</a:t>
             </a:r>
-            <a:endParaRPr/>
+          </a:p>
+          <a:p>
+            <a:pPr marL="182880" lvl="0" indent="-154940" algn="l" rtl="0">
+              <a:spcBef>
+                <a:spcPts val="0"/>
+              </a:spcBef>
+              <a:spcAft>
+                <a:spcPts val="0"/>
+              </a:spcAft>
+              <a:buSzPts val="1000"/>
+              <a:buChar char="●"/>
+            </a:pPr>
+            <a:endParaRPr lang="en" dirty="0"/>
+          </a:p>
+          <a:p>
+            <a:pPr marL="182880" indent="-154940"/>
+            <a:r>
+              <a:rPr lang="de-DE" b="1" dirty="0"/>
+              <a:t>SMARTER-Goals </a:t>
+            </a:r>
+            <a:r>
+              <a:rPr lang="de-DE" b="1" dirty="0" err="1"/>
+              <a:t>reflections</a:t>
+            </a:r>
+            <a:r>
+              <a:rPr lang="de-DE" b="1" dirty="0"/>
+              <a:t>:</a:t>
+            </a:r>
+          </a:p>
+          <a:p>
+            <a:pPr marL="182880" lvl="0" indent="-154940" algn="l" rtl="0">
+              <a:spcBef>
+                <a:spcPts val="0"/>
+              </a:spcBef>
+              <a:spcAft>
+                <a:spcPts val="0"/>
+              </a:spcAft>
+              <a:buSzPts val="1000"/>
+              <a:buChar char="●"/>
+            </a:pPr>
+            <a:endParaRPr dirty="0"/>
           </a:p>
         </p:txBody>
       </p:sp>
@@ -41895,6 +42882,126 @@
               <a:rPr lang="de-DE" dirty="0"/>
               <a:t>.</a:t>
             </a:r>
+            <a:br>
+              <a:rPr lang="de-DE" dirty="0"/>
+            </a:br>
+            <a:r>
+              <a:rPr lang="de-DE" dirty="0"/>
+              <a:t>READJUSTMENT: On 06/01/2025, I </a:t>
+            </a:r>
+            <a:r>
+              <a:rPr lang="de-DE" dirty="0" err="1"/>
+              <a:t>readjusted</a:t>
+            </a:r>
+            <a:r>
+              <a:rPr lang="de-DE" dirty="0"/>
+              <a:t> </a:t>
+            </a:r>
+            <a:r>
+              <a:rPr lang="de-DE" dirty="0" err="1"/>
+              <a:t>this</a:t>
+            </a:r>
+            <a:r>
+              <a:rPr lang="de-DE" dirty="0"/>
+              <a:t> </a:t>
+            </a:r>
+            <a:r>
+              <a:rPr lang="de-DE" dirty="0" err="1"/>
+              <a:t>goal</a:t>
+            </a:r>
+            <a:r>
+              <a:rPr lang="de-DE" dirty="0"/>
+              <a:t> down </a:t>
+            </a:r>
+            <a:r>
+              <a:rPr lang="de-DE" dirty="0" err="1"/>
+              <a:t>to</a:t>
+            </a:r>
+            <a:r>
+              <a:rPr lang="de-DE" dirty="0"/>
+              <a:t> 240 </a:t>
+            </a:r>
+            <a:r>
+              <a:rPr lang="de-DE" dirty="0" err="1"/>
+              <a:t>hours</a:t>
+            </a:r>
+            <a:r>
+              <a:rPr lang="de-DE" dirty="0"/>
+              <a:t> (30 </a:t>
+            </a:r>
+            <a:r>
+              <a:rPr lang="de-DE" dirty="0" err="1"/>
+              <a:t>hours</a:t>
+            </a:r>
+            <a:r>
+              <a:rPr lang="de-DE" dirty="0"/>
+              <a:t> per </a:t>
+            </a:r>
+            <a:r>
+              <a:rPr lang="de-DE" dirty="0" err="1"/>
+              <a:t>week</a:t>
+            </a:r>
+            <a:r>
+              <a:rPr lang="de-DE" dirty="0"/>
+              <a:t>) </a:t>
+            </a:r>
+            <a:r>
+              <a:rPr lang="de-DE" dirty="0" err="1"/>
+              <a:t>as</a:t>
+            </a:r>
+            <a:r>
+              <a:rPr lang="de-DE" dirty="0"/>
+              <a:t> I do not </a:t>
+            </a:r>
+            <a:r>
+              <a:rPr lang="de-DE" dirty="0" err="1"/>
+              <a:t>believe</a:t>
+            </a:r>
+            <a:r>
+              <a:rPr lang="de-DE" dirty="0"/>
+              <a:t> I </a:t>
+            </a:r>
+            <a:r>
+              <a:rPr lang="de-DE" dirty="0" err="1"/>
+              <a:t>can</a:t>
+            </a:r>
+            <a:r>
+              <a:rPr lang="de-DE" dirty="0"/>
+              <a:t> </a:t>
+            </a:r>
+            <a:r>
+              <a:rPr lang="de-DE" dirty="0" err="1"/>
+              <a:t>reach</a:t>
+            </a:r>
+            <a:r>
+              <a:rPr lang="de-DE" dirty="0"/>
+              <a:t> </a:t>
+            </a:r>
+            <a:r>
+              <a:rPr lang="de-DE" dirty="0" err="1"/>
+              <a:t>my</a:t>
+            </a:r>
+            <a:r>
+              <a:rPr lang="de-DE" dirty="0"/>
+              <a:t> original </a:t>
+            </a:r>
+            <a:r>
+              <a:rPr lang="de-DE" dirty="0" err="1"/>
+              <a:t>goal</a:t>
+            </a:r>
+            <a:r>
+              <a:rPr lang="de-DE" dirty="0"/>
+              <a:t> </a:t>
+            </a:r>
+            <a:r>
+              <a:rPr lang="de-DE" dirty="0" err="1"/>
+              <a:t>anymore</a:t>
+            </a:r>
+            <a:r>
+              <a:rPr lang="de-DE"/>
+              <a:t>.</a:t>
+            </a:r>
+            <a:endParaRPr lang="de-DE" dirty="0"/>
           </a:p>
           <a:p>
             <a:pPr marL="0" lvl="0" indent="0" algn="just" rtl="0">
@@ -45438,24 +46545,6 @@
 </file>
 
 <file path=customXml/item1.xml><?xml version="1.0" encoding="utf-8"?>
-<p:properties xmlns:p="http://schemas.microsoft.com/office/2006/metadata/properties" xmlns:xsi="http://www.w3.org/2001/XMLSchema-instance" xmlns:pc="http://schemas.microsoft.com/office/infopath/2007/PartnerControls">
-  <documentManagement>
-    <SharedWithUsers xmlns="6c8d291c-a5bf-4049-930d-38db8e991d8e">
-      <UserInfo>
-        <DisplayName/>
-        <AccountId xsi:nil="true"/>
-        <AccountType/>
-      </UserInfo>
-    </SharedWithUsers>
-    <TaxCatchAll xmlns="6c8d291c-a5bf-4049-930d-38db8e991d8e" xsi:nil="true"/>
-    <lcf76f155ced4ddcb4097134ff3c332f xmlns="5ff92c65-ed86-4457-baee-ccd535c9ea21">
-      <Terms xmlns="http://schemas.microsoft.com/office/infopath/2007/PartnerControls"/>
-    </lcf76f155ced4ddcb4097134ff3c332f>
-  </documentManagement>
-</p:properties>
-</file>
-
-<file path=customXml/item2.xml><?xml version="1.0" encoding="utf-8"?>
 <?mso-contentType ?>
 <FormTemplates xmlns="http://schemas.microsoft.com/sharepoint/v3/contenttype/forms">
   <Display>DocumentLibraryForm</Display>
@@ -45464,7 +46553,7 @@
 </FormTemplates>
 </file>
 
-<file path=customXml/item3.xml><?xml version="1.0" encoding="utf-8"?>
+<file path=customXml/item2.xml><?xml version="1.0" encoding="utf-8"?>
 <ct:contentTypeSchema xmlns:ct="http://schemas.microsoft.com/office/2006/metadata/contentType" xmlns:ma="http://schemas.microsoft.com/office/2006/metadata/properties/metaAttributes" ct:_="" ma:_="" ma:contentTypeName="Document" ma:contentTypeID="0x0101000BADAD4AA324BF48804EF76FD903323C" ma:contentTypeVersion="15" ma:contentTypeDescription="Create a new document." ma:contentTypeScope="" ma:versionID="4ea0feda506421460444ca95554a0aab">
   <xsd:schema xmlns:xsd="http://www.w3.org/2001/XMLSchema" xmlns:xs="http://www.w3.org/2001/XMLSchema" xmlns:p="http://schemas.microsoft.com/office/2006/metadata/properties" xmlns:ns2="5ff92c65-ed86-4457-baee-ccd535c9ea21" xmlns:ns3="6c8d291c-a5bf-4049-930d-38db8e991d8e" targetNamespace="http://schemas.microsoft.com/office/2006/metadata/properties" ma:root="true" ma:fieldsID="0fc8cf7d0f5ee312899395875a30595e" ns2:_="" ns3:_="">
     <xsd:import namespace="5ff92c65-ed86-4457-baee-ccd535c9ea21"/>
@@ -45699,24 +46788,25 @@
 </ct:contentTypeSchema>
 </file>
 
-<file path=customXml/itemProps1.xml><?xml version="1.0" encoding="utf-8"?>
-<ds:datastoreItem xmlns:ds="http://schemas.openxmlformats.org/officeDocument/2006/customXml" ds:itemID="{3067B86F-F5BB-4BE6-9A37-0E19E53CB68B}">
-  <ds:schemaRefs>
-    <ds:schemaRef ds:uri="5ff92c65-ed86-4457-baee-ccd535c9ea21"/>
-    <ds:schemaRef ds:uri="6c8d291c-a5bf-4049-930d-38db8e991d8e"/>
-    <ds:schemaRef ds:uri="http://purl.org/dc/dcmitype/"/>
-    <ds:schemaRef ds:uri="http://purl.org/dc/elements/1.1/"/>
-    <ds:schemaRef ds:uri="http://purl.org/dc/terms/"/>
-    <ds:schemaRef ds:uri="http://schemas.microsoft.com/office/2006/documentManagement/types"/>
-    <ds:schemaRef ds:uri="http://schemas.microsoft.com/office/2006/metadata/properties"/>
-    <ds:schemaRef ds:uri="http://schemas.microsoft.com/office/infopath/2007/PartnerControls"/>
-    <ds:schemaRef ds:uri="http://schemas.openxmlformats.org/package/2006/metadata/core-properties"/>
-    <ds:schemaRef ds:uri="http://www.w3.org/XML/1998/namespace"/>
-  </ds:schemaRefs>
-</ds:datastoreItem>
+<file path=customXml/item3.xml><?xml version="1.0" encoding="utf-8"?>
+<p:properties xmlns:p="http://schemas.microsoft.com/office/2006/metadata/properties" xmlns:xsi="http://www.w3.org/2001/XMLSchema-instance" xmlns:pc="http://schemas.microsoft.com/office/infopath/2007/PartnerControls">
+  <documentManagement>
+    <SharedWithUsers xmlns="6c8d291c-a5bf-4049-930d-38db8e991d8e">
+      <UserInfo>
+        <DisplayName/>
+        <AccountId xsi:nil="true"/>
+        <AccountType/>
+      </UserInfo>
+    </SharedWithUsers>
+    <TaxCatchAll xmlns="6c8d291c-a5bf-4049-930d-38db8e991d8e" xsi:nil="true"/>
+    <lcf76f155ced4ddcb4097134ff3c332f xmlns="5ff92c65-ed86-4457-baee-ccd535c9ea21">
+      <Terms xmlns="http://schemas.microsoft.com/office/infopath/2007/PartnerControls"/>
+    </lcf76f155ced4ddcb4097134ff3c332f>
+  </documentManagement>
+</p:properties>
 </file>
 
-<file path=customXml/itemProps2.xml><?xml version="1.0" encoding="utf-8"?>
+<file path=customXml/itemProps1.xml><?xml version="1.0" encoding="utf-8"?>
 <ds:datastoreItem xmlns:ds="http://schemas.openxmlformats.org/officeDocument/2006/customXml" ds:itemID="{98D9791E-52D0-4ABB-925A-4EAECF798D9B}">
   <ds:schemaRefs>
     <ds:schemaRef ds:uri="http://schemas.microsoft.com/sharepoint/v3/contenttype/forms"/>
@@ -45724,7 +46814,7 @@
 </ds:datastoreItem>
 </file>
 
-<file path=customXml/itemProps3.xml><?xml version="1.0" encoding="utf-8"?>
+<file path=customXml/itemProps2.xml><?xml version="1.0" encoding="utf-8"?>
 <ds:datastoreItem xmlns:ds="http://schemas.openxmlformats.org/officeDocument/2006/customXml" ds:itemID="{AA562638-1947-4789-9FBF-F833DB2C18A8}">
   <ds:schemaRefs>
     <ds:schemaRef ds:uri="5ff92c65-ed86-4457-baee-ccd535c9ea21"/>
@@ -45741,4 +46831,21 @@
     <ds:schemaRef ds:uri="http://www.w3.org/2001/XMLSchema"/>
   </ds:schemaRefs>
 </ds:datastoreItem>
+</file>
+
+<file path=customXml/itemProps3.xml><?xml version="1.0" encoding="utf-8"?>
+<ds:datastoreItem xmlns:ds="http://schemas.openxmlformats.org/officeDocument/2006/customXml" ds:itemID="{3067B86F-F5BB-4BE6-9A37-0E19E53CB68B}">
+  <ds:schemaRefs>
+    <ds:schemaRef ds:uri="5ff92c65-ed86-4457-baee-ccd535c9ea21"/>
+    <ds:schemaRef ds:uri="6c8d291c-a5bf-4049-930d-38db8e991d8e"/>
+    <ds:schemaRef ds:uri="http://purl.org/dc/dcmitype/"/>
+    <ds:schemaRef ds:uri="http://purl.org/dc/elements/1.1/"/>
+    <ds:schemaRef ds:uri="http://purl.org/dc/terms/"/>
+    <ds:schemaRef ds:uri="http://schemas.microsoft.com/office/2006/documentManagement/types"/>
+    <ds:schemaRef ds:uri="http://schemas.microsoft.com/office/2006/metadata/properties"/>
+    <ds:schemaRef ds:uri="http://schemas.microsoft.com/office/infopath/2007/PartnerControls"/>
+    <ds:schemaRef ds:uri="http://schemas.openxmlformats.org/package/2006/metadata/core-properties"/>
+    <ds:schemaRef ds:uri="http://www.w3.org/XML/1998/namespace"/>
+  </ds:schemaRefs>
+</ds:datastoreItem>
 </file>
</xml_diff>